<commit_message>
Ajoute une slide jeux de données, retire les 2 slides redondantes avec la démo live
- Slide "Validation — Démonstration en Direct" enrichie avec le graphique
  de comparaison des 4 corpus (capture du site) — comblait un vrai trou,
  les datasets n'étaient présentés qu'en texte avant.
- Retire les slides "Résultats — vue d'ensemble" et "Pareto" ajoutées au
  commit précédent : elles font doublon avec ce qui sera montré en direct
  sur le tableau de bord pendant les 15 minutes de soutenance, où chaque
  minute compte. Garde la slide graphe G/G' (valeur propre, pas montrée
  forcément pendant la démo).
- Net : 12 → 13 slides (contre 15 précédemment).
</commit_message>
<xml_diff>
--- a/presentation/AURORA_Soutenance_FR.pptx
+++ b/presentation/AURORA_Soutenance_FR.pptx
@@ -11,6 +11,7 @@
     <p:sldId id="259" r:id="rId10"/>
     <p:sldId id="260" r:id="rId11"/>
     <p:sldId id="261" r:id="rId12"/>
+    <p:sldId id="268" r:id="rId19"/>
     <p:sldId id="262" r:id="rId13"/>
     <p:sldId id="263" r:id="rId14"/>
     <p:sldId id="264" r:id="rId15"/>
@@ -3421,7 +3422,7 @@
 </p:sld>
 </file>
 
-<file path=ppt/slides/slide10.xml><?xml version="1.0" encoding="utf-8"?>
+<file path=ppt/slides/slide12.xml><?xml version="1.0" encoding="utf-8"?>
 <p:sld xmlns:a="http://schemas.openxmlformats.org/drawingml/2006/main" xmlns:p="http://schemas.openxmlformats.org/presentationml/2006/main" xmlns:r="http://schemas.openxmlformats.org/officeDocument/2006/relationships">
   <p:cSld>
     <p:spTree>
@@ -3462,7 +3463,7 @@
               </a:defRPr>
             </a:pPr>
             <a:r>
-              <a:t>Références (1/2)</a:t>
+              <a:t>Conclusion — Contribution et Perspectives</a:t>
             </a:r>
           </a:p>
         </p:txBody>
@@ -3493,14 +3494,14 @@
               <a:spcAft>
                 <a:spcPts val="1400"/>
               </a:spcAft>
-              <a:defRPr sz="1600">
+              <a:defRPr sz="1900">
                 <a:solidFill>
                   <a:srgbClr val="1A1A1A"/>
                 </a:solidFill>
               </a:defRPr>
             </a:pPr>
             <a:r>
-              <a:t>•  Aird et al. — Exploring Social Choice Mechanisms for Recommendation Fairness in SCRUF (2023)</a:t>
+              <a:t>•  Intégrer l'EDI directement dans la structure du résumé produit des compromis équité-diversité plus robustes que la correction a posteriori</a:t>
             </a:r>
           </a:p>
           <a:p>
@@ -3508,14 +3509,14 @@
               <a:spcAft>
                 <a:spcPts val="1400"/>
               </a:spcAft>
-              <a:defRPr sz="1600">
+              <a:defRPr sz="1900">
                 <a:solidFill>
                   <a:srgbClr val="1A1A1A"/>
                 </a:solidFill>
               </a:defRPr>
             </a:pPr>
             <a:r>
-              <a:t>•  Aird et al. — Social Choice for Heterogeneous Fairness in Recommendation, SCRUF-D (2024)</a:t>
+              <a:t>•  AURORA égale ou dépasse le re-classement sur les corpus plus petits ou côté item, mais pas sur les grandes bases ou les domaines à préférences réciproques</a:t>
             </a:r>
           </a:p>
           <a:p>
@@ -3523,59 +3524,74 @@
               <a:spcAft>
                 <a:spcPts val="1400"/>
               </a:spcAft>
-              <a:defRPr sz="1600">
+              <a:defRPr sz="1900">
                 <a:solidFill>
                   <a:srgbClr val="1A1A1A"/>
                 </a:solidFill>
               </a:defRPr>
             </a:pPr>
             <a:r>
-              <a:t>•  Dong et al. — Fairness in Graph Mining: A Survey. IEEE TKDE (2023)</a:t>
+              <a:t>•  Perspectives :</a:t>
             </a:r>
           </a:p>
           <a:p>
             <a:pPr>
               <a:spcAft>
-                <a:spcPts val="1400"/>
+                <a:spcPts val="800"/>
               </a:spcAft>
               <a:defRPr sz="1600">
                 <a:solidFill>
-                  <a:srgbClr val="1A1A1A"/>
-                </a:solidFill>
-              </a:defRPr>
-            </a:pPr>
-            <a:r>
-              <a:t>•  Harper &amp; Konstan — The MovieLens Datasets: History and Context. ACM TiiS (2015)</a:t>
+                  <a:srgbClr val="555555"/>
+                </a:solidFill>
+              </a:defRPr>
+            </a:pPr>
+            <a:r>
+              <a:t>      ‒  Attributs sensibles multiples et simultanés</a:t>
             </a:r>
           </a:p>
           <a:p>
             <a:pPr>
               <a:spcAft>
-                <a:spcPts val="1400"/>
+                <a:spcPts val="800"/>
               </a:spcAft>
               <a:defRPr sz="1600">
                 <a:solidFill>
-                  <a:srgbClr val="1A1A1A"/>
-                </a:solidFill>
-              </a:defRPr>
-            </a:pPr>
-            <a:r>
-              <a:t>•  Kellerhals &amp; Peters — Proportional Fairness in Clustering (2024)</a:t>
+                  <a:srgbClr val="555555"/>
+                </a:solidFill>
+              </a:defRPr>
+            </a:pPr>
+            <a:r>
+              <a:t>      ‒  Graphes de préférences dynamiques</a:t>
             </a:r>
           </a:p>
           <a:p>
             <a:pPr>
               <a:spcAft>
-                <a:spcPts val="1400"/>
+                <a:spcPts val="800"/>
               </a:spcAft>
               <a:defRPr sz="1600">
                 <a:solidFill>
-                  <a:srgbClr val="1A1A1A"/>
-                </a:solidFill>
-              </a:defRPr>
-            </a:pPr>
-            <a:r>
-              <a:t>•  Leonhardt et al. — User Fairness in Recommender Systems (2018)</a:t>
+                  <a:srgbClr val="555555"/>
+                </a:solidFill>
+              </a:defRPr>
+            </a:pPr>
+            <a:r>
+              <a:t>      ‒  Calibration des tolérances ε par analyse de front de Pareto</a:t>
+            </a:r>
+          </a:p>
+          <a:p>
+            <a:pPr>
+              <a:spcAft>
+                <a:spcPts val="800"/>
+              </a:spcAft>
+              <a:defRPr sz="1600">
+                <a:solidFill>
+                  <a:srgbClr val="555555"/>
+                </a:solidFill>
+              </a:defRPr>
+            </a:pPr>
+            <a:r>
+              <a:t>      ‒  Fusion guidée par détection de communautés et impact EDI</a:t>
             </a:r>
           </a:p>
         </p:txBody>
@@ -3666,7 +3682,7 @@
 </p:sld>
 </file>
 
-<file path=ppt/slides/slide11.xml><?xml version="1.0" encoding="utf-8"?>
+<file path=ppt/slides/slide13.xml><?xml version="1.0" encoding="utf-8"?>
 <p:sld xmlns:a="http://schemas.openxmlformats.org/drawingml/2006/main" xmlns:p="http://schemas.openxmlformats.org/presentationml/2006/main" xmlns:r="http://schemas.openxmlformats.org/officeDocument/2006/relationships">
   <p:cSld>
     <p:spTree>
@@ -3707,7 +3723,7 @@
               </a:defRPr>
             </a:pPr>
             <a:r>
-              <a:t>Références (2/2)</a:t>
+              <a:t>Références (1/2)</a:t>
             </a:r>
           </a:p>
         </p:txBody>
@@ -3745,7 +3761,7 @@
               </a:defRPr>
             </a:pPr>
             <a:r>
-              <a:t>•  Liu et al. — Graph Summarization Methods and Applications: A Survey (2018)</a:t>
+              <a:t>•  Aird et al. — Exploring Social Choice Mechanisms for Recommendation Fairness in SCRUF (2023)</a:t>
             </a:r>
           </a:p>
           <a:p>
@@ -3760,7 +3776,7 @@
               </a:defRPr>
             </a:pPr>
             <a:r>
-              <a:t>•  Ricci, Rokach &amp; Shapira — Recommender Systems Handbook (2011)</a:t>
+              <a:t>•  Aird et al. — Social Choice for Heterogeneous Fairness in Recommendation, SCRUF-D (2024)</a:t>
             </a:r>
           </a:p>
           <a:p>
@@ -3775,7 +3791,7 @@
               </a:defRPr>
             </a:pPr>
             <a:r>
-              <a:t>•  Roy, Schieber &amp; Talmon — Fairness in Preference Queries. VLDB (2024)</a:t>
+              <a:t>•  Dong et al. — Fairness in Graph Mining: A Survey. IEEE TKDE (2023)</a:t>
             </a:r>
           </a:p>
           <a:p>
@@ -3790,7 +3806,7 @@
               </a:defRPr>
             </a:pPr>
             <a:r>
-              <a:t>•  Shabani et al. — Graph Summarization with GNNs: A Survey (2024)</a:t>
+              <a:t>•  Harper &amp; Konstan — The MovieLens Datasets: History and Context. ACM TiiS (2015)</a:t>
             </a:r>
           </a:p>
           <a:p>
@@ -3805,7 +3821,7 @@
               </a:defRPr>
             </a:pPr>
             <a:r>
-              <a:t>•  Yao &amp; Huang — New Fairness Metrics for Recommendation (2017)</a:t>
+              <a:t>•  Kellerhals &amp; Peters — Proportional Fairness in Clustering (2024)</a:t>
             </a:r>
           </a:p>
           <a:p>
@@ -3820,7 +3836,7 @@
               </a:defRPr>
             </a:pPr>
             <a:r>
-              <a:t>•  Zhao et al. — Fairness and Diversity in Recommender Systems: A Survey (2024)</a:t>
+              <a:t>•  Leonhardt et al. — User Fairness in Recommender Systems (2018)</a:t>
             </a:r>
           </a:p>
         </p:txBody>
@@ -3911,7 +3927,7 @@
 </p:sld>
 </file>
 
-<file path=ppt/slides/slide12.xml><?xml version="1.0" encoding="utf-8"?>
+<file path=ppt/slides/slide14.xml><?xml version="1.0" encoding="utf-8"?>
 <p:sld xmlns:a="http://schemas.openxmlformats.org/drawingml/2006/main" xmlns:p="http://schemas.openxmlformats.org/presentationml/2006/main" xmlns:r="http://schemas.openxmlformats.org/officeDocument/2006/relationships">
   <p:cSld>
     <p:spTree>
@@ -3929,8 +3945,8 @@
         </p:nvSpPr>
         <p:spPr>
           <a:xfrm>
-            <a:off x="914400" y="2560320"/>
-            <a:ext cx="10332720" cy="1097280"/>
+            <a:off x="548640" y="320040"/>
+            <a:ext cx="11064240" cy="914400"/>
           </a:xfrm>
           <a:prstGeom prst="rect">
             <a:avLst/>
@@ -3938,20 +3954,21 @@
           <a:noFill/>
         </p:spPr>
         <p:txBody>
-          <a:bodyPr wrap="none">
+          <a:bodyPr wrap="square">
             <a:spAutoFit/>
           </a:bodyPr>
           <a:lstStyle/>
           <a:p>
-            <a:pPr algn="ctr">
-              <a:defRPr sz="4800" b="1">
+            <a:pPr>
+              <a:defRPr sz="3000" b="1">
                 <a:solidFill>
                   <a:srgbClr val="63003C"/>
                 </a:solidFill>
-              </a:defRPr>
-            </a:pPr>
-            <a:r>
-              <a:t>Merci</a:t>
+                <a:latin typeface="Georgia"/>
+              </a:defRPr>
+            </a:pPr>
+            <a:r>
+              <a:t>Références (2/2)</a:t>
             </a:r>
           </a:p>
         </p:txBody>
@@ -3964,8 +3981,8 @@
         </p:nvSpPr>
         <p:spPr>
           <a:xfrm>
-            <a:off x="914400" y="3566160"/>
-            <a:ext cx="10332720" cy="731520"/>
+            <a:off x="685800" y="1371600"/>
+            <a:ext cx="10789920" cy="4846320"/>
           </a:xfrm>
           <a:prstGeom prst="rect">
             <a:avLst/>
@@ -3973,20 +3990,98 @@
           <a:noFill/>
         </p:spPr>
         <p:txBody>
-          <a:bodyPr wrap="none">
+          <a:bodyPr wrap="square">
             <a:spAutoFit/>
           </a:bodyPr>
           <a:lstStyle/>
           <a:p>
-            <a:pPr algn="ctr">
-              <a:defRPr sz="2400">
-                <a:solidFill>
-                  <a:srgbClr val="555555"/>
-                </a:solidFill>
-              </a:defRPr>
-            </a:pPr>
-            <a:r>
-              <a:t>Questions ?</a:t>
+            <a:pPr>
+              <a:spcAft>
+                <a:spcPts val="1400"/>
+              </a:spcAft>
+              <a:defRPr sz="1600">
+                <a:solidFill>
+                  <a:srgbClr val="1A1A1A"/>
+                </a:solidFill>
+              </a:defRPr>
+            </a:pPr>
+            <a:r>
+              <a:t>•  Liu et al. — Graph Summarization Methods and Applications: A Survey (2018)</a:t>
+            </a:r>
+          </a:p>
+          <a:p>
+            <a:pPr>
+              <a:spcAft>
+                <a:spcPts val="1400"/>
+              </a:spcAft>
+              <a:defRPr sz="1600">
+                <a:solidFill>
+                  <a:srgbClr val="1A1A1A"/>
+                </a:solidFill>
+              </a:defRPr>
+            </a:pPr>
+            <a:r>
+              <a:t>•  Ricci, Rokach &amp; Shapira — Recommender Systems Handbook (2011)</a:t>
+            </a:r>
+          </a:p>
+          <a:p>
+            <a:pPr>
+              <a:spcAft>
+                <a:spcPts val="1400"/>
+              </a:spcAft>
+              <a:defRPr sz="1600">
+                <a:solidFill>
+                  <a:srgbClr val="1A1A1A"/>
+                </a:solidFill>
+              </a:defRPr>
+            </a:pPr>
+            <a:r>
+              <a:t>•  Roy, Schieber &amp; Talmon — Fairness in Preference Queries. VLDB (2024)</a:t>
+            </a:r>
+          </a:p>
+          <a:p>
+            <a:pPr>
+              <a:spcAft>
+                <a:spcPts val="1400"/>
+              </a:spcAft>
+              <a:defRPr sz="1600">
+                <a:solidFill>
+                  <a:srgbClr val="1A1A1A"/>
+                </a:solidFill>
+              </a:defRPr>
+            </a:pPr>
+            <a:r>
+              <a:t>•  Shabani et al. — Graph Summarization with GNNs: A Survey (2024)</a:t>
+            </a:r>
+          </a:p>
+          <a:p>
+            <a:pPr>
+              <a:spcAft>
+                <a:spcPts val="1400"/>
+              </a:spcAft>
+              <a:defRPr sz="1600">
+                <a:solidFill>
+                  <a:srgbClr val="1A1A1A"/>
+                </a:solidFill>
+              </a:defRPr>
+            </a:pPr>
+            <a:r>
+              <a:t>•  Yao &amp; Huang — New Fairness Metrics for Recommendation (2017)</a:t>
+            </a:r>
+          </a:p>
+          <a:p>
+            <a:pPr>
+              <a:spcAft>
+                <a:spcPts val="1400"/>
+              </a:spcAft>
+              <a:defRPr sz="1600">
+                <a:solidFill>
+                  <a:srgbClr val="1A1A1A"/>
+                </a:solidFill>
+              </a:defRPr>
+            </a:pPr>
+            <a:r>
+              <a:t>•  Zhao et al. — Fairness and Diversity in Recommender Systems: A Survey (2024)</a:t>
             </a:r>
           </a:p>
         </p:txBody>
@@ -4065,6 +4160,172 @@
             </a:pPr>
             <a:r>
               <a:t>12</a:t>
+            </a:r>
+          </a:p>
+        </p:txBody>
+      </p:sp>
+    </p:spTree>
+  </p:cSld>
+  <p:clrMapOvr>
+    <a:masterClrMapping/>
+  </p:clrMapOvr>
+</p:sld>
+</file>
+
+<file path=ppt/slides/slide15.xml><?xml version="1.0" encoding="utf-8"?>
+<p:sld xmlns:a="http://schemas.openxmlformats.org/drawingml/2006/main" xmlns:p="http://schemas.openxmlformats.org/presentationml/2006/main" xmlns:r="http://schemas.openxmlformats.org/officeDocument/2006/relationships">
+  <p:cSld>
+    <p:spTree>
+      <p:nvGrpSpPr>
+        <p:cNvPr id="1" name=""/>
+        <p:cNvGrpSpPr/>
+        <p:nvPr/>
+      </p:nvGrpSpPr>
+      <p:grpSpPr/>
+      <p:sp>
+        <p:nvSpPr>
+          <p:cNvPr id="2" name="TextBox 1"/>
+          <p:cNvSpPr txBox="1"/>
+          <p:nvPr/>
+        </p:nvSpPr>
+        <p:spPr>
+          <a:xfrm>
+            <a:off x="914400" y="2560320"/>
+            <a:ext cx="10332720" cy="1097280"/>
+          </a:xfrm>
+          <a:prstGeom prst="rect">
+            <a:avLst/>
+          </a:prstGeom>
+          <a:noFill/>
+        </p:spPr>
+        <p:txBody>
+          <a:bodyPr wrap="none">
+            <a:spAutoFit/>
+          </a:bodyPr>
+          <a:lstStyle/>
+          <a:p>
+            <a:pPr algn="ctr">
+              <a:defRPr sz="4800" b="1">
+                <a:solidFill>
+                  <a:srgbClr val="63003C"/>
+                </a:solidFill>
+              </a:defRPr>
+            </a:pPr>
+            <a:r>
+              <a:t>Merci</a:t>
+            </a:r>
+          </a:p>
+        </p:txBody>
+      </p:sp>
+      <p:sp>
+        <p:nvSpPr>
+          <p:cNvPr id="3" name="TextBox 2"/>
+          <p:cNvSpPr txBox="1"/>
+          <p:nvPr/>
+        </p:nvSpPr>
+        <p:spPr>
+          <a:xfrm>
+            <a:off x="914400" y="3566160"/>
+            <a:ext cx="10332720" cy="731520"/>
+          </a:xfrm>
+          <a:prstGeom prst="rect">
+            <a:avLst/>
+          </a:prstGeom>
+          <a:noFill/>
+        </p:spPr>
+        <p:txBody>
+          <a:bodyPr wrap="none">
+            <a:spAutoFit/>
+          </a:bodyPr>
+          <a:lstStyle/>
+          <a:p>
+            <a:pPr algn="ctr">
+              <a:defRPr sz="2400">
+                <a:solidFill>
+                  <a:srgbClr val="555555"/>
+                </a:solidFill>
+              </a:defRPr>
+            </a:pPr>
+            <a:r>
+              <a:t>Questions ?</a:t>
+            </a:r>
+          </a:p>
+        </p:txBody>
+      </p:sp>
+      <p:sp>
+        <p:nvSpPr>
+          <p:cNvPr id="4" name="Rectangle 3"/>
+          <p:cNvSpPr/>
+          <p:nvPr/>
+        </p:nvSpPr>
+        <p:spPr>
+          <a:xfrm>
+            <a:off x="548640" y="6446520"/>
+            <a:ext cx="11091672" cy="27940"/>
+          </a:xfrm>
+          <a:prstGeom prst="rect">
+            <a:avLst/>
+          </a:prstGeom>
+          <a:solidFill>
+            <a:srgbClr val="63003C"/>
+          </a:solidFill>
+          <a:ln>
+            <a:noFill/>
+          </a:ln>
+        </p:spPr>
+        <p:style>
+          <a:lnRef idx="1">
+            <a:schemeClr val="accent1"/>
+          </a:lnRef>
+          <a:fillRef idx="3">
+            <a:schemeClr val="accent1"/>
+          </a:fillRef>
+          <a:effectRef idx="2">
+            <a:schemeClr val="accent1"/>
+          </a:effectRef>
+          <a:fontRef idx="minor">
+            <a:schemeClr val="lt1"/>
+          </a:fontRef>
+        </p:style>
+        <p:txBody>
+          <a:bodyPr rtlCol="0" anchor="ctr"/>
+          <a:lstStyle/>
+          <a:p>
+            <a:pPr algn="ctr"/>
+          </a:p>
+        </p:txBody>
+      </p:sp>
+      <p:sp>
+        <p:nvSpPr>
+          <p:cNvPr id="5" name="TextBox 4"/>
+          <p:cNvSpPr txBox="1"/>
+          <p:nvPr/>
+        </p:nvSpPr>
+        <p:spPr>
+          <a:xfrm>
+            <a:off x="11521440" y="6492240"/>
+            <a:ext cx="548640" cy="320040"/>
+          </a:xfrm>
+          <a:prstGeom prst="rect">
+            <a:avLst/>
+          </a:prstGeom>
+          <a:noFill/>
+        </p:spPr>
+        <p:txBody>
+          <a:bodyPr wrap="none">
+            <a:spAutoFit/>
+          </a:bodyPr>
+          <a:lstStyle/>
+          <a:p>
+            <a:pPr algn="r">
+              <a:defRPr sz="1100">
+                <a:solidFill>
+                  <a:srgbClr val="555555"/>
+                </a:solidFill>
+              </a:defRPr>
+            </a:pPr>
+            <a:r>
+              <a:t>13</a:t>
             </a:r>
           </a:p>
         </p:txBody>
@@ -5274,30 +5535,76 @@
           </a:bodyPr>
           <a:lstStyle/>
           <a:p>
-            <a:pPr>
-              <a:defRPr sz="3000" b="1">
+            <a:r>
+              <a:rPr sz="3000" b="1">
                 <a:solidFill>
                   <a:srgbClr val="63003C"/>
                 </a:solidFill>
                 <a:latin typeface="Georgia"/>
-              </a:defRPr>
-            </a:pPr>
-            <a:r>
-              <a:t>Validation — Démonstration en Direct</a:t>
-            </a:r>
-          </a:p>
-        </p:txBody>
-      </p:sp>
-      <p:sp>
-        <p:nvSpPr>
-          <p:cNvPr id="3" name="TextBox 2"/>
+              </a:rPr>
+              <a:t>Le graphe biparti G et son résumé G′</a:t>
+            </a:r>
+          </a:p>
+        </p:txBody>
+      </p:sp>
+      <p:pic>
+        <p:nvPicPr>
+          <p:cNvPr id="3" name="Picture 2" descr="shot_graph_G.png"/>
+          <p:cNvPicPr>
+            <a:picLocks noChangeAspect="1"/>
+          </p:cNvPicPr>
+          <p:nvPr/>
+        </p:nvPicPr>
+        <p:blipFill>
+          <a:blip r:embed="rId2"/>
+          <a:stretch>
+            <a:fillRect/>
+          </a:stretch>
+        </p:blipFill>
+        <p:spPr>
+          <a:xfrm>
+            <a:off x="685800" y="1650000"/>
+            <a:ext cx="5244960" cy="3195073"/>
+          </a:xfrm>
+          <a:prstGeom prst="rect">
+            <a:avLst/>
+          </a:prstGeom>
+        </p:spPr>
+      </p:pic>
+      <p:pic>
+        <p:nvPicPr>
+          <p:cNvPr id="4" name="Picture 3" descr="shot_graph_Gprime.png"/>
+          <p:cNvPicPr>
+            <a:picLocks noChangeAspect="1"/>
+          </p:cNvPicPr>
+          <p:nvPr/>
+        </p:nvPicPr>
+        <p:blipFill>
+          <a:blip r:embed="rId3"/>
+          <a:stretch>
+            <a:fillRect/>
+          </a:stretch>
+        </p:blipFill>
+        <p:spPr>
+          <a:xfrm>
+            <a:off x="6230760" y="1650000"/>
+            <a:ext cx="5244960" cy="3195073"/>
+          </a:xfrm>
+          <a:prstGeom prst="rect">
+            <a:avLst/>
+          </a:prstGeom>
+        </p:spPr>
+      </p:pic>
+      <p:sp>
+        <p:nvSpPr>
+          <p:cNvPr id="5" name="TextBox 4"/>
           <p:cNvSpPr txBox="1"/>
           <p:nvPr/>
         </p:nvSpPr>
         <p:spPr>
           <a:xfrm>
-            <a:off x="685800" y="1463040"/>
-            <a:ext cx="10789920" cy="4846320"/>
+            <a:off x="685800" y="4905073"/>
+            <a:ext cx="5244960" cy="320040"/>
           </a:xfrm>
           <a:prstGeom prst="rect">
             <a:avLst/>
@@ -5310,47 +5617,28 @@
           </a:bodyPr>
           <a:lstStyle/>
           <a:p>
-            <a:pPr>
-              <a:spcAft>
-                <a:spcPts val="1400"/>
-              </a:spcAft>
-              <a:defRPr sz="2200">
-                <a:solidFill>
-                  <a:srgbClr val="1A1A1A"/>
-                </a:solidFill>
-              </a:defRPr>
-            </a:pPr>
-            <a:r>
-              <a:t>•  5 jeux de données, 4 domaines : MovieLens 100k et 1M, libimseti.cz, Rate My Professors, OpenAlex</a:t>
-            </a:r>
-          </a:p>
-          <a:p>
-            <a:pPr>
-              <a:spcAft>
-                <a:spcPts val="1400"/>
-              </a:spcAft>
-              <a:defRPr sz="2200">
-                <a:solidFill>
-                  <a:srgbClr val="1A1A1A"/>
-                </a:solidFill>
-              </a:defRPr>
-            </a:pPr>
-            <a:r>
-              <a:t>•  Bascule vers le tableau de bord interactif :</a:t>
-            </a:r>
-          </a:p>
-        </p:txBody>
-      </p:sp>
-      <p:sp>
-        <p:nvSpPr>
-          <p:cNvPr id="4" name="TextBox 3"/>
+            <a:pPr algn="ctr"/>
+            <a:r>
+              <a:rPr sz="1300" b="1">
+                <a:solidFill>
+                  <a:srgbClr val="555555"/>
+                </a:solidFill>
+              </a:rPr>
+              <a:t>Graphe original G</a:t>
+            </a:r>
+          </a:p>
+        </p:txBody>
+      </p:sp>
+      <p:sp>
+        <p:nvSpPr>
+          <p:cNvPr id="6" name="TextBox 5"/>
           <p:cNvSpPr txBox="1"/>
           <p:nvPr/>
         </p:nvSpPr>
         <p:spPr>
           <a:xfrm>
-            <a:off x="1188720" y="3291840"/>
-            <a:ext cx="9784080" cy="914400"/>
+            <a:off x="6230760" y="4905073"/>
+            <a:ext cx="5244960" cy="320040"/>
           </a:xfrm>
           <a:prstGeom prst="rect">
             <a:avLst/>
@@ -5358,27 +5646,60 @@
           <a:noFill/>
         </p:spPr>
         <p:txBody>
-          <a:bodyPr wrap="none">
+          <a:bodyPr wrap="square">
             <a:spAutoFit/>
           </a:bodyPr>
           <a:lstStyle/>
           <a:p>
-            <a:pPr algn="ctr">
-              <a:defRPr sz="3000" b="1">
-                <a:solidFill>
-                  <a:srgbClr val="63003C"/>
-                </a:solidFill>
-              </a:defRPr>
-            </a:pPr>
-            <a:r>
-              <a:t>sitaacisse-boop.github.io/EDI</a:t>
-            </a:r>
-          </a:p>
-        </p:txBody>
-      </p:sp>
-      <p:sp>
-        <p:nvSpPr>
-          <p:cNvPr id="5" name="Rectangle 4"/>
+            <a:pPr algn="ctr"/>
+            <a:r>
+              <a:rPr sz="1300" b="1">
+                <a:solidFill>
+                  <a:srgbClr val="555555"/>
+                </a:solidFill>
+              </a:rPr>
+              <a:t>Graphe résumé G′ (fusion en super-nœuds)</a:t>
+            </a:r>
+          </a:p>
+        </p:txBody>
+      </p:sp>
+      <p:sp>
+        <p:nvSpPr>
+          <p:cNvPr id="7" name="TextBox 6"/>
+          <p:cNvSpPr txBox="1"/>
+          <p:nvPr/>
+        </p:nvSpPr>
+        <p:spPr>
+          <a:xfrm>
+            <a:off x="548640" y="6120000"/>
+            <a:ext cx="11064240" cy="280000"/>
+          </a:xfrm>
+          <a:prstGeom prst="rect">
+            <a:avLst/>
+          </a:prstGeom>
+          <a:noFill/>
+        </p:spPr>
+        <p:txBody>
+          <a:bodyPr wrap="square">
+            <a:spAutoFit/>
+          </a:bodyPr>
+          <a:lstStyle/>
+          <a:p>
+            <a:pPr algn="ctr"/>
+            <a:r>
+              <a:rPr sz="1000" i="1">
+                <a:solidFill>
+                  <a:srgbClr val="555555"/>
+                </a:solidFill>
+              </a:rPr>
+              <a:t>Capture du tableau de bord interactif — sitaacisse-boop.github.io/EDI</a:t>
+            </a:r>
+          </a:p>
+        </p:txBody>
+      </p:sp>
+      <p:sp>
+        <p:nvSpPr>
+          <p:cNvPr id="8" name="Rectangle 7"/>
           <p:cNvSpPr/>
           <p:nvPr/>
         </p:nvSpPr>
@@ -5396,6 +5717,7 @@
           <a:ln>
             <a:noFill/>
           </a:ln>
+          <a:effectLst/>
         </p:spPr>
         <p:style>
           <a:lnRef idx="1">
@@ -5421,7 +5743,7 @@
       </p:sp>
       <p:sp>
         <p:nvSpPr>
-          <p:cNvPr id="6" name="TextBox 5"/>
+          <p:cNvPr id="9" name="TextBox 8"/>
           <p:cNvSpPr txBox="1"/>
           <p:nvPr/>
         </p:nvSpPr>
@@ -5441,14 +5763,13 @@
           </a:bodyPr>
           <a:lstStyle/>
           <a:p>
-            <a:pPr algn="r">
-              <a:defRPr sz="1100">
+            <a:pPr algn="r"/>
+            <a:r>
+              <a:rPr sz="1100">
                 <a:solidFill>
                   <a:srgbClr val="555555"/>
                 </a:solidFill>
-              </a:defRPr>
-            </a:pPr>
-            <a:r>
+              </a:rPr>
               <a:t>7</a:t>
             </a:r>
           </a:p>
@@ -5503,112 +5824,14 @@
               </a:defRPr>
             </a:pPr>
             <a:r>
-              <a:t>Conclusion — Résultats Clés</a:t>
-            </a:r>
-          </a:p>
-        </p:txBody>
-      </p:sp>
-      <p:sp>
-        <p:nvSpPr>
-          <p:cNvPr id="3" name="TextBox 2"/>
-          <p:cNvSpPr txBox="1"/>
-          <p:nvPr/>
-        </p:nvSpPr>
-        <p:spPr>
-          <a:xfrm>
-            <a:off x="685800" y="1371600"/>
-            <a:ext cx="10789920" cy="4846320"/>
-          </a:xfrm>
-          <a:prstGeom prst="rect">
-            <a:avLst/>
-          </a:prstGeom>
-          <a:noFill/>
-        </p:spPr>
-        <p:txBody>
-          <a:bodyPr wrap="square">
-            <a:spAutoFit/>
-          </a:bodyPr>
-          <a:lstStyle/>
-          <a:p>
-            <a:pPr>
-              <a:spcAft>
-                <a:spcPts val="1400"/>
-              </a:spcAft>
-              <a:defRPr sz="1900">
-                <a:solidFill>
-                  <a:srgbClr val="1A1A1A"/>
-                </a:solidFill>
-              </a:defRPr>
-            </a:pPr>
-            <a:r>
-              <a:t>•  Aucune méthode de référence ne satisfait les trois critères EDI simultanément</a:t>
-            </a:r>
-          </a:p>
-          <a:p>
-            <a:pPr>
-              <a:spcAft>
-                <a:spcPts val="1400"/>
-              </a:spcAft>
-              <a:defRPr sz="1900">
-                <a:solidFill>
-                  <a:srgbClr val="1A1A1A"/>
-                </a:solidFill>
-              </a:defRPr>
-            </a:pPr>
-            <a:r>
-              <a:t>•  Sur MovieLens 100k (k=20), AURORA bat Borda et Condorcet sur ΔE, ILD et inclusion à la fois</a:t>
-            </a:r>
-          </a:p>
-          <a:p>
-            <a:pPr>
-              <a:spcAft>
-                <a:spcPts val="1400"/>
-              </a:spcAft>
-              <a:defRPr sz="1900">
-                <a:solidFill>
-                  <a:srgbClr val="1A1A1A"/>
-                </a:solidFill>
-              </a:defRPr>
-            </a:pPr>
-            <a:r>
-              <a:t>•  2ᵉ meilleure diversité (hors Average Score, dégénérée) et meilleure représentation sur Rate My Professors ; meilleur ΔE sur OpenAlex</a:t>
-            </a:r>
-          </a:p>
-          <a:p>
-            <a:pPr>
-              <a:spcAft>
-                <a:spcPts val="800"/>
-              </a:spcAft>
-              <a:defRPr sz="1600">
-                <a:solidFill>
-                  <a:srgbClr val="555555"/>
-                </a:solidFill>
-              </a:defRPr>
-            </a:pPr>
-            <a:r>
-              <a:t>      ‒  Sur libimseti.cz : AURORA ne réduit pas ΔE, comme les méthodes de vote — Average Score et Fair Re-rank y parviennent ; limite structurelle du domaine (genre des deux côtés du graphe), pas un défaut de réglage</a:t>
-            </a:r>
-          </a:p>
-          <a:p>
-            <a:pPr>
-              <a:spcAft>
-                <a:spcPts val="1400"/>
-              </a:spcAft>
-              <a:defRPr sz="1900">
-                <a:solidFill>
-                  <a:srgbClr val="1A1A1A"/>
-                </a:solidFill>
-              </a:defRPr>
-            </a:pPr>
-            <a:r>
-              <a:t>•  Sur MovieLens 1M (plus grand), Fair Re-rank domine sur les deux axes — le re-classement a posteriori dispose de plus de marge de manœuvre</a:t>
-            </a:r>
-          </a:p>
-        </p:txBody>
-      </p:sp>
-      <p:sp>
-        <p:nvSpPr>
-          <p:cNvPr id="4" name="Rectangle 3"/>
+              <a:t>Validation — Démonstration en Direct</a:t>
+            </a:r>
+          </a:p>
+        </p:txBody>
+      </p:sp>
+      <p:sp>
+        <p:nvSpPr>
+          <p:cNvPr id="5" name="Rectangle 4"/>
           <p:cNvSpPr/>
           <p:nvPr/>
         </p:nvSpPr>
@@ -5651,7 +5874,7 @@
       </p:sp>
       <p:sp>
         <p:nvSpPr>
-          <p:cNvPr id="5" name="TextBox 4"/>
+          <p:cNvPr id="6" name="TextBox 5"/>
           <p:cNvSpPr txBox="1"/>
           <p:nvPr/>
         </p:nvSpPr>
@@ -5684,6 +5907,83 @@
           </a:p>
         </p:txBody>
       </p:sp>
+      <p:sp>
+        <p:nvSpPr>
+          <p:cNvPr id="7" name="TextBox 6"/>
+          <p:cNvSpPr txBox="1"/>
+          <p:nvPr/>
+        </p:nvSpPr>
+        <p:spPr>
+          <a:xfrm>
+            <a:off x="685800" y="1350000"/>
+            <a:ext cx="10789920" cy="1000000"/>
+          </a:xfrm>
+          <a:prstGeom prst="rect">
+            <a:avLst/>
+          </a:prstGeom>
+          <a:noFill/>
+        </p:spPr>
+        <p:txBody>
+          <a:bodyPr wrap="square">
+            <a:spAutoFit/>
+          </a:bodyPr>
+          <a:lstStyle/>
+          <a:p>
+            <a:pPr>
+              <a:spcAft>
+                <a:spcPts val="1000"/>
+              </a:spcAft>
+            </a:pPr>
+            <a:r>
+              <a:rPr sz="1900">
+                <a:solidFill>
+                  <a:srgbClr val="1A1A1A"/>
+                </a:solidFill>
+              </a:rPr>
+              <a:t>•  5 jeux de données, 4 domaines : MovieLens 100k et 1M, libimseti.cz, Rate My Professors, OpenAlex</a:t>
+            </a:r>
+          </a:p>
+          <a:p>
+            <a:pPr>
+              <a:spcAft>
+                <a:spcPts val="1000"/>
+              </a:spcAft>
+            </a:pPr>
+            <a:r>
+              <a:rPr sz="1900">
+                <a:solidFill>
+                  <a:srgbClr val="1A1A1A"/>
+                </a:solidFill>
+              </a:rPr>
+              <a:t>•  Bascule vers le tableau de bord interactif — sitaacisse-boop.github.io/EDI</a:t>
+            </a:r>
+          </a:p>
+        </p:txBody>
+      </p:sp>
+      <p:pic>
+        <p:nvPicPr>
+          <p:cNvPr id="8" name="Picture 7" descr="shot_data_overview.png"/>
+          <p:cNvPicPr>
+            <a:picLocks noChangeAspect="1"/>
+          </p:cNvPicPr>
+          <p:nvPr/>
+        </p:nvPicPr>
+        <p:blipFill>
+          <a:blip r:embed="rId2"/>
+          <a:stretch>
+            <a:fillRect/>
+          </a:stretch>
+        </p:blipFill>
+        <p:spPr>
+          <a:xfrm>
+            <a:off x="1644697" y="2450000"/>
+            <a:ext cx="8902301" cy="3800000"/>
+          </a:xfrm>
+          <a:prstGeom prst="rect">
+            <a:avLst/>
+          </a:prstGeom>
+        </p:spPr>
+      </p:pic>
     </p:spTree>
   </p:cSld>
   <p:clrMapOvr>
@@ -5733,7 +6033,7 @@
               </a:defRPr>
             </a:pPr>
             <a:r>
-              <a:t>Conclusion — Contribution et Perspectives</a:t>
+              <a:t>Conclusion — Résultats Clés</a:t>
             </a:r>
           </a:p>
         </p:txBody>
@@ -5771,7 +6071,7 @@
               </a:defRPr>
             </a:pPr>
             <a:r>
-              <a:t>•  Intégrer l'EDI directement dans la structure du résumé produit des compromis équité-diversité plus robustes que la correction a posteriori</a:t>
+              <a:t>•  Aucune méthode de référence ne satisfait les trois critères EDI simultanément</a:t>
             </a:r>
           </a:p>
           <a:p>
@@ -5786,7 +6086,7 @@
               </a:defRPr>
             </a:pPr>
             <a:r>
-              <a:t>•  AURORA égale ou dépasse le re-classement sur les corpus plus petits ou côté item, mais pas sur les grandes bases ou les domaines à préférences réciproques</a:t>
+              <a:t>•  Sur MovieLens 100k (k=20), AURORA bat Borda et Condorcet sur ΔE, ILD et inclusion à la fois</a:t>
             </a:r>
           </a:p>
           <a:p>
@@ -5801,7 +6101,7 @@
               </a:defRPr>
             </a:pPr>
             <a:r>
-              <a:t>•  Perspectives :</a:t>
+              <a:t>•  2ᵉ meilleure diversité (hors Average Score, dégénérée) et meilleure représentation sur Rate My Professors ; meilleur ΔE sur OpenAlex</a:t>
             </a:r>
           </a:p>
           <a:p>
@@ -5816,52 +6116,22 @@
               </a:defRPr>
             </a:pPr>
             <a:r>
-              <a:t>      ‒  Attributs sensibles multiples et simultanés</a:t>
+              <a:t>      ‒  Sur libimseti.cz : AURORA ne réduit pas ΔE, comme les méthodes de vote — Average Score et Fair Re-rank y parviennent ; limite structurelle du domaine (genre des deux côtés du graphe), pas un défaut de réglage</a:t>
             </a:r>
           </a:p>
           <a:p>
             <a:pPr>
               <a:spcAft>
-                <a:spcPts val="800"/>
+                <a:spcPts val="1400"/>
               </a:spcAft>
-              <a:defRPr sz="1600">
-                <a:solidFill>
-                  <a:srgbClr val="555555"/>
-                </a:solidFill>
-              </a:defRPr>
-            </a:pPr>
-            <a:r>
-              <a:t>      ‒  Graphes de préférences dynamiques</a:t>
-            </a:r>
-          </a:p>
-          <a:p>
-            <a:pPr>
-              <a:spcAft>
-                <a:spcPts val="800"/>
-              </a:spcAft>
-              <a:defRPr sz="1600">
-                <a:solidFill>
-                  <a:srgbClr val="555555"/>
-                </a:solidFill>
-              </a:defRPr>
-            </a:pPr>
-            <a:r>
-              <a:t>      ‒  Calibration des tolérances ε par analyse de front de Pareto</a:t>
-            </a:r>
-          </a:p>
-          <a:p>
-            <a:pPr>
-              <a:spcAft>
-                <a:spcPts val="800"/>
-              </a:spcAft>
-              <a:defRPr sz="1600">
-                <a:solidFill>
-                  <a:srgbClr val="555555"/>
-                </a:solidFill>
-              </a:defRPr>
-            </a:pPr>
-            <a:r>
-              <a:t>      ‒  Fusion guidée par détection de communautés et impact EDI</a:t>
+              <a:defRPr sz="1900">
+                <a:solidFill>
+                  <a:srgbClr val="1A1A1A"/>
+                </a:solidFill>
+              </a:defRPr>
+            </a:pPr>
+            <a:r>
+              <a:t>•  Sur MovieLens 1M (plus grand), Fair Re-rank domine sur les deux axes — le re-classement a posteriori dispose de plus de marge de manœuvre</a:t>
             </a:r>
           </a:p>
         </p:txBody>

</xml_diff>

<commit_message>
Corrige la mise en page de la slide 7 après réorganisation manuelle
Le déplacement du graphique des données sur la slide "graphe biparti"
créait un chevauchement avec le titre et une incohérence titre/contenu.
Recompose la slide : titre couvrant les deux sujets ("Jeux de données et
graphe biparti G / G′"), 3 visuels repositionnés sans chevauchement
(bandeau des données en haut, G/G′ côte à côte en dessous, légendes et
source repositionnées avant le pied de page).
</commit_message>
<xml_diff>
--- a/presentation/AURORA_Soutenance_FR.pptx
+++ b/presentation/AURORA_Soutenance_FR.pptx
@@ -5,21 +5,21 @@
     <p:sldMasterId id="2147483648" r:id="rId1"/>
   </p:sldMasterIdLst>
   <p:sldIdLst>
-    <p:sldId id="256" r:id="rId7"/>
-    <p:sldId id="257" r:id="rId8"/>
-    <p:sldId id="258" r:id="rId9"/>
-    <p:sldId id="259" r:id="rId10"/>
-    <p:sldId id="260" r:id="rId11"/>
-    <p:sldId id="261" r:id="rId12"/>
-    <p:sldId id="268" r:id="rId19"/>
-    <p:sldId id="262" r:id="rId13"/>
-    <p:sldId id="263" r:id="rId14"/>
-    <p:sldId id="264" r:id="rId15"/>
-    <p:sldId id="265" r:id="rId16"/>
-    <p:sldId id="266" r:id="rId17"/>
-    <p:sldId id="267" r:id="rId18"/>
+    <p:sldId id="256" r:id="rId2"/>
+    <p:sldId id="257" r:id="rId3"/>
+    <p:sldId id="258" r:id="rId4"/>
+    <p:sldId id="259" r:id="rId5"/>
+    <p:sldId id="260" r:id="rId6"/>
+    <p:sldId id="261" r:id="rId7"/>
+    <p:sldId id="268" r:id="rId8"/>
+    <p:sldId id="262" r:id="rId9"/>
+    <p:sldId id="263" r:id="rId10"/>
+    <p:sldId id="264" r:id="rId11"/>
+    <p:sldId id="265" r:id="rId12"/>
+    <p:sldId id="266" r:id="rId13"/>
+    <p:sldId id="267" r:id="rId14"/>
   </p:sldIdLst>
-  <p:sldSz cx="12191695" cy="6858000" type="screen4x3"/>
+  <p:sldSz cx="12192000" cy="6858000"/>
   <p:notesSz cx="6858000" cy="9144000"/>
   <p:defaultTextStyle>
     <a:defPPr>
@@ -116,6 +116,22 @@
       </a:defRPr>
     </a:lvl9pPr>
   </p:defaultTextStyle>
+  <p:extLst>
+    <p:ext uri="{EFAFB233-063F-42B5-8137-9DF3F51BA10A}">
+      <p15:sldGuideLst xmlns:p15="http://schemas.microsoft.com/office/powerpoint/2012/main">
+        <p15:guide id="1" orient="horz" pos="2160">
+          <p15:clr>
+            <a:srgbClr val="A4A3A4"/>
+          </p15:clr>
+        </p15:guide>
+        <p15:guide id="2" pos="2880">
+          <p15:clr>
+            <a:srgbClr val="A4A3A4"/>
+          </p15:clr>
+        </p15:guide>
+      </p15:sldGuideLst>
+    </p:ext>
+  </p:extLst>
 </p:presentation>
 </file>
 
@@ -157,10 +173,9 @@
           <a:lstStyle/>
           <a:p>
             <a:r>
-              <a:rPr lang="en-US" smtClean="0"/>
+              <a:rPr lang="en-US"/>
               <a:t>Click to edit Master title style</a:t>
             </a:r>
-            <a:endParaRPr lang="en-US"/>
           </a:p>
         </p:txBody>
       </p:sp>
@@ -276,10 +291,9 @@
           </a:lstStyle>
           <a:p>
             <a:r>
-              <a:rPr lang="en-US" smtClean="0"/>
+              <a:rPr lang="en-US"/>
               <a:t>Click to edit Master subtitle style</a:t>
             </a:r>
-            <a:endParaRPr lang="en-US"/>
           </a:p>
         </p:txBody>
       </p:sp>
@@ -300,7 +314,7 @@
           <a:p>
             <a:fld id="{5BCAD085-E8A6-8845-BD4E-CB4CCA059FC4}" type="datetimeFigureOut">
               <a:rPr lang="en-US" smtClean="0"/>
-              <a:t>1/27/13</a:t>
+              <a:t>8/26/26</a:t>
             </a:fld>
             <a:endParaRPr lang="en-US"/>
           </a:p>
@@ -342,7 +356,7 @@
           <a:p>
             <a:fld id="{C1FF6DA9-008F-8B48-92A6-B652298478BF}" type="slidenum">
               <a:rPr lang="en-US" smtClean="0"/>
-              <a:t>‹#›</a:t>
+              <a:t>‹N°›</a:t>
             </a:fld>
             <a:endParaRPr lang="en-US"/>
           </a:p>
@@ -394,10 +408,9 @@
           <a:lstStyle/>
           <a:p>
             <a:r>
-              <a:rPr lang="en-US" smtClean="0"/>
+              <a:rPr lang="en-US"/>
               <a:t>Click to edit Master title style</a:t>
             </a:r>
-            <a:endParaRPr lang="en-US"/>
           </a:p>
         </p:txBody>
       </p:sp>
@@ -418,38 +431,37 @@
           <a:p>
             <a:pPr lvl="0"/>
             <a:r>
-              <a:rPr lang="en-US" smtClean="0"/>
+              <a:rPr lang="en-US"/>
               <a:t>Click to edit Master text styles</a:t>
             </a:r>
           </a:p>
           <a:p>
             <a:pPr lvl="1"/>
             <a:r>
-              <a:rPr lang="en-US" smtClean="0"/>
+              <a:rPr lang="en-US"/>
               <a:t>Second level</a:t>
             </a:r>
           </a:p>
           <a:p>
             <a:pPr lvl="2"/>
             <a:r>
-              <a:rPr lang="en-US" smtClean="0"/>
+              <a:rPr lang="en-US"/>
               <a:t>Third level</a:t>
             </a:r>
           </a:p>
           <a:p>
             <a:pPr lvl="3"/>
             <a:r>
-              <a:rPr lang="en-US" smtClean="0"/>
+              <a:rPr lang="en-US"/>
               <a:t>Fourth level</a:t>
             </a:r>
           </a:p>
           <a:p>
             <a:pPr lvl="4"/>
             <a:r>
-              <a:rPr lang="en-US" smtClean="0"/>
+              <a:rPr lang="en-US"/>
               <a:t>Fifth level</a:t>
             </a:r>
-            <a:endParaRPr lang="en-US"/>
           </a:p>
         </p:txBody>
       </p:sp>
@@ -470,7 +482,7 @@
           <a:p>
             <a:fld id="{5BCAD085-E8A6-8845-BD4E-CB4CCA059FC4}" type="datetimeFigureOut">
               <a:rPr lang="en-US" smtClean="0"/>
-              <a:t>1/27/13</a:t>
+              <a:t>8/26/26</a:t>
             </a:fld>
             <a:endParaRPr lang="en-US"/>
           </a:p>
@@ -512,7 +524,7 @@
           <a:p>
             <a:fld id="{C1FF6DA9-008F-8B48-92A6-B652298478BF}" type="slidenum">
               <a:rPr lang="en-US" smtClean="0"/>
-              <a:t>‹#›</a:t>
+              <a:t>‹N°›</a:t>
             </a:fld>
             <a:endParaRPr lang="en-US"/>
           </a:p>
@@ -569,10 +581,9 @@
           <a:lstStyle/>
           <a:p>
             <a:r>
-              <a:rPr lang="en-US" smtClean="0"/>
+              <a:rPr lang="en-US"/>
               <a:t>Click to edit Master title style</a:t>
             </a:r>
-            <a:endParaRPr lang="en-US"/>
           </a:p>
         </p:txBody>
       </p:sp>
@@ -598,38 +609,37 @@
           <a:p>
             <a:pPr lvl="0"/>
             <a:r>
-              <a:rPr lang="en-US" smtClean="0"/>
+              <a:rPr lang="en-US"/>
               <a:t>Click to edit Master text styles</a:t>
             </a:r>
           </a:p>
           <a:p>
             <a:pPr lvl="1"/>
             <a:r>
-              <a:rPr lang="en-US" smtClean="0"/>
+              <a:rPr lang="en-US"/>
               <a:t>Second level</a:t>
             </a:r>
           </a:p>
           <a:p>
             <a:pPr lvl="2"/>
             <a:r>
-              <a:rPr lang="en-US" smtClean="0"/>
+              <a:rPr lang="en-US"/>
               <a:t>Third level</a:t>
             </a:r>
           </a:p>
           <a:p>
             <a:pPr lvl="3"/>
             <a:r>
-              <a:rPr lang="en-US" smtClean="0"/>
+              <a:rPr lang="en-US"/>
               <a:t>Fourth level</a:t>
             </a:r>
           </a:p>
           <a:p>
             <a:pPr lvl="4"/>
             <a:r>
-              <a:rPr lang="en-US" smtClean="0"/>
+              <a:rPr lang="en-US"/>
               <a:t>Fifth level</a:t>
             </a:r>
-            <a:endParaRPr lang="en-US"/>
           </a:p>
         </p:txBody>
       </p:sp>
@@ -650,7 +660,7 @@
           <a:p>
             <a:fld id="{5BCAD085-E8A6-8845-BD4E-CB4CCA059FC4}" type="datetimeFigureOut">
               <a:rPr lang="en-US" smtClean="0"/>
-              <a:t>1/27/13</a:t>
+              <a:t>8/26/26</a:t>
             </a:fld>
             <a:endParaRPr lang="en-US"/>
           </a:p>
@@ -692,7 +702,7 @@
           <a:p>
             <a:fld id="{C1FF6DA9-008F-8B48-92A6-B652298478BF}" type="slidenum">
               <a:rPr lang="en-US" smtClean="0"/>
-              <a:t>‹#›</a:t>
+              <a:t>‹N°›</a:t>
             </a:fld>
             <a:endParaRPr lang="en-US"/>
           </a:p>
@@ -744,10 +754,9 @@
           <a:lstStyle/>
           <a:p>
             <a:r>
-              <a:rPr lang="en-US" smtClean="0"/>
+              <a:rPr lang="en-US"/>
               <a:t>Click to edit Master title style</a:t>
             </a:r>
-            <a:endParaRPr lang="en-US"/>
           </a:p>
         </p:txBody>
       </p:sp>
@@ -768,38 +777,37 @@
           <a:p>
             <a:pPr lvl="0"/>
             <a:r>
-              <a:rPr lang="en-US" smtClean="0"/>
+              <a:rPr lang="en-US"/>
               <a:t>Click to edit Master text styles</a:t>
             </a:r>
           </a:p>
           <a:p>
             <a:pPr lvl="1"/>
             <a:r>
-              <a:rPr lang="en-US" smtClean="0"/>
+              <a:rPr lang="en-US"/>
               <a:t>Second level</a:t>
             </a:r>
           </a:p>
           <a:p>
             <a:pPr lvl="2"/>
             <a:r>
-              <a:rPr lang="en-US" smtClean="0"/>
+              <a:rPr lang="en-US"/>
               <a:t>Third level</a:t>
             </a:r>
           </a:p>
           <a:p>
             <a:pPr lvl="3"/>
             <a:r>
-              <a:rPr lang="en-US" smtClean="0"/>
+              <a:rPr lang="en-US"/>
               <a:t>Fourth level</a:t>
             </a:r>
           </a:p>
           <a:p>
             <a:pPr lvl="4"/>
             <a:r>
-              <a:rPr lang="en-US" smtClean="0"/>
+              <a:rPr lang="en-US"/>
               <a:t>Fifth level</a:t>
             </a:r>
-            <a:endParaRPr lang="en-US"/>
           </a:p>
         </p:txBody>
       </p:sp>
@@ -820,7 +828,7 @@
           <a:p>
             <a:fld id="{5BCAD085-E8A6-8845-BD4E-CB4CCA059FC4}" type="datetimeFigureOut">
               <a:rPr lang="en-US" smtClean="0"/>
-              <a:t>1/27/13</a:t>
+              <a:t>8/26/26</a:t>
             </a:fld>
             <a:endParaRPr lang="en-US"/>
           </a:p>
@@ -862,7 +870,7 @@
           <a:p>
             <a:fld id="{C1FF6DA9-008F-8B48-92A6-B652298478BF}" type="slidenum">
               <a:rPr lang="en-US" smtClean="0"/>
-              <a:t>‹#›</a:t>
+              <a:t>‹N°›</a:t>
             </a:fld>
             <a:endParaRPr lang="en-US"/>
           </a:p>
@@ -923,10 +931,9 @@
           </a:lstStyle>
           <a:p>
             <a:r>
-              <a:rPr lang="en-US" smtClean="0"/>
+              <a:rPr lang="en-US"/>
               <a:t>Click to edit Master title style</a:t>
             </a:r>
-            <a:endParaRPr lang="en-US"/>
           </a:p>
         </p:txBody>
       </p:sp>
@@ -1043,7 +1050,7 @@
           <a:p>
             <a:pPr lvl="0"/>
             <a:r>
-              <a:rPr lang="en-US" smtClean="0"/>
+              <a:rPr lang="en-US"/>
               <a:t>Click to edit Master text styles</a:t>
             </a:r>
           </a:p>
@@ -1066,7 +1073,7 @@
           <a:p>
             <a:fld id="{5BCAD085-E8A6-8845-BD4E-CB4CCA059FC4}" type="datetimeFigureOut">
               <a:rPr lang="en-US" smtClean="0"/>
-              <a:t>1/27/13</a:t>
+              <a:t>8/26/26</a:t>
             </a:fld>
             <a:endParaRPr lang="en-US"/>
           </a:p>
@@ -1108,7 +1115,7 @@
           <a:p>
             <a:fld id="{C1FF6DA9-008F-8B48-92A6-B652298478BF}" type="slidenum">
               <a:rPr lang="en-US" smtClean="0"/>
-              <a:t>‹#›</a:t>
+              <a:t>‹N°›</a:t>
             </a:fld>
             <a:endParaRPr lang="en-US"/>
           </a:p>
@@ -1160,10 +1167,9 @@
           <a:lstStyle/>
           <a:p>
             <a:r>
-              <a:rPr lang="en-US" smtClean="0"/>
+              <a:rPr lang="en-US"/>
               <a:t>Click to edit Master title style</a:t>
             </a:r>
-            <a:endParaRPr lang="en-US"/>
           </a:p>
         </p:txBody>
       </p:sp>
@@ -1217,38 +1223,37 @@
           <a:p>
             <a:pPr lvl="0"/>
             <a:r>
-              <a:rPr lang="en-US" smtClean="0"/>
+              <a:rPr lang="en-US"/>
               <a:t>Click to edit Master text styles</a:t>
             </a:r>
           </a:p>
           <a:p>
             <a:pPr lvl="1"/>
             <a:r>
-              <a:rPr lang="en-US" smtClean="0"/>
+              <a:rPr lang="en-US"/>
               <a:t>Second level</a:t>
             </a:r>
           </a:p>
           <a:p>
             <a:pPr lvl="2"/>
             <a:r>
-              <a:rPr lang="en-US" smtClean="0"/>
+              <a:rPr lang="en-US"/>
               <a:t>Third level</a:t>
             </a:r>
           </a:p>
           <a:p>
             <a:pPr lvl="3"/>
             <a:r>
-              <a:rPr lang="en-US" smtClean="0"/>
+              <a:rPr lang="en-US"/>
               <a:t>Fourth level</a:t>
             </a:r>
           </a:p>
           <a:p>
             <a:pPr lvl="4"/>
             <a:r>
-              <a:rPr lang="en-US" smtClean="0"/>
+              <a:rPr lang="en-US"/>
               <a:t>Fifth level</a:t>
             </a:r>
-            <a:endParaRPr lang="en-US"/>
           </a:p>
         </p:txBody>
       </p:sp>
@@ -1302,38 +1307,37 @@
           <a:p>
             <a:pPr lvl="0"/>
             <a:r>
-              <a:rPr lang="en-US" smtClean="0"/>
+              <a:rPr lang="en-US"/>
               <a:t>Click to edit Master text styles</a:t>
             </a:r>
           </a:p>
           <a:p>
             <a:pPr lvl="1"/>
             <a:r>
-              <a:rPr lang="en-US" smtClean="0"/>
+              <a:rPr lang="en-US"/>
               <a:t>Second level</a:t>
             </a:r>
           </a:p>
           <a:p>
             <a:pPr lvl="2"/>
             <a:r>
-              <a:rPr lang="en-US" smtClean="0"/>
+              <a:rPr lang="en-US"/>
               <a:t>Third level</a:t>
             </a:r>
           </a:p>
           <a:p>
             <a:pPr lvl="3"/>
             <a:r>
-              <a:rPr lang="en-US" smtClean="0"/>
+              <a:rPr lang="en-US"/>
               <a:t>Fourth level</a:t>
             </a:r>
           </a:p>
           <a:p>
             <a:pPr lvl="4"/>
             <a:r>
-              <a:rPr lang="en-US" smtClean="0"/>
+              <a:rPr lang="en-US"/>
               <a:t>Fifth level</a:t>
             </a:r>
-            <a:endParaRPr lang="en-US"/>
           </a:p>
         </p:txBody>
       </p:sp>
@@ -1354,7 +1358,7 @@
           <a:p>
             <a:fld id="{5BCAD085-E8A6-8845-BD4E-CB4CCA059FC4}" type="datetimeFigureOut">
               <a:rPr lang="en-US" smtClean="0"/>
-              <a:t>1/27/13</a:t>
+              <a:t>8/26/26</a:t>
             </a:fld>
             <a:endParaRPr lang="en-US"/>
           </a:p>
@@ -1396,7 +1400,7 @@
           <a:p>
             <a:fld id="{C1FF6DA9-008F-8B48-92A6-B652298478BF}" type="slidenum">
               <a:rPr lang="en-US" smtClean="0"/>
-              <a:t>‹#›</a:t>
+              <a:t>‹N°›</a:t>
             </a:fld>
             <a:endParaRPr lang="en-US"/>
           </a:p>
@@ -1452,10 +1456,9 @@
           </a:lstStyle>
           <a:p>
             <a:r>
-              <a:rPr lang="en-US" smtClean="0"/>
+              <a:rPr lang="en-US"/>
               <a:t>Click to edit Master title style</a:t>
             </a:r>
-            <a:endParaRPr lang="en-US"/>
           </a:p>
         </p:txBody>
       </p:sp>
@@ -1518,7 +1521,7 @@
           <a:p>
             <a:pPr lvl="0"/>
             <a:r>
-              <a:rPr lang="en-US" smtClean="0"/>
+              <a:rPr lang="en-US"/>
               <a:t>Click to edit Master text styles</a:t>
             </a:r>
           </a:p>
@@ -1574,38 +1577,37 @@
           <a:p>
             <a:pPr lvl="0"/>
             <a:r>
-              <a:rPr lang="en-US" smtClean="0"/>
+              <a:rPr lang="en-US"/>
               <a:t>Click to edit Master text styles</a:t>
             </a:r>
           </a:p>
           <a:p>
             <a:pPr lvl="1"/>
             <a:r>
-              <a:rPr lang="en-US" smtClean="0"/>
+              <a:rPr lang="en-US"/>
               <a:t>Second level</a:t>
             </a:r>
           </a:p>
           <a:p>
             <a:pPr lvl="2"/>
             <a:r>
-              <a:rPr lang="en-US" smtClean="0"/>
+              <a:rPr lang="en-US"/>
               <a:t>Third level</a:t>
             </a:r>
           </a:p>
           <a:p>
             <a:pPr lvl="3"/>
             <a:r>
-              <a:rPr lang="en-US" smtClean="0"/>
+              <a:rPr lang="en-US"/>
               <a:t>Fourth level</a:t>
             </a:r>
           </a:p>
           <a:p>
             <a:pPr lvl="4"/>
             <a:r>
-              <a:rPr lang="en-US" smtClean="0"/>
+              <a:rPr lang="en-US"/>
               <a:t>Fifth level</a:t>
             </a:r>
-            <a:endParaRPr lang="en-US"/>
           </a:p>
         </p:txBody>
       </p:sp>
@@ -1668,7 +1670,7 @@
           <a:p>
             <a:pPr lvl="0"/>
             <a:r>
-              <a:rPr lang="en-US" smtClean="0"/>
+              <a:rPr lang="en-US"/>
               <a:t>Click to edit Master text styles</a:t>
             </a:r>
           </a:p>
@@ -1724,38 +1726,37 @@
           <a:p>
             <a:pPr lvl="0"/>
             <a:r>
-              <a:rPr lang="en-US" smtClean="0"/>
+              <a:rPr lang="en-US"/>
               <a:t>Click to edit Master text styles</a:t>
             </a:r>
           </a:p>
           <a:p>
             <a:pPr lvl="1"/>
             <a:r>
-              <a:rPr lang="en-US" smtClean="0"/>
+              <a:rPr lang="en-US"/>
               <a:t>Second level</a:t>
             </a:r>
           </a:p>
           <a:p>
             <a:pPr lvl="2"/>
             <a:r>
-              <a:rPr lang="en-US" smtClean="0"/>
+              <a:rPr lang="en-US"/>
               <a:t>Third level</a:t>
             </a:r>
           </a:p>
           <a:p>
             <a:pPr lvl="3"/>
             <a:r>
-              <a:rPr lang="en-US" smtClean="0"/>
+              <a:rPr lang="en-US"/>
               <a:t>Fourth level</a:t>
             </a:r>
           </a:p>
           <a:p>
             <a:pPr lvl="4"/>
             <a:r>
-              <a:rPr lang="en-US" smtClean="0"/>
+              <a:rPr lang="en-US"/>
               <a:t>Fifth level</a:t>
             </a:r>
-            <a:endParaRPr lang="en-US"/>
           </a:p>
         </p:txBody>
       </p:sp>
@@ -1776,7 +1777,7 @@
           <a:p>
             <a:fld id="{5BCAD085-E8A6-8845-BD4E-CB4CCA059FC4}" type="datetimeFigureOut">
               <a:rPr lang="en-US" smtClean="0"/>
-              <a:t>1/27/13</a:t>
+              <a:t>8/26/26</a:t>
             </a:fld>
             <a:endParaRPr lang="en-US"/>
           </a:p>
@@ -1818,7 +1819,7 @@
           <a:p>
             <a:fld id="{C1FF6DA9-008F-8B48-92A6-B652298478BF}" type="slidenum">
               <a:rPr lang="en-US" smtClean="0"/>
-              <a:t>‹#›</a:t>
+              <a:t>‹N°›</a:t>
             </a:fld>
             <a:endParaRPr lang="en-US"/>
           </a:p>
@@ -1870,10 +1871,9 @@
           <a:lstStyle/>
           <a:p>
             <a:r>
-              <a:rPr lang="en-US" smtClean="0"/>
+              <a:rPr lang="en-US"/>
               <a:t>Click to edit Master title style</a:t>
             </a:r>
-            <a:endParaRPr lang="en-US"/>
           </a:p>
         </p:txBody>
       </p:sp>
@@ -1894,7 +1894,7 @@
           <a:p>
             <a:fld id="{5BCAD085-E8A6-8845-BD4E-CB4CCA059FC4}" type="datetimeFigureOut">
               <a:rPr lang="en-US" smtClean="0"/>
-              <a:t>1/27/13</a:t>
+              <a:t>8/26/26</a:t>
             </a:fld>
             <a:endParaRPr lang="en-US"/>
           </a:p>
@@ -1936,7 +1936,7 @@
           <a:p>
             <a:fld id="{C1FF6DA9-008F-8B48-92A6-B652298478BF}" type="slidenum">
               <a:rPr lang="en-US" smtClean="0"/>
-              <a:t>‹#›</a:t>
+              <a:t>‹N°›</a:t>
             </a:fld>
             <a:endParaRPr lang="en-US"/>
           </a:p>
@@ -1989,7 +1989,7 @@
           <a:p>
             <a:fld id="{5BCAD085-E8A6-8845-BD4E-CB4CCA059FC4}" type="datetimeFigureOut">
               <a:rPr lang="en-US" smtClean="0"/>
-              <a:t>1/27/13</a:t>
+              <a:t>8/26/26</a:t>
             </a:fld>
             <a:endParaRPr lang="en-US"/>
           </a:p>
@@ -2031,7 +2031,7 @@
           <a:p>
             <a:fld id="{C1FF6DA9-008F-8B48-92A6-B652298478BF}" type="slidenum">
               <a:rPr lang="en-US" smtClean="0"/>
-              <a:t>‹#›</a:t>
+              <a:t>‹N°›</a:t>
             </a:fld>
             <a:endParaRPr lang="en-US"/>
           </a:p>
@@ -2092,10 +2092,9 @@
           </a:lstStyle>
           <a:p>
             <a:r>
-              <a:rPr lang="en-US" smtClean="0"/>
+              <a:rPr lang="en-US"/>
               <a:t>Click to edit Master title style</a:t>
             </a:r>
-            <a:endParaRPr lang="en-US"/>
           </a:p>
         </p:txBody>
       </p:sp>
@@ -2149,38 +2148,37 @@
           <a:p>
             <a:pPr lvl="0"/>
             <a:r>
-              <a:rPr lang="en-US" smtClean="0"/>
+              <a:rPr lang="en-US"/>
               <a:t>Click to edit Master text styles</a:t>
             </a:r>
           </a:p>
           <a:p>
             <a:pPr lvl="1"/>
             <a:r>
-              <a:rPr lang="en-US" smtClean="0"/>
+              <a:rPr lang="en-US"/>
               <a:t>Second level</a:t>
             </a:r>
           </a:p>
           <a:p>
             <a:pPr lvl="2"/>
             <a:r>
-              <a:rPr lang="en-US" smtClean="0"/>
+              <a:rPr lang="en-US"/>
               <a:t>Third level</a:t>
             </a:r>
           </a:p>
           <a:p>
             <a:pPr lvl="3"/>
             <a:r>
-              <a:rPr lang="en-US" smtClean="0"/>
+              <a:rPr lang="en-US"/>
               <a:t>Fourth level</a:t>
             </a:r>
           </a:p>
           <a:p>
             <a:pPr lvl="4"/>
             <a:r>
-              <a:rPr lang="en-US" smtClean="0"/>
+              <a:rPr lang="en-US"/>
               <a:t>Fifth level</a:t>
             </a:r>
-            <a:endParaRPr lang="en-US"/>
           </a:p>
         </p:txBody>
       </p:sp>
@@ -2243,7 +2241,7 @@
           <a:p>
             <a:pPr lvl="0"/>
             <a:r>
-              <a:rPr lang="en-US" smtClean="0"/>
+              <a:rPr lang="en-US"/>
               <a:t>Click to edit Master text styles</a:t>
             </a:r>
           </a:p>
@@ -2266,7 +2264,7 @@
           <a:p>
             <a:fld id="{5BCAD085-E8A6-8845-BD4E-CB4CCA059FC4}" type="datetimeFigureOut">
               <a:rPr lang="en-US" smtClean="0"/>
-              <a:t>1/27/13</a:t>
+              <a:t>8/26/26</a:t>
             </a:fld>
             <a:endParaRPr lang="en-US"/>
           </a:p>
@@ -2308,7 +2306,7 @@
           <a:p>
             <a:fld id="{C1FF6DA9-008F-8B48-92A6-B652298478BF}" type="slidenum">
               <a:rPr lang="en-US" smtClean="0"/>
-              <a:t>‹#›</a:t>
+              <a:t>‹N°›</a:t>
             </a:fld>
             <a:endParaRPr lang="en-US"/>
           </a:p>
@@ -2369,10 +2367,9 @@
           </a:lstStyle>
           <a:p>
             <a:r>
-              <a:rPr lang="en-US" smtClean="0"/>
+              <a:rPr lang="en-US"/>
               <a:t>Click to edit Master title style</a:t>
             </a:r>
-            <a:endParaRPr lang="en-US"/>
           </a:p>
         </p:txBody>
       </p:sp>
@@ -2496,7 +2493,7 @@
           <a:p>
             <a:pPr lvl="0"/>
             <a:r>
-              <a:rPr lang="en-US" smtClean="0"/>
+              <a:rPr lang="en-US"/>
               <a:t>Click to edit Master text styles</a:t>
             </a:r>
           </a:p>
@@ -2519,7 +2516,7 @@
           <a:p>
             <a:fld id="{5BCAD085-E8A6-8845-BD4E-CB4CCA059FC4}" type="datetimeFigureOut">
               <a:rPr lang="en-US" smtClean="0"/>
-              <a:t>1/27/13</a:t>
+              <a:t>8/26/26</a:t>
             </a:fld>
             <a:endParaRPr lang="en-US"/>
           </a:p>
@@ -2561,7 +2558,7 @@
           <a:p>
             <a:fld id="{C1FF6DA9-008F-8B48-92A6-B652298478BF}" type="slidenum">
               <a:rPr lang="en-US" smtClean="0"/>
-              <a:t>‹#›</a:t>
+              <a:t>‹N°›</a:t>
             </a:fld>
             <a:endParaRPr lang="en-US"/>
           </a:p>
@@ -2628,10 +2625,9 @@
           <a:lstStyle/>
           <a:p>
             <a:r>
-              <a:rPr lang="en-US" smtClean="0"/>
+              <a:rPr lang="en-US"/>
               <a:t>Click to edit Master title style</a:t>
             </a:r>
-            <a:endParaRPr lang="en-US"/>
           </a:p>
         </p:txBody>
       </p:sp>
@@ -2662,38 +2658,37 @@
           <a:p>
             <a:pPr lvl="0"/>
             <a:r>
-              <a:rPr lang="en-US" smtClean="0"/>
+              <a:rPr lang="en-US"/>
               <a:t>Click to edit Master text styles</a:t>
             </a:r>
           </a:p>
           <a:p>
             <a:pPr lvl="1"/>
             <a:r>
-              <a:rPr lang="en-US" smtClean="0"/>
+              <a:rPr lang="en-US"/>
               <a:t>Second level</a:t>
             </a:r>
           </a:p>
           <a:p>
             <a:pPr lvl="2"/>
             <a:r>
-              <a:rPr lang="en-US" smtClean="0"/>
+              <a:rPr lang="en-US"/>
               <a:t>Third level</a:t>
             </a:r>
           </a:p>
           <a:p>
             <a:pPr lvl="3"/>
             <a:r>
-              <a:rPr lang="en-US" smtClean="0"/>
+              <a:rPr lang="en-US"/>
               <a:t>Fourth level</a:t>
             </a:r>
           </a:p>
           <a:p>
             <a:pPr lvl="4"/>
             <a:r>
-              <a:rPr lang="en-US" smtClean="0"/>
+              <a:rPr lang="en-US"/>
               <a:t>Fifth level</a:t>
             </a:r>
-            <a:endParaRPr lang="en-US"/>
           </a:p>
         </p:txBody>
       </p:sp>
@@ -2732,7 +2727,7 @@
           <a:p>
             <a:fld id="{5BCAD085-E8A6-8845-BD4E-CB4CCA059FC4}" type="datetimeFigureOut">
               <a:rPr lang="en-US" smtClean="0"/>
-              <a:t>1/27/13</a:t>
+              <a:t>8/26/26</a:t>
             </a:fld>
             <a:endParaRPr lang="en-US"/>
           </a:p>
@@ -2810,7 +2805,7 @@
           <a:p>
             <a:fld id="{C1FF6DA9-008F-8B48-92A6-B652298478BF}" type="slidenum">
               <a:rPr lang="en-US" smtClean="0"/>
-              <a:t>‹#›</a:t>
+              <a:t>‹N°›</a:t>
             </a:fld>
             <a:endParaRPr lang="en-US"/>
           </a:p>
@@ -3091,7 +3086,7 @@
 </file>
 
 <file path=ppt/slides/slide1.xml><?xml version="1.0" encoding="utf-8"?>
-<p:sld xmlns:a="http://schemas.openxmlformats.org/drawingml/2006/main" xmlns:p="http://schemas.openxmlformats.org/presentationml/2006/main" xmlns:r="http://schemas.openxmlformats.org/officeDocument/2006/relationships">
+<p:sld xmlns:a="http://schemas.openxmlformats.org/drawingml/2006/main" xmlns:r="http://schemas.openxmlformats.org/officeDocument/2006/relationships" xmlns:p="http://schemas.openxmlformats.org/presentationml/2006/main">
   <p:cSld>
     <p:spTree>
       <p:nvGrpSpPr>
@@ -3099,7 +3094,14 @@
         <p:cNvGrpSpPr/>
         <p:nvPr/>
       </p:nvGrpSpPr>
-      <p:grpSpPr/>
+      <p:grpSpPr>
+        <a:xfrm>
+          <a:off x="0" y="0"/>
+          <a:ext cx="0" cy="0"/>
+          <a:chOff x="0" y="0"/>
+          <a:chExt cx="0" cy="0"/>
+        </a:xfrm>
+      </p:grpSpPr>
       <p:sp>
         <p:nvSpPr>
           <p:cNvPr id="2" name="Rectangle 1"/>
@@ -3140,6 +3142,7 @@
           <a:lstStyle/>
           <a:p>
             <a:pPr algn="ctr"/>
+            <a:endParaRPr/>
           </a:p>
         </p:txBody>
       </p:sp>
@@ -3261,7 +3264,7 @@
           <a:lstStyle/>
           <a:p>
             <a:pPr algn="ctr">
-              <a:defRPr b="1" sz="1500">
+              <a:defRPr sz="1500" b="1">
                 <a:solidFill>
                   <a:srgbClr val="63003C"/>
                 </a:solidFill>
@@ -3308,7 +3311,7 @@
           <a:lstStyle/>
           <a:p>
             <a:pPr algn="ctr">
-              <a:defRPr b="1" sz="1500">
+              <a:defRPr sz="1500" b="1">
                 <a:solidFill>
                   <a:srgbClr val="63003C"/>
                 </a:solidFill>
@@ -3355,7 +3358,7 @@
           <a:lstStyle/>
           <a:p>
             <a:pPr algn="ctr">
-              <a:defRPr b="1" sz="1500">
+              <a:defRPr sz="1500" b="1">
                 <a:solidFill>
                   <a:srgbClr val="63003C"/>
                 </a:solidFill>
@@ -3422,8 +3425,8 @@
 </p:sld>
 </file>
 
-<file path=ppt/slides/slide12.xml><?xml version="1.0" encoding="utf-8"?>
-<p:sld xmlns:a="http://schemas.openxmlformats.org/drawingml/2006/main" xmlns:p="http://schemas.openxmlformats.org/presentationml/2006/main" xmlns:r="http://schemas.openxmlformats.org/officeDocument/2006/relationships">
+<file path=ppt/slides/slide10.xml><?xml version="1.0" encoding="utf-8"?>
+<p:sld xmlns:a="http://schemas.openxmlformats.org/drawingml/2006/main" xmlns:r="http://schemas.openxmlformats.org/officeDocument/2006/relationships" xmlns:p="http://schemas.openxmlformats.org/presentationml/2006/main">
   <p:cSld>
     <p:spTree>
       <p:nvGrpSpPr>
@@ -3431,7 +3434,14 @@
         <p:cNvGrpSpPr/>
         <p:nvPr/>
       </p:nvGrpSpPr>
-      <p:grpSpPr/>
+      <p:grpSpPr>
+        <a:xfrm>
+          <a:off x="0" y="0"/>
+          <a:ext cx="0" cy="0"/>
+          <a:chOff x="0" y="0"/>
+          <a:chExt cx="0" cy="0"/>
+        </a:xfrm>
+      </p:grpSpPr>
       <p:sp>
         <p:nvSpPr>
           <p:cNvPr id="2" name="TextBox 1"/>
@@ -3636,6 +3646,7 @@
           <a:lstStyle/>
           <a:p>
             <a:pPr algn="ctr"/>
+            <a:endParaRPr/>
           </a:p>
         </p:txBody>
       </p:sp>
@@ -3682,8 +3693,8 @@
 </p:sld>
 </file>
 
-<file path=ppt/slides/slide13.xml><?xml version="1.0" encoding="utf-8"?>
-<p:sld xmlns:a="http://schemas.openxmlformats.org/drawingml/2006/main" xmlns:p="http://schemas.openxmlformats.org/presentationml/2006/main" xmlns:r="http://schemas.openxmlformats.org/officeDocument/2006/relationships">
+<file path=ppt/slides/slide11.xml><?xml version="1.0" encoding="utf-8"?>
+<p:sld xmlns:a="http://schemas.openxmlformats.org/drawingml/2006/main" xmlns:r="http://schemas.openxmlformats.org/officeDocument/2006/relationships" xmlns:p="http://schemas.openxmlformats.org/presentationml/2006/main">
   <p:cSld>
     <p:spTree>
       <p:nvGrpSpPr>
@@ -3691,7 +3702,14 @@
         <p:cNvGrpSpPr/>
         <p:nvPr/>
       </p:nvGrpSpPr>
-      <p:grpSpPr/>
+      <p:grpSpPr>
+        <a:xfrm>
+          <a:off x="0" y="0"/>
+          <a:ext cx="0" cy="0"/>
+          <a:chOff x="0" y="0"/>
+          <a:chExt cx="0" cy="0"/>
+        </a:xfrm>
+      </p:grpSpPr>
       <p:sp>
         <p:nvSpPr>
           <p:cNvPr id="2" name="TextBox 1"/>
@@ -3881,6 +3899,7 @@
           <a:lstStyle/>
           <a:p>
             <a:pPr algn="ctr"/>
+            <a:endParaRPr/>
           </a:p>
         </p:txBody>
       </p:sp>
@@ -3927,8 +3946,8 @@
 </p:sld>
 </file>
 
-<file path=ppt/slides/slide14.xml><?xml version="1.0" encoding="utf-8"?>
-<p:sld xmlns:a="http://schemas.openxmlformats.org/drawingml/2006/main" xmlns:p="http://schemas.openxmlformats.org/presentationml/2006/main" xmlns:r="http://schemas.openxmlformats.org/officeDocument/2006/relationships">
+<file path=ppt/slides/slide12.xml><?xml version="1.0" encoding="utf-8"?>
+<p:sld xmlns:a="http://schemas.openxmlformats.org/drawingml/2006/main" xmlns:r="http://schemas.openxmlformats.org/officeDocument/2006/relationships" xmlns:p="http://schemas.openxmlformats.org/presentationml/2006/main">
   <p:cSld>
     <p:spTree>
       <p:nvGrpSpPr>
@@ -3936,7 +3955,14 @@
         <p:cNvGrpSpPr/>
         <p:nvPr/>
       </p:nvGrpSpPr>
-      <p:grpSpPr/>
+      <p:grpSpPr>
+        <a:xfrm>
+          <a:off x="0" y="0"/>
+          <a:ext cx="0" cy="0"/>
+          <a:chOff x="0" y="0"/>
+          <a:chExt cx="0" cy="0"/>
+        </a:xfrm>
+      </p:grpSpPr>
       <p:sp>
         <p:nvSpPr>
           <p:cNvPr id="2" name="TextBox 1"/>
@@ -4126,6 +4152,7 @@
           <a:lstStyle/>
           <a:p>
             <a:pPr algn="ctr"/>
+            <a:endParaRPr/>
           </a:p>
         </p:txBody>
       </p:sp>
@@ -4172,8 +4199,8 @@
 </p:sld>
 </file>
 
-<file path=ppt/slides/slide15.xml><?xml version="1.0" encoding="utf-8"?>
-<p:sld xmlns:a="http://schemas.openxmlformats.org/drawingml/2006/main" xmlns:p="http://schemas.openxmlformats.org/presentationml/2006/main" xmlns:r="http://schemas.openxmlformats.org/officeDocument/2006/relationships">
+<file path=ppt/slides/slide13.xml><?xml version="1.0" encoding="utf-8"?>
+<p:sld xmlns:a="http://schemas.openxmlformats.org/drawingml/2006/main" xmlns:r="http://schemas.openxmlformats.org/officeDocument/2006/relationships" xmlns:p="http://schemas.openxmlformats.org/presentationml/2006/main">
   <p:cSld>
     <p:spTree>
       <p:nvGrpSpPr>
@@ -4181,7 +4208,14 @@
         <p:cNvGrpSpPr/>
         <p:nvPr/>
       </p:nvGrpSpPr>
-      <p:grpSpPr/>
+      <p:grpSpPr>
+        <a:xfrm>
+          <a:off x="0" y="0"/>
+          <a:ext cx="0" cy="0"/>
+          <a:chOff x="0" y="0"/>
+          <a:chExt cx="0" cy="0"/>
+        </a:xfrm>
+      </p:grpSpPr>
       <p:sp>
         <p:nvSpPr>
           <p:cNvPr id="2" name="TextBox 1"/>
@@ -4292,6 +4326,7 @@
           <a:lstStyle/>
           <a:p>
             <a:pPr algn="ctr"/>
+            <a:endParaRPr/>
           </a:p>
         </p:txBody>
       </p:sp>
@@ -4339,7 +4374,7 @@
 </file>
 
 <file path=ppt/slides/slide2.xml><?xml version="1.0" encoding="utf-8"?>
-<p:sld xmlns:a="http://schemas.openxmlformats.org/drawingml/2006/main" xmlns:p="http://schemas.openxmlformats.org/presentationml/2006/main" xmlns:r="http://schemas.openxmlformats.org/officeDocument/2006/relationships">
+<p:sld xmlns:a="http://schemas.openxmlformats.org/drawingml/2006/main" xmlns:r="http://schemas.openxmlformats.org/officeDocument/2006/relationships" xmlns:p="http://schemas.openxmlformats.org/presentationml/2006/main">
   <p:cSld>
     <p:spTree>
       <p:nvGrpSpPr>
@@ -4347,7 +4382,14 @@
         <p:cNvGrpSpPr/>
         <p:nvPr/>
       </p:nvGrpSpPr>
-      <p:grpSpPr/>
+      <p:grpSpPr>
+        <a:xfrm>
+          <a:off x="0" y="0"/>
+          <a:ext cx="0" cy="0"/>
+          <a:chOff x="0" y="0"/>
+          <a:chExt cx="0" cy="0"/>
+        </a:xfrm>
+      </p:grpSpPr>
       <p:sp>
         <p:nvSpPr>
           <p:cNvPr id="2" name="TextBox 1"/>
@@ -4522,6 +4564,7 @@
           <a:lstStyle/>
           <a:p>
             <a:pPr algn="ctr"/>
+            <a:endParaRPr/>
           </a:p>
         </p:txBody>
       </p:sp>
@@ -4569,7 +4612,7 @@
 </file>
 
 <file path=ppt/slides/slide3.xml><?xml version="1.0" encoding="utf-8"?>
-<p:sld xmlns:a="http://schemas.openxmlformats.org/drawingml/2006/main" xmlns:p="http://schemas.openxmlformats.org/presentationml/2006/main" xmlns:r="http://schemas.openxmlformats.org/officeDocument/2006/relationships">
+<p:sld xmlns:a="http://schemas.openxmlformats.org/drawingml/2006/main" xmlns:r="http://schemas.openxmlformats.org/officeDocument/2006/relationships" xmlns:p="http://schemas.openxmlformats.org/presentationml/2006/main">
   <p:cSld>
     <p:spTree>
       <p:nvGrpSpPr>
@@ -4577,7 +4620,14 @@
         <p:cNvGrpSpPr/>
         <p:nvPr/>
       </p:nvGrpSpPr>
-      <p:grpSpPr/>
+      <p:grpSpPr>
+        <a:xfrm>
+          <a:off x="0" y="0"/>
+          <a:ext cx="0" cy="0"/>
+          <a:chOff x="0" y="0"/>
+          <a:chExt cx="0" cy="0"/>
+        </a:xfrm>
+      </p:grpSpPr>
       <p:sp>
         <p:nvSpPr>
           <p:cNvPr id="2" name="TextBox 1"/>
@@ -4752,6 +4802,7 @@
           <a:lstStyle/>
           <a:p>
             <a:pPr algn="ctr"/>
+            <a:endParaRPr/>
           </a:p>
         </p:txBody>
       </p:sp>
@@ -4799,7 +4850,7 @@
 </file>
 
 <file path=ppt/slides/slide4.xml><?xml version="1.0" encoding="utf-8"?>
-<p:sld xmlns:a="http://schemas.openxmlformats.org/drawingml/2006/main" xmlns:p="http://schemas.openxmlformats.org/presentationml/2006/main" xmlns:r="http://schemas.openxmlformats.org/officeDocument/2006/relationships">
+<p:sld xmlns:a="http://schemas.openxmlformats.org/drawingml/2006/main" xmlns:r="http://schemas.openxmlformats.org/officeDocument/2006/relationships" xmlns:p="http://schemas.openxmlformats.org/presentationml/2006/main">
   <p:cSld>
     <p:spTree>
       <p:nvGrpSpPr>
@@ -4807,7 +4858,14 @@
         <p:cNvGrpSpPr/>
         <p:nvPr/>
       </p:nvGrpSpPr>
-      <p:grpSpPr/>
+      <p:grpSpPr>
+        <a:xfrm>
+          <a:off x="0" y="0"/>
+          <a:ext cx="0" cy="0"/>
+          <a:chOff x="0" y="0"/>
+          <a:chExt cx="0" cy="0"/>
+        </a:xfrm>
+      </p:grpSpPr>
       <p:sp>
         <p:nvSpPr>
           <p:cNvPr id="2" name="TextBox 1"/>
@@ -4982,6 +5040,7 @@
           <a:lstStyle/>
           <a:p>
             <a:pPr algn="ctr"/>
+            <a:endParaRPr/>
           </a:p>
         </p:txBody>
       </p:sp>
@@ -5029,7 +5088,7 @@
 </file>
 
 <file path=ppt/slides/slide5.xml><?xml version="1.0" encoding="utf-8"?>
-<p:sld xmlns:a="http://schemas.openxmlformats.org/drawingml/2006/main" xmlns:p="http://schemas.openxmlformats.org/presentationml/2006/main" xmlns:r="http://schemas.openxmlformats.org/officeDocument/2006/relationships">
+<p:sld xmlns:a="http://schemas.openxmlformats.org/drawingml/2006/main" xmlns:r="http://schemas.openxmlformats.org/officeDocument/2006/relationships" xmlns:p="http://schemas.openxmlformats.org/presentationml/2006/main">
   <p:cSld>
     <p:spTree>
       <p:nvGrpSpPr>
@@ -5037,7 +5096,14 @@
         <p:cNvGrpSpPr/>
         <p:nvPr/>
       </p:nvGrpSpPr>
-      <p:grpSpPr/>
+      <p:grpSpPr>
+        <a:xfrm>
+          <a:off x="0" y="0"/>
+          <a:ext cx="0" cy="0"/>
+          <a:chOff x="0" y="0"/>
+          <a:chExt cx="0" cy="0"/>
+        </a:xfrm>
+      </p:grpSpPr>
       <p:sp>
         <p:nvSpPr>
           <p:cNvPr id="2" name="TextBox 1"/>
@@ -5212,6 +5278,7 @@
           <a:lstStyle/>
           <a:p>
             <a:pPr algn="ctr"/>
+            <a:endParaRPr/>
           </a:p>
         </p:txBody>
       </p:sp>
@@ -5259,7 +5326,7 @@
 </file>
 
 <file path=ppt/slides/slide6.xml><?xml version="1.0" encoding="utf-8"?>
-<p:sld xmlns:a="http://schemas.openxmlformats.org/drawingml/2006/main" xmlns:p="http://schemas.openxmlformats.org/presentationml/2006/main" xmlns:r="http://schemas.openxmlformats.org/officeDocument/2006/relationships">
+<p:sld xmlns:a="http://schemas.openxmlformats.org/drawingml/2006/main" xmlns:r="http://schemas.openxmlformats.org/officeDocument/2006/relationships" xmlns:p="http://schemas.openxmlformats.org/presentationml/2006/main">
   <p:cSld>
     <p:spTree>
       <p:nvGrpSpPr>
@@ -5267,7 +5334,14 @@
         <p:cNvGrpSpPr/>
         <p:nvPr/>
       </p:nvGrpSpPr>
-      <p:grpSpPr/>
+      <p:grpSpPr>
+        <a:xfrm>
+          <a:off x="0" y="0"/>
+          <a:ext cx="0" cy="0"/>
+          <a:chOff x="0" y="0"/>
+          <a:chExt cx="0" cy="0"/>
+        </a:xfrm>
+      </p:grpSpPr>
       <p:sp>
         <p:nvSpPr>
           <p:cNvPr id="2" name="TextBox 1"/>
@@ -5457,6 +5531,7 @@
           <a:lstStyle/>
           <a:p>
             <a:pPr algn="ctr"/>
+            <a:endParaRPr/>
           </a:p>
         </p:txBody>
       </p:sp>
@@ -5504,7 +5579,7 @@
 </file>
 
 <file path=ppt/slides/slide7.xml><?xml version="1.0" encoding="utf-8"?>
-<p:sld xmlns:a="http://schemas.openxmlformats.org/drawingml/2006/main" xmlns:p="http://schemas.openxmlformats.org/presentationml/2006/main" xmlns:r="http://schemas.openxmlformats.org/officeDocument/2006/relationships">
+<p:sld xmlns:a="http://schemas.openxmlformats.org/drawingml/2006/main" xmlns:r="http://schemas.openxmlformats.org/officeDocument/2006/relationships" xmlns:p="http://schemas.openxmlformats.org/presentationml/2006/main">
   <p:cSld>
     <p:spTree>
       <p:nvGrpSpPr>
@@ -5512,7 +5587,14 @@
         <p:cNvGrpSpPr/>
         <p:nvPr/>
       </p:nvGrpSpPr>
-      <p:grpSpPr/>
+      <p:grpSpPr>
+        <a:xfrm>
+          <a:off x="0" y="0"/>
+          <a:ext cx="0" cy="0"/>
+          <a:chOff x="0" y="0"/>
+          <a:chExt cx="0" cy="0"/>
+        </a:xfrm>
+      </p:grpSpPr>
       <p:sp>
         <p:nvSpPr>
           <p:cNvPr id="2" name="TextBox 1"/>
@@ -5542,157 +5624,7 @@
                 </a:solidFill>
                 <a:latin typeface="Georgia"/>
               </a:rPr>
-              <a:t>Le graphe biparti G et son résumé G′</a:t>
-            </a:r>
-          </a:p>
-        </p:txBody>
-      </p:sp>
-      <p:pic>
-        <p:nvPicPr>
-          <p:cNvPr id="3" name="Picture 2" descr="shot_graph_G.png"/>
-          <p:cNvPicPr>
-            <a:picLocks noChangeAspect="1"/>
-          </p:cNvPicPr>
-          <p:nvPr/>
-        </p:nvPicPr>
-        <p:blipFill>
-          <a:blip r:embed="rId2"/>
-          <a:stretch>
-            <a:fillRect/>
-          </a:stretch>
-        </p:blipFill>
-        <p:spPr>
-          <a:xfrm>
-            <a:off x="685800" y="1650000"/>
-            <a:ext cx="5244960" cy="3195073"/>
-          </a:xfrm>
-          <a:prstGeom prst="rect">
-            <a:avLst/>
-          </a:prstGeom>
-        </p:spPr>
-      </p:pic>
-      <p:pic>
-        <p:nvPicPr>
-          <p:cNvPr id="4" name="Picture 3" descr="shot_graph_Gprime.png"/>
-          <p:cNvPicPr>
-            <a:picLocks noChangeAspect="1"/>
-          </p:cNvPicPr>
-          <p:nvPr/>
-        </p:nvPicPr>
-        <p:blipFill>
-          <a:blip r:embed="rId3"/>
-          <a:stretch>
-            <a:fillRect/>
-          </a:stretch>
-        </p:blipFill>
-        <p:spPr>
-          <a:xfrm>
-            <a:off x="6230760" y="1650000"/>
-            <a:ext cx="5244960" cy="3195073"/>
-          </a:xfrm>
-          <a:prstGeom prst="rect">
-            <a:avLst/>
-          </a:prstGeom>
-        </p:spPr>
-      </p:pic>
-      <p:sp>
-        <p:nvSpPr>
-          <p:cNvPr id="5" name="TextBox 4"/>
-          <p:cNvSpPr txBox="1"/>
-          <p:nvPr/>
-        </p:nvSpPr>
-        <p:spPr>
-          <a:xfrm>
-            <a:off x="685800" y="4905073"/>
-            <a:ext cx="5244960" cy="320040"/>
-          </a:xfrm>
-          <a:prstGeom prst="rect">
-            <a:avLst/>
-          </a:prstGeom>
-          <a:noFill/>
-        </p:spPr>
-        <p:txBody>
-          <a:bodyPr wrap="square">
-            <a:spAutoFit/>
-          </a:bodyPr>
-          <a:lstStyle/>
-          <a:p>
-            <a:pPr algn="ctr"/>
-            <a:r>
-              <a:rPr sz="1300" b="1">
-                <a:solidFill>
-                  <a:srgbClr val="555555"/>
-                </a:solidFill>
-              </a:rPr>
-              <a:t>Graphe original G</a:t>
-            </a:r>
-          </a:p>
-        </p:txBody>
-      </p:sp>
-      <p:sp>
-        <p:nvSpPr>
-          <p:cNvPr id="6" name="TextBox 5"/>
-          <p:cNvSpPr txBox="1"/>
-          <p:nvPr/>
-        </p:nvSpPr>
-        <p:spPr>
-          <a:xfrm>
-            <a:off x="6230760" y="4905073"/>
-            <a:ext cx="5244960" cy="320040"/>
-          </a:xfrm>
-          <a:prstGeom prst="rect">
-            <a:avLst/>
-          </a:prstGeom>
-          <a:noFill/>
-        </p:spPr>
-        <p:txBody>
-          <a:bodyPr wrap="square">
-            <a:spAutoFit/>
-          </a:bodyPr>
-          <a:lstStyle/>
-          <a:p>
-            <a:pPr algn="ctr"/>
-            <a:r>
-              <a:rPr sz="1300" b="1">
-                <a:solidFill>
-                  <a:srgbClr val="555555"/>
-                </a:solidFill>
-              </a:rPr>
-              <a:t>Graphe résumé G′ (fusion en super-nœuds)</a:t>
-            </a:r>
-          </a:p>
-        </p:txBody>
-      </p:sp>
-      <p:sp>
-        <p:nvSpPr>
-          <p:cNvPr id="7" name="TextBox 6"/>
-          <p:cNvSpPr txBox="1"/>
-          <p:nvPr/>
-        </p:nvSpPr>
-        <p:spPr>
-          <a:xfrm>
-            <a:off x="548640" y="6120000"/>
-            <a:ext cx="11064240" cy="280000"/>
-          </a:xfrm>
-          <a:prstGeom prst="rect">
-            <a:avLst/>
-          </a:prstGeom>
-          <a:noFill/>
-        </p:spPr>
-        <p:txBody>
-          <a:bodyPr wrap="square">
-            <a:spAutoFit/>
-          </a:bodyPr>
-          <a:lstStyle/>
-          <a:p>
-            <a:pPr algn="ctr"/>
-            <a:r>
-              <a:rPr sz="1000" i="1">
-                <a:solidFill>
-                  <a:srgbClr val="555555"/>
-                </a:solidFill>
-              </a:rPr>
-              <a:t>Capture du tableau de bord interactif — sitaacisse-boop.github.io/EDI</a:t>
+              <a:t>Jeux de données et graphe biparti G / G′</a:t>
             </a:r>
           </a:p>
         </p:txBody>
@@ -5738,6 +5670,7 @@
           <a:lstStyle/>
           <a:p>
             <a:pPr algn="ctr"/>
+            <a:endParaRPr/>
           </a:p>
         </p:txBody>
       </p:sp>
@@ -5771,6 +5704,214 @@
                 </a:solidFill>
               </a:rPr>
               <a:t>7</a:t>
+            </a:r>
+          </a:p>
+        </p:txBody>
+      </p:sp>
+      <p:sp>
+        <p:nvSpPr>
+          <p:cNvPr id="10" name="TextBox 9"/>
+          <p:cNvSpPr txBox="1"/>
+          <p:nvPr/>
+        </p:nvSpPr>
+        <p:spPr>
+          <a:xfrm>
+            <a:off x="685800" y="1310000"/>
+            <a:ext cx="10789920" cy="300000"/>
+          </a:xfrm>
+          <a:prstGeom prst="rect">
+            <a:avLst/>
+          </a:prstGeom>
+          <a:noFill/>
+        </p:spPr>
+        <p:txBody>
+          <a:bodyPr wrap="square">
+            <a:spAutoFit/>
+          </a:bodyPr>
+          <a:lstStyle/>
+          <a:p>
+            <a:pPr algn="l"/>
+            <a:r>
+              <a:rPr sz="1650" b="0" i="0">
+                <a:solidFill>
+                  <a:srgbClr val="1A1A1A"/>
+                </a:solidFill>
+              </a:rPr>
+              <a:t>•  5 jeux de données, 4 domaines : MovieLens 100k et 1M, libimseti.cz, Rate My Professors, OpenAlex</a:t>
+            </a:r>
+          </a:p>
+        </p:txBody>
+      </p:sp>
+      <p:pic>
+        <p:nvPicPr>
+          <p:cNvPr id="11" name="Picture 10" descr="image.png"/>
+          <p:cNvPicPr>
+            <a:picLocks noChangeAspect="1"/>
+          </p:cNvPicPr>
+          <p:nvPr/>
+        </p:nvPicPr>
+        <p:blipFill>
+          <a:blip r:embed="rId4"/>
+          <a:stretch>
+            <a:fillRect/>
+          </a:stretch>
+        </p:blipFill>
+        <p:spPr>
+          <a:xfrm>
+            <a:off x="4148023" y="1660000"/>
+            <a:ext cx="3865473" cy="1650000"/>
+          </a:xfrm>
+          <a:prstGeom prst="rect">
+            <a:avLst/>
+          </a:prstGeom>
+        </p:spPr>
+      </p:pic>
+      <p:pic>
+        <p:nvPicPr>
+          <p:cNvPr id="12" name="Picture 11" descr="image.png"/>
+          <p:cNvPicPr>
+            <a:picLocks noChangeAspect="1"/>
+          </p:cNvPicPr>
+          <p:nvPr/>
+        </p:nvPicPr>
+        <p:blipFill>
+          <a:blip r:embed="rId2"/>
+          <a:stretch>
+            <a:fillRect/>
+          </a:stretch>
+        </p:blipFill>
+        <p:spPr>
+          <a:xfrm>
+            <a:off x="1846818" y="3360000"/>
+            <a:ext cx="4103942" cy="2500000"/>
+          </a:xfrm>
+          <a:prstGeom prst="rect">
+            <a:avLst/>
+          </a:prstGeom>
+        </p:spPr>
+      </p:pic>
+      <p:pic>
+        <p:nvPicPr>
+          <p:cNvPr id="13" name="Picture 12" descr="image.png"/>
+          <p:cNvPicPr>
+            <a:picLocks noChangeAspect="1"/>
+          </p:cNvPicPr>
+          <p:nvPr/>
+        </p:nvPicPr>
+        <p:blipFill>
+          <a:blip r:embed="rId3"/>
+          <a:stretch>
+            <a:fillRect/>
+          </a:stretch>
+        </p:blipFill>
+        <p:spPr>
+          <a:xfrm>
+            <a:off x="6210760" y="3360000"/>
+            <a:ext cx="4103942" cy="2500000"/>
+          </a:xfrm>
+          <a:prstGeom prst="rect">
+            <a:avLst/>
+          </a:prstGeom>
+        </p:spPr>
+      </p:pic>
+      <p:sp>
+        <p:nvSpPr>
+          <p:cNvPr id="14" name="TextBox 13"/>
+          <p:cNvSpPr txBox="1"/>
+          <p:nvPr/>
+        </p:nvSpPr>
+        <p:spPr>
+          <a:xfrm>
+            <a:off x="1846818" y="5880000"/>
+            <a:ext cx="4103942" cy="280000"/>
+          </a:xfrm>
+          <a:prstGeom prst="rect">
+            <a:avLst/>
+          </a:prstGeom>
+          <a:noFill/>
+        </p:spPr>
+        <p:txBody>
+          <a:bodyPr wrap="square">
+            <a:spAutoFit/>
+          </a:bodyPr>
+          <a:lstStyle/>
+          <a:p>
+            <a:pPr algn="ctr"/>
+            <a:r>
+              <a:rPr sz="1200" b="1">
+                <a:solidFill>
+                  <a:srgbClr val="555555"/>
+                </a:solidFill>
+              </a:rPr>
+              <a:t>Graphe original G</a:t>
+            </a:r>
+          </a:p>
+        </p:txBody>
+      </p:sp>
+      <p:sp>
+        <p:nvSpPr>
+          <p:cNvPr id="15" name="TextBox 14"/>
+          <p:cNvSpPr txBox="1"/>
+          <p:nvPr/>
+        </p:nvSpPr>
+        <p:spPr>
+          <a:xfrm>
+            <a:off x="6210760" y="5880000"/>
+            <a:ext cx="4103942" cy="280000"/>
+          </a:xfrm>
+          <a:prstGeom prst="rect">
+            <a:avLst/>
+          </a:prstGeom>
+          <a:noFill/>
+        </p:spPr>
+        <p:txBody>
+          <a:bodyPr wrap="square">
+            <a:spAutoFit/>
+          </a:bodyPr>
+          <a:lstStyle/>
+          <a:p>
+            <a:pPr algn="ctr"/>
+            <a:r>
+              <a:rPr sz="1200" b="1">
+                <a:solidFill>
+                  <a:srgbClr val="555555"/>
+                </a:solidFill>
+              </a:rPr>
+              <a:t>Graphe résumé G′ (fusion en super-nœuds)</a:t>
+            </a:r>
+          </a:p>
+        </p:txBody>
+      </p:sp>
+      <p:sp>
+        <p:nvSpPr>
+          <p:cNvPr id="16" name="TextBox 15"/>
+          <p:cNvSpPr txBox="1"/>
+          <p:nvPr/>
+        </p:nvSpPr>
+        <p:spPr>
+          <a:xfrm>
+            <a:off x="685800" y="6180000"/>
+            <a:ext cx="10789920" cy="240000"/>
+          </a:xfrm>
+          <a:prstGeom prst="rect">
+            <a:avLst/>
+          </a:prstGeom>
+          <a:noFill/>
+        </p:spPr>
+        <p:txBody>
+          <a:bodyPr wrap="square">
+            <a:spAutoFit/>
+          </a:bodyPr>
+          <a:lstStyle/>
+          <a:p>
+            <a:pPr algn="ctr"/>
+            <a:r>
+              <a:rPr sz="1000" b="0" i="1">
+                <a:solidFill>
+                  <a:srgbClr val="555555"/>
+                </a:solidFill>
+              </a:rPr>
+              <a:t>Captures du tableau de bord interactif — sitaacisse-boop.github.io/EDI</a:t>
             </a:r>
           </a:p>
         </p:txBody>
@@ -5784,7 +5925,7 @@
 </file>
 
 <file path=ppt/slides/slide8.xml><?xml version="1.0" encoding="utf-8"?>
-<p:sld xmlns:a="http://schemas.openxmlformats.org/drawingml/2006/main" xmlns:p="http://schemas.openxmlformats.org/presentationml/2006/main" xmlns:r="http://schemas.openxmlformats.org/officeDocument/2006/relationships">
+<p:sld xmlns:a="http://schemas.openxmlformats.org/drawingml/2006/main" xmlns:r="http://schemas.openxmlformats.org/officeDocument/2006/relationships" xmlns:p="http://schemas.openxmlformats.org/presentationml/2006/main">
   <p:cSld>
     <p:spTree>
       <p:nvGrpSpPr>
@@ -5792,7 +5933,14 @@
         <p:cNvGrpSpPr/>
         <p:nvPr/>
       </p:nvGrpSpPr>
-      <p:grpSpPr/>
+      <p:grpSpPr>
+        <a:xfrm>
+          <a:off x="0" y="0"/>
+          <a:ext cx="0" cy="0"/>
+          <a:chOff x="0" y="0"/>
+          <a:chExt cx="0" cy="0"/>
+        </a:xfrm>
+      </p:grpSpPr>
       <p:sp>
         <p:nvSpPr>
           <p:cNvPr id="2" name="TextBox 1"/>
@@ -5869,6 +6017,7 @@
           <a:lstStyle/>
           <a:p>
             <a:pPr algn="ctr"/>
+            <a:endParaRPr/>
           </a:p>
         </p:txBody>
       </p:sp>
@@ -5916,7 +6065,7 @@
         <p:spPr>
           <a:xfrm>
             <a:off x="685800" y="1350000"/>
-            <a:ext cx="10789920" cy="1000000"/>
+            <a:ext cx="10789920" cy="805349"/>
           </a:xfrm>
           <a:prstGeom prst="rect">
             <a:avLst/>
@@ -5935,13 +6084,34 @@
               </a:spcAft>
             </a:pPr>
             <a:r>
-              <a:rPr sz="1900">
+              <a:rPr sz="1900" dirty="0">
                 <a:solidFill>
                   <a:srgbClr val="1A1A1A"/>
                 </a:solidFill>
               </a:rPr>
-              <a:t>•  5 jeux de données, 4 domaines : MovieLens 100k et 1M, libimseti.cz, Rate My Professors, OpenAlex</a:t>
-            </a:r>
+              <a:t>•  Bascule vers le tableau de bord </a:t>
+            </a:r>
+            <a:r>
+              <a:rPr sz="1900" dirty="0" err="1">
+                <a:solidFill>
+                  <a:srgbClr val="1A1A1A"/>
+                </a:solidFill>
+              </a:rPr>
+              <a:t>interactif</a:t>
+            </a:r>
+            <a:r>
+              <a:rPr sz="1900" dirty="0">
+                <a:solidFill>
+                  <a:srgbClr val="1A1A1A"/>
+                </a:solidFill>
+              </a:rPr>
+              <a:t> —</a:t>
+            </a:r>
+            <a:endParaRPr lang="fr-FR" sz="1900" dirty="0">
+              <a:solidFill>
+                <a:srgbClr val="1A1A1A"/>
+              </a:solidFill>
+            </a:endParaRPr>
           </a:p>
           <a:p>
             <a:pPr>
@@ -5950,40 +6120,32 @@
               </a:spcAft>
             </a:pPr>
             <a:r>
-              <a:rPr sz="1900">
+              <a:rPr sz="1900" dirty="0">
                 <a:solidFill>
                   <a:srgbClr val="1A1A1A"/>
                 </a:solidFill>
               </a:rPr>
-              <a:t>•  Bascule vers le tableau de bord interactif — sitaacisse-boop.github.io/EDI</a:t>
-            </a:r>
-          </a:p>
-        </p:txBody>
-      </p:sp>
-      <p:pic>
-        <p:nvPicPr>
-          <p:cNvPr id="8" name="Picture 7" descr="shot_data_overview.png"/>
-          <p:cNvPicPr>
-            <a:picLocks noChangeAspect="1"/>
-          </p:cNvPicPr>
-          <p:nvPr/>
-        </p:nvPicPr>
-        <p:blipFill>
-          <a:blip r:embed="rId2"/>
-          <a:stretch>
-            <a:fillRect/>
-          </a:stretch>
-        </p:blipFill>
-        <p:spPr>
-          <a:xfrm>
-            <a:off x="1644697" y="2450000"/>
-            <a:ext cx="8902301" cy="3800000"/>
-          </a:xfrm>
-          <a:prstGeom prst="rect">
-            <a:avLst/>
-          </a:prstGeom>
-        </p:spPr>
-      </p:pic>
+              <a:t> </a:t>
+            </a:r>
+            <a:r>
+              <a:rPr sz="1900" dirty="0" err="1">
+                <a:solidFill>
+                  <a:srgbClr val="1A1A1A"/>
+                </a:solidFill>
+              </a:rPr>
+              <a:t>sitaacisse-boop.github.io</a:t>
+            </a:r>
+            <a:r>
+              <a:rPr sz="1900" dirty="0">
+                <a:solidFill>
+                  <a:srgbClr val="1A1A1A"/>
+                </a:solidFill>
+              </a:rPr>
+              <a:t>/EDI</a:t>
+            </a:r>
+          </a:p>
+        </p:txBody>
+      </p:sp>
     </p:spTree>
   </p:cSld>
   <p:clrMapOvr>
@@ -5993,7 +6155,7 @@
 </file>
 
 <file path=ppt/slides/slide9.xml><?xml version="1.0" encoding="utf-8"?>
-<p:sld xmlns:a="http://schemas.openxmlformats.org/drawingml/2006/main" xmlns:p="http://schemas.openxmlformats.org/presentationml/2006/main" xmlns:r="http://schemas.openxmlformats.org/officeDocument/2006/relationships">
+<p:sld xmlns:a="http://schemas.openxmlformats.org/drawingml/2006/main" xmlns:r="http://schemas.openxmlformats.org/officeDocument/2006/relationships" xmlns:p="http://schemas.openxmlformats.org/presentationml/2006/main">
   <p:cSld>
     <p:spTree>
       <p:nvGrpSpPr>
@@ -6001,7 +6163,14 @@
         <p:cNvGrpSpPr/>
         <p:nvPr/>
       </p:nvGrpSpPr>
-      <p:grpSpPr/>
+      <p:grpSpPr>
+        <a:xfrm>
+          <a:off x="0" y="0"/>
+          <a:ext cx="0" cy="0"/>
+          <a:chOff x="0" y="0"/>
+          <a:chExt cx="0" cy="0"/>
+        </a:xfrm>
+      </p:grpSpPr>
       <p:sp>
         <p:nvSpPr>
           <p:cNvPr id="2" name="TextBox 1"/>
@@ -6176,6 +6345,7 @@
           <a:lstStyle/>
           <a:p>
             <a:pPr algn="ctr"/>
+            <a:endParaRPr/>
           </a:p>
         </p:txBody>
       </p:sp>

</xml_diff>

<commit_message>
Restaure les deux puces originales de la slide Validation — Démonstration en Direct
</commit_message>
<xml_diff>
--- a/presentation/AURORA_Soutenance_FR.pptx
+++ b/presentation/AURORA_Soutenance_FR.pptx
@@ -6080,32 +6080,16 @@
           <a:p>
             <a:pPr>
               <a:spcAft>
-                <a:spcPts val="1000"/>
+                <a:spcPts val="1400"/>
               </a:spcAft>
             </a:pPr>
             <a:r>
-              <a:rPr sz="1900" dirty="0">
+              <a:rPr sz="2200">
                 <a:solidFill>
                   <a:srgbClr val="1A1A1A"/>
                 </a:solidFill>
               </a:rPr>
-              <a:t>•  Bascule vers le tableau de bord </a:t>
-            </a:r>
-            <a:r>
-              <a:rPr sz="1900" dirty="0" err="1">
-                <a:solidFill>
-                  <a:srgbClr val="1A1A1A"/>
-                </a:solidFill>
-              </a:rPr>
-              <a:t>interactif</a:t>
-            </a:r>
-            <a:r>
-              <a:rPr sz="1900" dirty="0">
-                <a:solidFill>
-                  <a:srgbClr val="1A1A1A"/>
-                </a:solidFill>
-              </a:rPr>
-              <a:t> —</a:t>
+              <a:t>•  5 jeux de données, 4 domaines : MovieLens 100k et 1M, libimseti.cz, Rate My Professors, OpenAlex</a:t>
             </a:r>
             <a:endParaRPr lang="fr-FR" sz="1900" dirty="0">
               <a:solidFill>
@@ -6116,32 +6100,16 @@
           <a:p>
             <a:pPr>
               <a:spcAft>
-                <a:spcPts val="1000"/>
+                <a:spcPts val="1400"/>
               </a:spcAft>
             </a:pPr>
             <a:r>
-              <a:rPr sz="1900" dirty="0">
+              <a:rPr sz="2200">
                 <a:solidFill>
                   <a:srgbClr val="1A1A1A"/>
                 </a:solidFill>
               </a:rPr>
-              <a:t> </a:t>
-            </a:r>
-            <a:r>
-              <a:rPr sz="1900" dirty="0" err="1">
-                <a:solidFill>
-                  <a:srgbClr val="1A1A1A"/>
-                </a:solidFill>
-              </a:rPr>
-              <a:t>sitaacisse-boop.github.io</a:t>
-            </a:r>
-            <a:r>
-              <a:rPr sz="1900" dirty="0">
-                <a:solidFill>
-                  <a:srgbClr val="1A1A1A"/>
-                </a:solidFill>
-              </a:rPr>
-              <a:t>/EDI</a:t>
+              <a:t>•  Bascule vers le tableau de bord interactif : sitaacisse-boop.github.io/EDI</a:t>
             </a:r>
           </a:p>
         </p:txBody>

</xml_diff>

<commit_message>
Sépare la slide combinée en deux : Jeux de données (figure du mémoire) et Graphe G/G'
- Nouvelle slide "Jeux de données" dédiée, utilisant la figure du mémoire
  (fig_datasets_overview_full_fr.png : taille des corpus, déséquilibre de
  genre, répartition des notes) plutôt que la petite capture du site.
- Slide "Le graphe biparti G et son résumé G'" séparée, gardant les deux
  captures avant/après fusion côte à côte.
- 13 → 14 slides.
</commit_message>
<xml_diff>
--- a/presentation/AURORA_Soutenance_FR.pptx
+++ b/presentation/AURORA_Soutenance_FR.pptx
@@ -12,6 +12,7 @@
     <p:sldId id="260" r:id="rId6"/>
     <p:sldId id="261" r:id="rId7"/>
     <p:sldId id="268" r:id="rId8"/>
+    <p:sldId id="269" r:id="rId19"/>
     <p:sldId id="262" r:id="rId9"/>
     <p:sldId id="263" r:id="rId10"/>
     <p:sldId id="264" r:id="rId11"/>
@@ -3680,7 +3681,7 @@
               </a:defRPr>
             </a:pPr>
             <a:r>
-              <a:t>10</a:t>
+              <a:t>11</a:t>
             </a:r>
           </a:p>
         </p:txBody>
@@ -3933,7 +3934,7 @@
               </a:defRPr>
             </a:pPr>
             <a:r>
-              <a:t>11</a:t>
+              <a:t>12</a:t>
             </a:r>
           </a:p>
         </p:txBody>
@@ -4186,7 +4187,7 @@
               </a:defRPr>
             </a:pPr>
             <a:r>
-              <a:t>12</a:t>
+              <a:t>13</a:t>
             </a:r>
           </a:p>
         </p:txBody>
@@ -4360,7 +4361,287 @@
               </a:defRPr>
             </a:pPr>
             <a:r>
-              <a:t>13</a:t>
+              <a:t>14</a:t>
+            </a:r>
+          </a:p>
+        </p:txBody>
+      </p:sp>
+    </p:spTree>
+  </p:cSld>
+  <p:clrMapOvr>
+    <a:masterClrMapping/>
+  </p:clrMapOvr>
+</p:sld>
+</file>
+
+<file path=ppt/slides/slide14.xml><?xml version="1.0" encoding="utf-8"?>
+<p:sld xmlns:a="http://schemas.openxmlformats.org/drawingml/2006/main" xmlns:p="http://schemas.openxmlformats.org/presentationml/2006/main" xmlns:r="http://schemas.openxmlformats.org/officeDocument/2006/relationships">
+  <p:cSld>
+    <p:spTree>
+      <p:nvGrpSpPr>
+        <p:cNvPr id="1" name=""/>
+        <p:cNvGrpSpPr/>
+        <p:nvPr/>
+      </p:nvGrpSpPr>
+      <p:grpSpPr/>
+      <p:sp>
+        <p:nvSpPr>
+          <p:cNvPr id="2" name="TextBox 1"/>
+          <p:cNvSpPr txBox="1"/>
+          <p:nvPr/>
+        </p:nvSpPr>
+        <p:spPr>
+          <a:xfrm>
+            <a:off x="548640" y="320040"/>
+            <a:ext cx="11064240" cy="914400"/>
+          </a:xfrm>
+          <a:prstGeom prst="rect">
+            <a:avLst/>
+          </a:prstGeom>
+          <a:noFill/>
+        </p:spPr>
+        <p:txBody>
+          <a:bodyPr wrap="square">
+            <a:spAutoFit/>
+          </a:bodyPr>
+          <a:lstStyle/>
+          <a:p>
+            <a:r>
+              <a:rPr sz="3000" b="1">
+                <a:solidFill>
+                  <a:srgbClr val="63003C"/>
+                </a:solidFill>
+                <a:latin typeface="Georgia"/>
+              </a:rPr>
+              <a:t>Le graphe biparti G et son résumé G′</a:t>
+            </a:r>
+          </a:p>
+        </p:txBody>
+      </p:sp>
+      <p:pic>
+        <p:nvPicPr>
+          <p:cNvPr id="3" name="Picture 2" descr="image.png"/>
+          <p:cNvPicPr>
+            <a:picLocks noChangeAspect="1"/>
+          </p:cNvPicPr>
+          <p:nvPr/>
+        </p:nvPicPr>
+        <p:blipFill>
+          <a:blip r:embed="rId2"/>
+          <a:stretch>
+            <a:fillRect/>
+          </a:stretch>
+        </p:blipFill>
+        <p:spPr>
+          <a:xfrm>
+            <a:off x="685800" y="1500000"/>
+            <a:ext cx="5244960" cy="3195073"/>
+          </a:xfrm>
+          <a:prstGeom prst="rect">
+            <a:avLst/>
+          </a:prstGeom>
+        </p:spPr>
+      </p:pic>
+      <p:pic>
+        <p:nvPicPr>
+          <p:cNvPr id="4" name="Picture 3" descr="image.png"/>
+          <p:cNvPicPr>
+            <a:picLocks noChangeAspect="1"/>
+          </p:cNvPicPr>
+          <p:nvPr/>
+        </p:nvPicPr>
+        <p:blipFill>
+          <a:blip r:embed="rId3"/>
+          <a:stretch>
+            <a:fillRect/>
+          </a:stretch>
+        </p:blipFill>
+        <p:spPr>
+          <a:xfrm>
+            <a:off x="6230760" y="1500000"/>
+            <a:ext cx="5244960" cy="3195073"/>
+          </a:xfrm>
+          <a:prstGeom prst="rect">
+            <a:avLst/>
+          </a:prstGeom>
+        </p:spPr>
+      </p:pic>
+      <p:sp>
+        <p:nvSpPr>
+          <p:cNvPr id="5" name="TextBox 4"/>
+          <p:cNvSpPr txBox="1"/>
+          <p:nvPr/>
+        </p:nvSpPr>
+        <p:spPr>
+          <a:xfrm>
+            <a:off x="685800" y="4745073"/>
+            <a:ext cx="5244960" cy="280000"/>
+          </a:xfrm>
+          <a:prstGeom prst="rect">
+            <a:avLst/>
+          </a:prstGeom>
+          <a:noFill/>
+        </p:spPr>
+        <p:txBody>
+          <a:bodyPr wrap="square">
+            <a:spAutoFit/>
+          </a:bodyPr>
+          <a:lstStyle/>
+          <a:p>
+            <a:pPr algn="ctr"/>
+            <a:r>
+              <a:rPr sz="1200" b="1">
+                <a:solidFill>
+                  <a:srgbClr val="555555"/>
+                </a:solidFill>
+              </a:rPr>
+              <a:t>Graphe original G</a:t>
+            </a:r>
+          </a:p>
+        </p:txBody>
+      </p:sp>
+      <p:sp>
+        <p:nvSpPr>
+          <p:cNvPr id="6" name="TextBox 5"/>
+          <p:cNvSpPr txBox="1"/>
+          <p:nvPr/>
+        </p:nvSpPr>
+        <p:spPr>
+          <a:xfrm>
+            <a:off x="6230760" y="4745073"/>
+            <a:ext cx="5244960" cy="280000"/>
+          </a:xfrm>
+          <a:prstGeom prst="rect">
+            <a:avLst/>
+          </a:prstGeom>
+          <a:noFill/>
+        </p:spPr>
+        <p:txBody>
+          <a:bodyPr wrap="square">
+            <a:spAutoFit/>
+          </a:bodyPr>
+          <a:lstStyle/>
+          <a:p>
+            <a:pPr algn="ctr"/>
+            <a:r>
+              <a:rPr sz="1200" b="1">
+                <a:solidFill>
+                  <a:srgbClr val="555555"/>
+                </a:solidFill>
+              </a:rPr>
+              <a:t>Graphe résumé G′ (fusion en super-nœuds)</a:t>
+            </a:r>
+          </a:p>
+        </p:txBody>
+      </p:sp>
+      <p:sp>
+        <p:nvSpPr>
+          <p:cNvPr id="7" name="TextBox 6"/>
+          <p:cNvSpPr txBox="1"/>
+          <p:nvPr/>
+        </p:nvSpPr>
+        <p:spPr>
+          <a:xfrm>
+            <a:off x="685800" y="5045073"/>
+            <a:ext cx="10789920" cy="240000"/>
+          </a:xfrm>
+          <a:prstGeom prst="rect">
+            <a:avLst/>
+          </a:prstGeom>
+          <a:noFill/>
+        </p:spPr>
+        <p:txBody>
+          <a:bodyPr wrap="square">
+            <a:spAutoFit/>
+          </a:bodyPr>
+          <a:lstStyle/>
+          <a:p>
+            <a:pPr algn="ctr"/>
+            <a:r>
+              <a:rPr sz="1000" b="0" i="1">
+                <a:solidFill>
+                  <a:srgbClr val="555555"/>
+                </a:solidFill>
+              </a:rPr>
+              <a:t>Captures du tableau de bord interactif — sitaacisse-boop.github.io/EDI</a:t>
+            </a:r>
+          </a:p>
+        </p:txBody>
+      </p:sp>
+      <p:sp>
+        <p:nvSpPr>
+          <p:cNvPr id="8" name="Rectangle 7"/>
+          <p:cNvSpPr/>
+          <p:nvPr/>
+        </p:nvSpPr>
+        <p:spPr>
+          <a:xfrm>
+            <a:off x="548640" y="6446520"/>
+            <a:ext cx="11091672" cy="27940"/>
+          </a:xfrm>
+          <a:prstGeom prst="rect">
+            <a:avLst/>
+          </a:prstGeom>
+          <a:solidFill>
+            <a:srgbClr val="63003C"/>
+          </a:solidFill>
+          <a:ln>
+            <a:noFill/>
+          </a:ln>
+          <a:effectLst/>
+        </p:spPr>
+        <p:style>
+          <a:lnRef idx="1">
+            <a:schemeClr val="accent1"/>
+          </a:lnRef>
+          <a:fillRef idx="3">
+            <a:schemeClr val="accent1"/>
+          </a:fillRef>
+          <a:effectRef idx="2">
+            <a:schemeClr val="accent1"/>
+          </a:effectRef>
+          <a:fontRef idx="minor">
+            <a:schemeClr val="lt1"/>
+          </a:fontRef>
+        </p:style>
+        <p:txBody>
+          <a:bodyPr rtlCol="0" anchor="ctr"/>
+          <a:lstStyle/>
+          <a:p>
+            <a:pPr algn="ctr"/>
+          </a:p>
+        </p:txBody>
+      </p:sp>
+      <p:sp>
+        <p:nvSpPr>
+          <p:cNvPr id="9" name="TextBox 8"/>
+          <p:cNvSpPr txBox="1"/>
+          <p:nvPr/>
+        </p:nvSpPr>
+        <p:spPr>
+          <a:xfrm>
+            <a:off x="11521440" y="6492240"/>
+            <a:ext cx="548640" cy="320040"/>
+          </a:xfrm>
+          <a:prstGeom prst="rect">
+            <a:avLst/>
+          </a:prstGeom>
+          <a:noFill/>
+        </p:spPr>
+        <p:txBody>
+          <a:bodyPr wrap="none">
+            <a:spAutoFit/>
+          </a:bodyPr>
+          <a:lstStyle/>
+          <a:p>
+            <a:pPr algn="r"/>
+            <a:r>
+              <a:rPr sz="1100">
+                <a:solidFill>
+                  <a:srgbClr val="555555"/>
+                </a:solidFill>
+              </a:rPr>
+              <a:t>8</a:t>
             </a:r>
           </a:p>
         </p:txBody>
@@ -5624,7 +5905,7 @@
                 </a:solidFill>
                 <a:latin typeface="Georgia"/>
               </a:rPr>
-              <a:t>Jeux de données et graphe biparti G / G′</a:t>
+              <a:t>Jeux de données</a:t>
             </a:r>
           </a:p>
         </p:txBody>
@@ -5708,122 +5989,40 @@
           </a:p>
         </p:txBody>
       </p:sp>
-      <p:sp>
-        <p:nvSpPr>
-          <p:cNvPr id="10" name="TextBox 9"/>
-          <p:cNvSpPr txBox="1"/>
-          <p:nvPr/>
-        </p:nvSpPr>
-        <p:spPr>
-          <a:xfrm>
-            <a:off x="685800" y="1310000"/>
-            <a:ext cx="10789920" cy="300000"/>
-          </a:xfrm>
-          <a:prstGeom prst="rect">
-            <a:avLst/>
-          </a:prstGeom>
-          <a:noFill/>
-        </p:spPr>
-        <p:txBody>
-          <a:bodyPr wrap="square">
-            <a:spAutoFit/>
-          </a:bodyPr>
-          <a:lstStyle/>
-          <a:p>
-            <a:pPr algn="l"/>
-            <a:r>
-              <a:rPr sz="1650" b="0" i="0">
-                <a:solidFill>
-                  <a:srgbClr val="1A1A1A"/>
-                </a:solidFill>
-              </a:rPr>
-              <a:t>•  5 jeux de données, 4 domaines : MovieLens 100k et 1M, libimseti.cz, Rate My Professors, OpenAlex</a:t>
-            </a:r>
-          </a:p>
-        </p:txBody>
-      </p:sp>
       <p:pic>
         <p:nvPicPr>
-          <p:cNvPr id="11" name="Picture 10" descr="image.png"/>
+          <p:cNvPr id="10" name="Picture 9" descr="fig_datasets_overview_full_fr.png"/>
           <p:cNvPicPr>
             <a:picLocks noChangeAspect="1"/>
           </p:cNvPicPr>
           <p:nvPr/>
         </p:nvPicPr>
         <p:blipFill>
-          <a:blip r:embed="rId4"/>
+          <a:blip r:embed="rId5"/>
           <a:stretch>
             <a:fillRect/>
           </a:stretch>
         </p:blipFill>
         <p:spPr>
           <a:xfrm>
-            <a:off x="4148023" y="1660000"/>
-            <a:ext cx="3865473" cy="1650000"/>
+            <a:off x="2576741" y="1330000"/>
+            <a:ext cx="7008038" cy="4650000"/>
           </a:xfrm>
           <a:prstGeom prst="rect">
             <a:avLst/>
           </a:prstGeom>
         </p:spPr>
       </p:pic>
-      <p:pic>
-        <p:nvPicPr>
-          <p:cNvPr id="12" name="Picture 11" descr="image.png"/>
-          <p:cNvPicPr>
-            <a:picLocks noChangeAspect="1"/>
-          </p:cNvPicPr>
-          <p:nvPr/>
-        </p:nvPicPr>
-        <p:blipFill>
-          <a:blip r:embed="rId2"/>
-          <a:stretch>
-            <a:fillRect/>
-          </a:stretch>
-        </p:blipFill>
-        <p:spPr>
-          <a:xfrm>
-            <a:off x="1846818" y="3360000"/>
-            <a:ext cx="4103942" cy="2500000"/>
-          </a:xfrm>
-          <a:prstGeom prst="rect">
-            <a:avLst/>
-          </a:prstGeom>
-        </p:spPr>
-      </p:pic>
-      <p:pic>
-        <p:nvPicPr>
-          <p:cNvPr id="13" name="Picture 12" descr="image.png"/>
-          <p:cNvPicPr>
-            <a:picLocks noChangeAspect="1"/>
-          </p:cNvPicPr>
-          <p:nvPr/>
-        </p:nvPicPr>
-        <p:blipFill>
-          <a:blip r:embed="rId3"/>
-          <a:stretch>
-            <a:fillRect/>
-          </a:stretch>
-        </p:blipFill>
-        <p:spPr>
-          <a:xfrm>
-            <a:off x="6210760" y="3360000"/>
-            <a:ext cx="4103942" cy="2500000"/>
-          </a:xfrm>
-          <a:prstGeom prst="rect">
-            <a:avLst/>
-          </a:prstGeom>
-        </p:spPr>
-      </p:pic>
-      <p:sp>
-        <p:nvSpPr>
-          <p:cNvPr id="14" name="TextBox 13"/>
+      <p:sp>
+        <p:nvSpPr>
+          <p:cNvPr id="11" name="TextBox 10"/>
           <p:cNvSpPr txBox="1"/>
           <p:nvPr/>
         </p:nvSpPr>
         <p:spPr>
           <a:xfrm>
-            <a:off x="1846818" y="5880000"/>
-            <a:ext cx="4103942" cy="280000"/>
+            <a:off x="685800" y="6020000"/>
+            <a:ext cx="10789920" cy="240000"/>
           </a:xfrm>
           <a:prstGeom prst="rect">
             <a:avLst/>
@@ -5838,80 +6037,12 @@
           <a:p>
             <a:pPr algn="ctr"/>
             <a:r>
-              <a:rPr sz="1200" b="1">
+              <a:rPr sz="1000" b="0" i="1">
                 <a:solidFill>
                   <a:srgbClr val="555555"/>
                 </a:solidFill>
               </a:rPr>
-              <a:t>Graphe original G</a:t>
-            </a:r>
-          </a:p>
-        </p:txBody>
-      </p:sp>
-      <p:sp>
-        <p:nvSpPr>
-          <p:cNvPr id="15" name="TextBox 14"/>
-          <p:cNvSpPr txBox="1"/>
-          <p:nvPr/>
-        </p:nvSpPr>
-        <p:spPr>
-          <a:xfrm>
-            <a:off x="6210760" y="5880000"/>
-            <a:ext cx="4103942" cy="280000"/>
-          </a:xfrm>
-          <a:prstGeom prst="rect">
-            <a:avLst/>
-          </a:prstGeom>
-          <a:noFill/>
-        </p:spPr>
-        <p:txBody>
-          <a:bodyPr wrap="square">
-            <a:spAutoFit/>
-          </a:bodyPr>
-          <a:lstStyle/>
-          <a:p>
-            <a:pPr algn="ctr"/>
-            <a:r>
-              <a:rPr sz="1200" b="1">
-                <a:solidFill>
-                  <a:srgbClr val="555555"/>
-                </a:solidFill>
-              </a:rPr>
-              <a:t>Graphe résumé G′ (fusion en super-nœuds)</a:t>
-            </a:r>
-          </a:p>
-        </p:txBody>
-      </p:sp>
-      <p:sp>
-        <p:nvSpPr>
-          <p:cNvPr id="16" name="TextBox 15"/>
-          <p:cNvSpPr txBox="1"/>
-          <p:nvPr/>
-        </p:nvSpPr>
-        <p:spPr>
-          <a:xfrm>
-            <a:off x="685800" y="6180000"/>
-            <a:ext cx="10789920" cy="240000"/>
-          </a:xfrm>
-          <a:prstGeom prst="rect">
-            <a:avLst/>
-          </a:prstGeom>
-          <a:noFill/>
-        </p:spPr>
-        <p:txBody>
-          <a:bodyPr wrap="square">
-            <a:spAutoFit/>
-          </a:bodyPr>
-          <a:lstStyle/>
-          <a:p>
-            <a:pPr algn="ctr"/>
-            <a:r>
-              <a:rPr sz="1000" b="0" i="1">
-                <a:solidFill>
-                  <a:srgbClr val="555555"/>
-                </a:solidFill>
-              </a:rPr>
-              <a:t>Captures du tableau de bord interactif — sitaacisse-boop.github.io/EDI</a:t>
+              <a:t>Figure extraite du mémoire — taille des corpus, déséquilibre de genre, répartition des notes</a:t>
             </a:r>
           </a:p>
         </p:txBody>
@@ -6051,7 +6182,7 @@
               </a:defRPr>
             </a:pPr>
             <a:r>
-              <a:t>8</a:t>
+              <a:t>9</a:t>
             </a:r>
           </a:p>
         </p:txBody>
@@ -6347,7 +6478,7 @@
               </a:defRPr>
             </a:pPr>
             <a:r>
-              <a:t>9</a:t>
+              <a:t>10</a:t>
             </a:r>
           </a:p>
         </p:txBody>

</xml_diff>

<commit_message>
Restaure le contenu perdu de la slide Validation — Démonstration en Direct (puces + lien en évidence)
</commit_message>
<xml_diff>
--- a/presentation/AURORA_Soutenance_FR.pptx
+++ b/presentation/AURORA_Soutenance_FR.pptx
@@ -12,13 +12,13 @@
     <p:sldId id="260" r:id="rId6"/>
     <p:sldId id="261" r:id="rId7"/>
     <p:sldId id="268" r:id="rId8"/>
-    <p:sldId id="269" r:id="rId19"/>
-    <p:sldId id="262" r:id="rId9"/>
-    <p:sldId id="263" r:id="rId10"/>
-    <p:sldId id="264" r:id="rId11"/>
-    <p:sldId id="265" r:id="rId12"/>
-    <p:sldId id="266" r:id="rId13"/>
-    <p:sldId id="267" r:id="rId14"/>
+    <p:sldId id="269" r:id="rId9"/>
+    <p:sldId id="262" r:id="rId10"/>
+    <p:sldId id="263" r:id="rId11"/>
+    <p:sldId id="264" r:id="rId12"/>
+    <p:sldId id="265" r:id="rId13"/>
+    <p:sldId id="266" r:id="rId14"/>
+    <p:sldId id="267" r:id="rId15"/>
   </p:sldIdLst>
   <p:sldSz cx="12192000" cy="6858000"/>
   <p:notesSz cx="6858000" cy="9144000"/>
@@ -3474,7 +3474,7 @@
               </a:defRPr>
             </a:pPr>
             <a:r>
-              <a:t>Conclusion — Contribution et Perspectives</a:t>
+              <a:t>Conclusion — Résultats Clés</a:t>
             </a:r>
           </a:p>
         </p:txBody>
@@ -3512,7 +3512,7 @@
               </a:defRPr>
             </a:pPr>
             <a:r>
-              <a:t>•  Intégrer l'EDI directement dans la structure du résumé produit des compromis équité-diversité plus robustes que la correction a posteriori</a:t>
+              <a:t>•  Aucune méthode de référence ne satisfait les trois critères EDI simultanément</a:t>
             </a:r>
           </a:p>
           <a:p>
@@ -3527,7 +3527,7 @@
               </a:defRPr>
             </a:pPr>
             <a:r>
-              <a:t>•  AURORA égale ou dépasse le re-classement sur les corpus plus petits ou côté item, mais pas sur les grandes bases ou les domaines à préférences réciproques</a:t>
+              <a:t>•  Sur MovieLens 100k (k=20), AURORA bat Borda et Condorcet sur ΔE, ILD et inclusion à la fois</a:t>
             </a:r>
           </a:p>
           <a:p>
@@ -3542,7 +3542,7 @@
               </a:defRPr>
             </a:pPr>
             <a:r>
-              <a:t>•  Perspectives :</a:t>
+              <a:t>•  2ᵉ meilleure diversité (hors Average Score, dégénérée) et meilleure représentation sur Rate My Professors ; meilleur ΔE sur OpenAlex</a:t>
             </a:r>
           </a:p>
           <a:p>
@@ -3557,52 +3557,22 @@
               </a:defRPr>
             </a:pPr>
             <a:r>
-              <a:t>      ‒  Attributs sensibles multiples et simultanés</a:t>
+              <a:t>      ‒  Sur libimseti.cz : AURORA ne réduit pas ΔE, comme les méthodes de vote — Average Score et Fair Re-rank y parviennent ; limite structurelle du domaine (genre des deux côtés du graphe), pas un défaut de réglage</a:t>
             </a:r>
           </a:p>
           <a:p>
             <a:pPr>
               <a:spcAft>
-                <a:spcPts val="800"/>
+                <a:spcPts val="1400"/>
               </a:spcAft>
-              <a:defRPr sz="1600">
-                <a:solidFill>
-                  <a:srgbClr val="555555"/>
-                </a:solidFill>
-              </a:defRPr>
-            </a:pPr>
-            <a:r>
-              <a:t>      ‒  Graphes de préférences dynamiques</a:t>
-            </a:r>
-          </a:p>
-          <a:p>
-            <a:pPr>
-              <a:spcAft>
-                <a:spcPts val="800"/>
-              </a:spcAft>
-              <a:defRPr sz="1600">
-                <a:solidFill>
-                  <a:srgbClr val="555555"/>
-                </a:solidFill>
-              </a:defRPr>
-            </a:pPr>
-            <a:r>
-              <a:t>      ‒  Calibration des tolérances ε par analyse de front de Pareto</a:t>
-            </a:r>
-          </a:p>
-          <a:p>
-            <a:pPr>
-              <a:spcAft>
-                <a:spcPts val="800"/>
-              </a:spcAft>
-              <a:defRPr sz="1600">
-                <a:solidFill>
-                  <a:srgbClr val="555555"/>
-                </a:solidFill>
-              </a:defRPr>
-            </a:pPr>
-            <a:r>
-              <a:t>      ‒  Fusion guidée par détection de communautés et impact EDI</a:t>
+              <a:defRPr sz="1900">
+                <a:solidFill>
+                  <a:srgbClr val="1A1A1A"/>
+                </a:solidFill>
+              </a:defRPr>
+            </a:pPr>
+            <a:r>
+              <a:t>•  Sur MovieLens 1M (plus grand), Fair Re-rank domine sur les deux axes — le re-classement a posteriori dispose de plus de marge de manœuvre</a:t>
             </a:r>
           </a:p>
         </p:txBody>
@@ -3681,7 +3651,7 @@
               </a:defRPr>
             </a:pPr>
             <a:r>
-              <a:t>11</a:t>
+              <a:t>10</a:t>
             </a:r>
           </a:p>
         </p:txBody>
@@ -3742,7 +3712,7 @@
               </a:defRPr>
             </a:pPr>
             <a:r>
-              <a:t>Références (1/2)</a:t>
+              <a:t>Conclusion — Contribution et Perspectives</a:t>
             </a:r>
           </a:p>
         </p:txBody>
@@ -3773,14 +3743,14 @@
               <a:spcAft>
                 <a:spcPts val="1400"/>
               </a:spcAft>
-              <a:defRPr sz="1600">
+              <a:defRPr sz="1900">
                 <a:solidFill>
                   <a:srgbClr val="1A1A1A"/>
                 </a:solidFill>
               </a:defRPr>
             </a:pPr>
             <a:r>
-              <a:t>•  Aird et al. — Exploring Social Choice Mechanisms for Recommendation Fairness in SCRUF (2023)</a:t>
+              <a:t>•  Intégrer l'EDI directement dans la structure du résumé produit des compromis équité-diversité plus robustes que la correction a posteriori</a:t>
             </a:r>
           </a:p>
           <a:p>
@@ -3788,14 +3758,14 @@
               <a:spcAft>
                 <a:spcPts val="1400"/>
               </a:spcAft>
-              <a:defRPr sz="1600">
+              <a:defRPr sz="1900">
                 <a:solidFill>
                   <a:srgbClr val="1A1A1A"/>
                 </a:solidFill>
               </a:defRPr>
             </a:pPr>
             <a:r>
-              <a:t>•  Aird et al. — Social Choice for Heterogeneous Fairness in Recommendation, SCRUF-D (2024)</a:t>
+              <a:t>•  AURORA égale ou dépasse le re-classement sur les corpus plus petits ou côté item, mais pas sur les grandes bases ou les domaines à préférences réciproques</a:t>
             </a:r>
           </a:p>
           <a:p>
@@ -3803,59 +3773,74 @@
               <a:spcAft>
                 <a:spcPts val="1400"/>
               </a:spcAft>
-              <a:defRPr sz="1600">
+              <a:defRPr sz="1900">
                 <a:solidFill>
                   <a:srgbClr val="1A1A1A"/>
                 </a:solidFill>
               </a:defRPr>
             </a:pPr>
             <a:r>
-              <a:t>•  Dong et al. — Fairness in Graph Mining: A Survey. IEEE TKDE (2023)</a:t>
+              <a:t>•  Perspectives :</a:t>
             </a:r>
           </a:p>
           <a:p>
             <a:pPr>
               <a:spcAft>
-                <a:spcPts val="1400"/>
+                <a:spcPts val="800"/>
               </a:spcAft>
               <a:defRPr sz="1600">
                 <a:solidFill>
-                  <a:srgbClr val="1A1A1A"/>
-                </a:solidFill>
-              </a:defRPr>
-            </a:pPr>
-            <a:r>
-              <a:t>•  Harper &amp; Konstan — The MovieLens Datasets: History and Context. ACM TiiS (2015)</a:t>
+                  <a:srgbClr val="555555"/>
+                </a:solidFill>
+              </a:defRPr>
+            </a:pPr>
+            <a:r>
+              <a:t>      ‒  Attributs sensibles multiples et simultanés</a:t>
             </a:r>
           </a:p>
           <a:p>
             <a:pPr>
               <a:spcAft>
-                <a:spcPts val="1400"/>
+                <a:spcPts val="800"/>
               </a:spcAft>
               <a:defRPr sz="1600">
                 <a:solidFill>
-                  <a:srgbClr val="1A1A1A"/>
-                </a:solidFill>
-              </a:defRPr>
-            </a:pPr>
-            <a:r>
-              <a:t>•  Kellerhals &amp; Peters — Proportional Fairness in Clustering (2024)</a:t>
+                  <a:srgbClr val="555555"/>
+                </a:solidFill>
+              </a:defRPr>
+            </a:pPr>
+            <a:r>
+              <a:t>      ‒  Graphes de préférences dynamiques</a:t>
             </a:r>
           </a:p>
           <a:p>
             <a:pPr>
               <a:spcAft>
-                <a:spcPts val="1400"/>
+                <a:spcPts val="800"/>
               </a:spcAft>
               <a:defRPr sz="1600">
                 <a:solidFill>
-                  <a:srgbClr val="1A1A1A"/>
-                </a:solidFill>
-              </a:defRPr>
-            </a:pPr>
-            <a:r>
-              <a:t>•  Leonhardt et al. — User Fairness in Recommender Systems (2018)</a:t>
+                  <a:srgbClr val="555555"/>
+                </a:solidFill>
+              </a:defRPr>
+            </a:pPr>
+            <a:r>
+              <a:t>      ‒  Calibration des tolérances ε par analyse de front de Pareto</a:t>
+            </a:r>
+          </a:p>
+          <a:p>
+            <a:pPr>
+              <a:spcAft>
+                <a:spcPts val="800"/>
+              </a:spcAft>
+              <a:defRPr sz="1600">
+                <a:solidFill>
+                  <a:srgbClr val="555555"/>
+                </a:solidFill>
+              </a:defRPr>
+            </a:pPr>
+            <a:r>
+              <a:t>      ‒  Fusion guidée par détection de communautés et impact EDI</a:t>
             </a:r>
           </a:p>
         </p:txBody>
@@ -3934,7 +3919,7 @@
               </a:defRPr>
             </a:pPr>
             <a:r>
-              <a:t>12</a:t>
+              <a:t>11</a:t>
             </a:r>
           </a:p>
         </p:txBody>
@@ -3995,7 +3980,7 @@
               </a:defRPr>
             </a:pPr>
             <a:r>
-              <a:t>Références (2/2)</a:t>
+              <a:t>Références (1/2)</a:t>
             </a:r>
           </a:p>
         </p:txBody>
@@ -4033,7 +4018,7 @@
               </a:defRPr>
             </a:pPr>
             <a:r>
-              <a:t>•  Liu et al. — Graph Summarization Methods and Applications: A Survey (2018)</a:t>
+              <a:t>•  Aird et al. — Exploring Social Choice Mechanisms for Recommendation Fairness in SCRUF (2023)</a:t>
             </a:r>
           </a:p>
           <a:p>
@@ -4048,7 +4033,7 @@
               </a:defRPr>
             </a:pPr>
             <a:r>
-              <a:t>•  Ricci, Rokach &amp; Shapira — Recommender Systems Handbook (2011)</a:t>
+              <a:t>•  Aird et al. — Social Choice for Heterogeneous Fairness in Recommendation, SCRUF-D (2024)</a:t>
             </a:r>
           </a:p>
           <a:p>
@@ -4063,7 +4048,7 @@
               </a:defRPr>
             </a:pPr>
             <a:r>
-              <a:t>•  Roy, Schieber &amp; Talmon — Fairness in Preference Queries. VLDB (2024)</a:t>
+              <a:t>•  Dong et al. — Fairness in Graph Mining: A Survey. IEEE TKDE (2023)</a:t>
             </a:r>
           </a:p>
           <a:p>
@@ -4078,7 +4063,7 @@
               </a:defRPr>
             </a:pPr>
             <a:r>
-              <a:t>•  Shabani et al. — Graph Summarization with GNNs: A Survey (2024)</a:t>
+              <a:t>•  Harper &amp; Konstan — The MovieLens Datasets: History and Context. ACM TiiS (2015)</a:t>
             </a:r>
           </a:p>
           <a:p>
@@ -4093,7 +4078,7 @@
               </a:defRPr>
             </a:pPr>
             <a:r>
-              <a:t>•  Yao &amp; Huang — New Fairness Metrics for Recommendation (2017)</a:t>
+              <a:t>•  Kellerhals &amp; Peters — Proportional Fairness in Clustering (2024)</a:t>
             </a:r>
           </a:p>
           <a:p>
@@ -4108,7 +4093,7 @@
               </a:defRPr>
             </a:pPr>
             <a:r>
-              <a:t>•  Zhao et al. — Fairness and Diversity in Recommender Systems: A Survey (2024)</a:t>
+              <a:t>•  Leonhardt et al. — User Fairness in Recommender Systems (2018)</a:t>
             </a:r>
           </a:p>
         </p:txBody>
@@ -4187,7 +4172,7 @@
               </a:defRPr>
             </a:pPr>
             <a:r>
-              <a:t>13</a:t>
+              <a:t>12</a:t>
             </a:r>
           </a:p>
         </p:txBody>
@@ -4225,8 +4210,8 @@
         </p:nvSpPr>
         <p:spPr>
           <a:xfrm>
-            <a:off x="914400" y="2560320"/>
-            <a:ext cx="10332720" cy="1097280"/>
+            <a:off x="548640" y="320040"/>
+            <a:ext cx="11064240" cy="914400"/>
           </a:xfrm>
           <a:prstGeom prst="rect">
             <a:avLst/>
@@ -4234,20 +4219,21 @@
           <a:noFill/>
         </p:spPr>
         <p:txBody>
-          <a:bodyPr wrap="none">
+          <a:bodyPr wrap="square">
             <a:spAutoFit/>
           </a:bodyPr>
           <a:lstStyle/>
           <a:p>
-            <a:pPr algn="ctr">
-              <a:defRPr sz="4800" b="1">
+            <a:pPr>
+              <a:defRPr sz="3000" b="1">
                 <a:solidFill>
                   <a:srgbClr val="63003C"/>
                 </a:solidFill>
-              </a:defRPr>
-            </a:pPr>
-            <a:r>
-              <a:t>Merci</a:t>
+                <a:latin typeface="Georgia"/>
+              </a:defRPr>
+            </a:pPr>
+            <a:r>
+              <a:t>Références (2/2)</a:t>
             </a:r>
           </a:p>
         </p:txBody>
@@ -4260,8 +4246,8 @@
         </p:nvSpPr>
         <p:spPr>
           <a:xfrm>
-            <a:off x="914400" y="3566160"/>
-            <a:ext cx="10332720" cy="731520"/>
+            <a:off x="685800" y="1371600"/>
+            <a:ext cx="10789920" cy="4846320"/>
           </a:xfrm>
           <a:prstGeom prst="rect">
             <a:avLst/>
@@ -4269,20 +4255,98 @@
           <a:noFill/>
         </p:spPr>
         <p:txBody>
-          <a:bodyPr wrap="none">
+          <a:bodyPr wrap="square">
             <a:spAutoFit/>
           </a:bodyPr>
           <a:lstStyle/>
           <a:p>
-            <a:pPr algn="ctr">
-              <a:defRPr sz="2400">
-                <a:solidFill>
-                  <a:srgbClr val="555555"/>
-                </a:solidFill>
-              </a:defRPr>
-            </a:pPr>
-            <a:r>
-              <a:t>Questions ?</a:t>
+            <a:pPr>
+              <a:spcAft>
+                <a:spcPts val="1400"/>
+              </a:spcAft>
+              <a:defRPr sz="1600">
+                <a:solidFill>
+                  <a:srgbClr val="1A1A1A"/>
+                </a:solidFill>
+              </a:defRPr>
+            </a:pPr>
+            <a:r>
+              <a:t>•  Liu et al. — Graph Summarization Methods and Applications: A Survey (2018)</a:t>
+            </a:r>
+          </a:p>
+          <a:p>
+            <a:pPr>
+              <a:spcAft>
+                <a:spcPts val="1400"/>
+              </a:spcAft>
+              <a:defRPr sz="1600">
+                <a:solidFill>
+                  <a:srgbClr val="1A1A1A"/>
+                </a:solidFill>
+              </a:defRPr>
+            </a:pPr>
+            <a:r>
+              <a:t>•  Ricci, Rokach &amp; Shapira — Recommender Systems Handbook (2011)</a:t>
+            </a:r>
+          </a:p>
+          <a:p>
+            <a:pPr>
+              <a:spcAft>
+                <a:spcPts val="1400"/>
+              </a:spcAft>
+              <a:defRPr sz="1600">
+                <a:solidFill>
+                  <a:srgbClr val="1A1A1A"/>
+                </a:solidFill>
+              </a:defRPr>
+            </a:pPr>
+            <a:r>
+              <a:t>•  Roy, Schieber &amp; Talmon — Fairness in Preference Queries. VLDB (2024)</a:t>
+            </a:r>
+          </a:p>
+          <a:p>
+            <a:pPr>
+              <a:spcAft>
+                <a:spcPts val="1400"/>
+              </a:spcAft>
+              <a:defRPr sz="1600">
+                <a:solidFill>
+                  <a:srgbClr val="1A1A1A"/>
+                </a:solidFill>
+              </a:defRPr>
+            </a:pPr>
+            <a:r>
+              <a:t>•  Shabani et al. — Graph Summarization with GNNs: A Survey (2024)</a:t>
+            </a:r>
+          </a:p>
+          <a:p>
+            <a:pPr>
+              <a:spcAft>
+                <a:spcPts val="1400"/>
+              </a:spcAft>
+              <a:defRPr sz="1600">
+                <a:solidFill>
+                  <a:srgbClr val="1A1A1A"/>
+                </a:solidFill>
+              </a:defRPr>
+            </a:pPr>
+            <a:r>
+              <a:t>•  Yao &amp; Huang — New Fairness Metrics for Recommendation (2017)</a:t>
+            </a:r>
+          </a:p>
+          <a:p>
+            <a:pPr>
+              <a:spcAft>
+                <a:spcPts val="1400"/>
+              </a:spcAft>
+              <a:defRPr sz="1600">
+                <a:solidFill>
+                  <a:srgbClr val="1A1A1A"/>
+                </a:solidFill>
+              </a:defRPr>
+            </a:pPr>
+            <a:r>
+              <a:t>•  Zhao et al. — Fairness and Diversity in Recommender Systems: A Survey (2024)</a:t>
             </a:r>
           </a:p>
         </p:txBody>
@@ -4361,7 +4425,7 @@
               </a:defRPr>
             </a:pPr>
             <a:r>
-              <a:t>14</a:t>
+              <a:t>13</a:t>
             </a:r>
           </a:p>
         </p:txBody>
@@ -4375,7 +4439,7 @@
 </file>
 
 <file path=ppt/slides/slide14.xml><?xml version="1.0" encoding="utf-8"?>
-<p:sld xmlns:a="http://schemas.openxmlformats.org/drawingml/2006/main" xmlns:p="http://schemas.openxmlformats.org/presentationml/2006/main" xmlns:r="http://schemas.openxmlformats.org/officeDocument/2006/relationships">
+<p:sld xmlns:a="http://schemas.openxmlformats.org/drawingml/2006/main" xmlns:r="http://schemas.openxmlformats.org/officeDocument/2006/relationships" xmlns:p="http://schemas.openxmlformats.org/presentationml/2006/main">
   <p:cSld>
     <p:spTree>
       <p:nvGrpSpPr>
@@ -4383,7 +4447,14 @@
         <p:cNvGrpSpPr/>
         <p:nvPr/>
       </p:nvGrpSpPr>
-      <p:grpSpPr/>
+      <p:grpSpPr>
+        <a:xfrm>
+          <a:off x="0" y="0"/>
+          <a:ext cx="0" cy="0"/>
+          <a:chOff x="0" y="0"/>
+          <a:chExt cx="0" cy="0"/>
+        </a:xfrm>
+      </p:grpSpPr>
       <p:sp>
         <p:nvSpPr>
           <p:cNvPr id="2" name="TextBox 1"/>
@@ -4392,8 +4463,8 @@
         </p:nvSpPr>
         <p:spPr>
           <a:xfrm>
-            <a:off x="548640" y="320040"/>
-            <a:ext cx="11064240" cy="914400"/>
+            <a:off x="914400" y="2560320"/>
+            <a:ext cx="10332720" cy="1097280"/>
           </a:xfrm>
           <a:prstGeom prst="rect">
             <a:avLst/>
@@ -4401,81 +4472,34 @@
           <a:noFill/>
         </p:spPr>
         <p:txBody>
-          <a:bodyPr wrap="square">
+          <a:bodyPr wrap="none">
             <a:spAutoFit/>
           </a:bodyPr>
           <a:lstStyle/>
           <a:p>
-            <a:r>
-              <a:rPr sz="3000" b="1">
+            <a:pPr algn="ctr">
+              <a:defRPr sz="4800" b="1">
                 <a:solidFill>
                   <a:srgbClr val="63003C"/>
                 </a:solidFill>
-                <a:latin typeface="Georgia"/>
-              </a:rPr>
-              <a:t>Le graphe biparti G et son résumé G′</a:t>
-            </a:r>
-          </a:p>
-        </p:txBody>
-      </p:sp>
-      <p:pic>
-        <p:nvPicPr>
-          <p:cNvPr id="3" name="Picture 2" descr="image.png"/>
-          <p:cNvPicPr>
-            <a:picLocks noChangeAspect="1"/>
-          </p:cNvPicPr>
-          <p:nvPr/>
-        </p:nvPicPr>
-        <p:blipFill>
-          <a:blip r:embed="rId2"/>
-          <a:stretch>
-            <a:fillRect/>
-          </a:stretch>
-        </p:blipFill>
-        <p:spPr>
-          <a:xfrm>
-            <a:off x="685800" y="1500000"/>
-            <a:ext cx="5244960" cy="3195073"/>
-          </a:xfrm>
-          <a:prstGeom prst="rect">
-            <a:avLst/>
-          </a:prstGeom>
-        </p:spPr>
-      </p:pic>
-      <p:pic>
-        <p:nvPicPr>
-          <p:cNvPr id="4" name="Picture 3" descr="image.png"/>
-          <p:cNvPicPr>
-            <a:picLocks noChangeAspect="1"/>
-          </p:cNvPicPr>
-          <p:nvPr/>
-        </p:nvPicPr>
-        <p:blipFill>
-          <a:blip r:embed="rId3"/>
-          <a:stretch>
-            <a:fillRect/>
-          </a:stretch>
-        </p:blipFill>
-        <p:spPr>
-          <a:xfrm>
-            <a:off x="6230760" y="1500000"/>
-            <a:ext cx="5244960" cy="3195073"/>
-          </a:xfrm>
-          <a:prstGeom prst="rect">
-            <a:avLst/>
-          </a:prstGeom>
-        </p:spPr>
-      </p:pic>
-      <p:sp>
-        <p:nvSpPr>
-          <p:cNvPr id="5" name="TextBox 4"/>
+              </a:defRPr>
+            </a:pPr>
+            <a:r>
+              <a:t>Merci</a:t>
+            </a:r>
+          </a:p>
+        </p:txBody>
+      </p:sp>
+      <p:sp>
+        <p:nvSpPr>
+          <p:cNvPr id="3" name="TextBox 2"/>
           <p:cNvSpPr txBox="1"/>
           <p:nvPr/>
         </p:nvSpPr>
         <p:spPr>
           <a:xfrm>
-            <a:off x="685800" y="4745073"/>
-            <a:ext cx="5244960" cy="280000"/>
+            <a:off x="914400" y="3566160"/>
+            <a:ext cx="10332720" cy="731520"/>
           </a:xfrm>
           <a:prstGeom prst="rect">
             <a:avLst/>
@@ -4483,94 +4507,27 @@
           <a:noFill/>
         </p:spPr>
         <p:txBody>
-          <a:bodyPr wrap="square">
+          <a:bodyPr wrap="none">
             <a:spAutoFit/>
           </a:bodyPr>
           <a:lstStyle/>
           <a:p>
-            <a:pPr algn="ctr"/>
-            <a:r>
-              <a:rPr sz="1200" b="1">
+            <a:pPr algn="ctr">
+              <a:defRPr sz="2400">
                 <a:solidFill>
                   <a:srgbClr val="555555"/>
                 </a:solidFill>
-              </a:rPr>
-              <a:t>Graphe original G</a:t>
-            </a:r>
-          </a:p>
-        </p:txBody>
-      </p:sp>
-      <p:sp>
-        <p:nvSpPr>
-          <p:cNvPr id="6" name="TextBox 5"/>
-          <p:cNvSpPr txBox="1"/>
-          <p:nvPr/>
-        </p:nvSpPr>
-        <p:spPr>
-          <a:xfrm>
-            <a:off x="6230760" y="4745073"/>
-            <a:ext cx="5244960" cy="280000"/>
-          </a:xfrm>
-          <a:prstGeom prst="rect">
-            <a:avLst/>
-          </a:prstGeom>
-          <a:noFill/>
-        </p:spPr>
-        <p:txBody>
-          <a:bodyPr wrap="square">
-            <a:spAutoFit/>
-          </a:bodyPr>
-          <a:lstStyle/>
-          <a:p>
-            <a:pPr algn="ctr"/>
-            <a:r>
-              <a:rPr sz="1200" b="1">
-                <a:solidFill>
-                  <a:srgbClr val="555555"/>
-                </a:solidFill>
-              </a:rPr>
-              <a:t>Graphe résumé G′ (fusion en super-nœuds)</a:t>
-            </a:r>
-          </a:p>
-        </p:txBody>
-      </p:sp>
-      <p:sp>
-        <p:nvSpPr>
-          <p:cNvPr id="7" name="TextBox 6"/>
-          <p:cNvSpPr txBox="1"/>
-          <p:nvPr/>
-        </p:nvSpPr>
-        <p:spPr>
-          <a:xfrm>
-            <a:off x="685800" y="5045073"/>
-            <a:ext cx="10789920" cy="240000"/>
-          </a:xfrm>
-          <a:prstGeom prst="rect">
-            <a:avLst/>
-          </a:prstGeom>
-          <a:noFill/>
-        </p:spPr>
-        <p:txBody>
-          <a:bodyPr wrap="square">
-            <a:spAutoFit/>
-          </a:bodyPr>
-          <a:lstStyle/>
-          <a:p>
-            <a:pPr algn="ctr"/>
-            <a:r>
-              <a:rPr sz="1000" b="0" i="1">
-                <a:solidFill>
-                  <a:srgbClr val="555555"/>
-                </a:solidFill>
-              </a:rPr>
-              <a:t>Captures du tableau de bord interactif — sitaacisse-boop.github.io/EDI</a:t>
-            </a:r>
-          </a:p>
-        </p:txBody>
-      </p:sp>
-      <p:sp>
-        <p:nvSpPr>
-          <p:cNvPr id="8" name="Rectangle 7"/>
+              </a:defRPr>
+            </a:pPr>
+            <a:r>
+              <a:t>Questions ?</a:t>
+            </a:r>
+          </a:p>
+        </p:txBody>
+      </p:sp>
+      <p:sp>
+        <p:nvSpPr>
+          <p:cNvPr id="4" name="Rectangle 3"/>
           <p:cNvSpPr/>
           <p:nvPr/>
         </p:nvSpPr>
@@ -4588,7 +4545,6 @@
           <a:ln>
             <a:noFill/>
           </a:ln>
-          <a:effectLst/>
         </p:spPr>
         <p:style>
           <a:lnRef idx="1">
@@ -4609,12 +4565,13 @@
           <a:lstStyle/>
           <a:p>
             <a:pPr algn="ctr"/>
-          </a:p>
-        </p:txBody>
-      </p:sp>
-      <p:sp>
-        <p:nvSpPr>
-          <p:cNvPr id="9" name="TextBox 8"/>
+            <a:endParaRPr/>
+          </a:p>
+        </p:txBody>
+      </p:sp>
+      <p:sp>
+        <p:nvSpPr>
+          <p:cNvPr id="5" name="TextBox 4"/>
           <p:cNvSpPr txBox="1"/>
           <p:nvPr/>
         </p:nvSpPr>
@@ -4634,14 +4591,15 @@
           </a:bodyPr>
           <a:lstStyle/>
           <a:p>
-            <a:pPr algn="r"/>
-            <a:r>
-              <a:rPr sz="1100">
+            <a:pPr algn="r">
+              <a:defRPr sz="1100">
                 <a:solidFill>
                   <a:srgbClr val="555555"/>
                 </a:solidFill>
-              </a:rPr>
-              <a:t>8</a:t>
+              </a:defRPr>
+            </a:pPr>
+            <a:r>
+              <a:t>14</a:t>
             </a:r>
           </a:p>
         </p:txBody>
@@ -5998,7 +5956,7 @@
           <p:nvPr/>
         </p:nvPicPr>
         <p:blipFill>
-          <a:blip r:embed="rId5"/>
+          <a:blip r:embed="rId2"/>
           <a:stretch>
             <a:fillRect/>
           </a:stretch>
@@ -6094,23 +6052,171 @@
           </a:bodyPr>
           <a:lstStyle/>
           <a:p>
-            <a:pPr>
-              <a:defRPr sz="3000" b="1">
+            <a:r>
+              <a:rPr sz="3000" b="1">
                 <a:solidFill>
                   <a:srgbClr val="63003C"/>
                 </a:solidFill>
                 <a:latin typeface="Georgia"/>
-              </a:defRPr>
-            </a:pPr>
-            <a:r>
-              <a:t>Validation — Démonstration en Direct</a:t>
-            </a:r>
-          </a:p>
-        </p:txBody>
-      </p:sp>
-      <p:sp>
-        <p:nvSpPr>
-          <p:cNvPr id="5" name="Rectangle 4"/>
+              </a:rPr>
+              <a:t>Le graphe biparti G et son résumé G′</a:t>
+            </a:r>
+          </a:p>
+        </p:txBody>
+      </p:sp>
+      <p:pic>
+        <p:nvPicPr>
+          <p:cNvPr id="3" name="Picture 2" descr="image.png"/>
+          <p:cNvPicPr>
+            <a:picLocks noChangeAspect="1"/>
+          </p:cNvPicPr>
+          <p:nvPr/>
+        </p:nvPicPr>
+        <p:blipFill>
+          <a:blip r:embed="rId2"/>
+          <a:stretch>
+            <a:fillRect/>
+          </a:stretch>
+        </p:blipFill>
+        <p:spPr>
+          <a:xfrm>
+            <a:off x="685800" y="1500000"/>
+            <a:ext cx="5244960" cy="3195073"/>
+          </a:xfrm>
+          <a:prstGeom prst="rect">
+            <a:avLst/>
+          </a:prstGeom>
+        </p:spPr>
+      </p:pic>
+      <p:pic>
+        <p:nvPicPr>
+          <p:cNvPr id="4" name="Picture 3" descr="image.png"/>
+          <p:cNvPicPr>
+            <a:picLocks noChangeAspect="1"/>
+          </p:cNvPicPr>
+          <p:nvPr/>
+        </p:nvPicPr>
+        <p:blipFill>
+          <a:blip r:embed="rId3"/>
+          <a:stretch>
+            <a:fillRect/>
+          </a:stretch>
+        </p:blipFill>
+        <p:spPr>
+          <a:xfrm>
+            <a:off x="6230760" y="1500000"/>
+            <a:ext cx="5244960" cy="3195073"/>
+          </a:xfrm>
+          <a:prstGeom prst="rect">
+            <a:avLst/>
+          </a:prstGeom>
+        </p:spPr>
+      </p:pic>
+      <p:sp>
+        <p:nvSpPr>
+          <p:cNvPr id="5" name="TextBox 4"/>
+          <p:cNvSpPr txBox="1"/>
+          <p:nvPr/>
+        </p:nvSpPr>
+        <p:spPr>
+          <a:xfrm>
+            <a:off x="685800" y="4745073"/>
+            <a:ext cx="5244960" cy="280000"/>
+          </a:xfrm>
+          <a:prstGeom prst="rect">
+            <a:avLst/>
+          </a:prstGeom>
+          <a:noFill/>
+        </p:spPr>
+        <p:txBody>
+          <a:bodyPr wrap="square">
+            <a:spAutoFit/>
+          </a:bodyPr>
+          <a:lstStyle/>
+          <a:p>
+            <a:pPr algn="ctr"/>
+            <a:r>
+              <a:rPr sz="1200" b="1">
+                <a:solidFill>
+                  <a:srgbClr val="555555"/>
+                </a:solidFill>
+              </a:rPr>
+              <a:t>Graphe original G</a:t>
+            </a:r>
+          </a:p>
+        </p:txBody>
+      </p:sp>
+      <p:sp>
+        <p:nvSpPr>
+          <p:cNvPr id="6" name="TextBox 5"/>
+          <p:cNvSpPr txBox="1"/>
+          <p:nvPr/>
+        </p:nvSpPr>
+        <p:spPr>
+          <a:xfrm>
+            <a:off x="6230760" y="4745073"/>
+            <a:ext cx="5244960" cy="280000"/>
+          </a:xfrm>
+          <a:prstGeom prst="rect">
+            <a:avLst/>
+          </a:prstGeom>
+          <a:noFill/>
+        </p:spPr>
+        <p:txBody>
+          <a:bodyPr wrap="square">
+            <a:spAutoFit/>
+          </a:bodyPr>
+          <a:lstStyle/>
+          <a:p>
+            <a:pPr algn="ctr"/>
+            <a:r>
+              <a:rPr sz="1200" b="1">
+                <a:solidFill>
+                  <a:srgbClr val="555555"/>
+                </a:solidFill>
+              </a:rPr>
+              <a:t>Graphe résumé G′ (fusion en super-nœuds)</a:t>
+            </a:r>
+          </a:p>
+        </p:txBody>
+      </p:sp>
+      <p:sp>
+        <p:nvSpPr>
+          <p:cNvPr id="7" name="TextBox 6"/>
+          <p:cNvSpPr txBox="1"/>
+          <p:nvPr/>
+        </p:nvSpPr>
+        <p:spPr>
+          <a:xfrm>
+            <a:off x="685800" y="5045073"/>
+            <a:ext cx="10789920" cy="240000"/>
+          </a:xfrm>
+          <a:prstGeom prst="rect">
+            <a:avLst/>
+          </a:prstGeom>
+          <a:noFill/>
+        </p:spPr>
+        <p:txBody>
+          <a:bodyPr wrap="square">
+            <a:spAutoFit/>
+          </a:bodyPr>
+          <a:lstStyle/>
+          <a:p>
+            <a:pPr algn="ctr"/>
+            <a:r>
+              <a:rPr sz="1000" b="0" i="1">
+                <a:solidFill>
+                  <a:srgbClr val="555555"/>
+                </a:solidFill>
+              </a:rPr>
+              <a:t>Captures du tableau de bord interactif — sitaacisse-boop.github.io/EDI</a:t>
+            </a:r>
+          </a:p>
+        </p:txBody>
+      </p:sp>
+      <p:sp>
+        <p:nvSpPr>
+          <p:cNvPr id="8" name="Rectangle 7"/>
           <p:cNvSpPr/>
           <p:nvPr/>
         </p:nvSpPr>
@@ -6128,6 +6234,7 @@
           <a:ln>
             <a:noFill/>
           </a:ln>
+          <a:effectLst/>
         </p:spPr>
         <p:style>
           <a:lnRef idx="1">
@@ -6154,7 +6261,7 @@
       </p:sp>
       <p:sp>
         <p:nvSpPr>
-          <p:cNvPr id="6" name="TextBox 5"/>
+          <p:cNvPr id="9" name="TextBox 8"/>
           <p:cNvSpPr txBox="1"/>
           <p:nvPr/>
         </p:nvSpPr>
@@ -6174,73 +6281,14 @@
           </a:bodyPr>
           <a:lstStyle/>
           <a:p>
-            <a:pPr algn="r">
-              <a:defRPr sz="1100">
+            <a:pPr algn="r"/>
+            <a:r>
+              <a:rPr sz="1100">
                 <a:solidFill>
                   <a:srgbClr val="555555"/>
                 </a:solidFill>
-              </a:defRPr>
-            </a:pPr>
-            <a:r>
-              <a:t>9</a:t>
-            </a:r>
-          </a:p>
-        </p:txBody>
-      </p:sp>
-      <p:sp>
-        <p:nvSpPr>
-          <p:cNvPr id="7" name="TextBox 6"/>
-          <p:cNvSpPr txBox="1"/>
-          <p:nvPr/>
-        </p:nvSpPr>
-        <p:spPr>
-          <a:xfrm>
-            <a:off x="685800" y="1350000"/>
-            <a:ext cx="10789920" cy="805349"/>
-          </a:xfrm>
-          <a:prstGeom prst="rect">
-            <a:avLst/>
-          </a:prstGeom>
-          <a:noFill/>
-        </p:spPr>
-        <p:txBody>
-          <a:bodyPr wrap="square">
-            <a:spAutoFit/>
-          </a:bodyPr>
-          <a:lstStyle/>
-          <a:p>
-            <a:pPr>
-              <a:spcAft>
-                <a:spcPts val="1400"/>
-              </a:spcAft>
-            </a:pPr>
-            <a:r>
-              <a:rPr sz="2200">
-                <a:solidFill>
-                  <a:srgbClr val="1A1A1A"/>
-                </a:solidFill>
               </a:rPr>
-              <a:t>•  5 jeux de données, 4 domaines : MovieLens 100k et 1M, libimseti.cz, Rate My Professors, OpenAlex</a:t>
-            </a:r>
-            <a:endParaRPr lang="fr-FR" sz="1900" dirty="0">
-              <a:solidFill>
-                <a:srgbClr val="1A1A1A"/>
-              </a:solidFill>
-            </a:endParaRPr>
-          </a:p>
-          <a:p>
-            <a:pPr>
-              <a:spcAft>
-                <a:spcPts val="1400"/>
-              </a:spcAft>
-            </a:pPr>
-            <a:r>
-              <a:rPr sz="2200">
-                <a:solidFill>
-                  <a:srgbClr val="1A1A1A"/>
-                </a:solidFill>
-              </a:rPr>
-              <a:t>•  Bascule vers le tableau de bord interactif : sitaacisse-boop.github.io/EDI</a:t>
+              <a:t>8</a:t>
             </a:r>
           </a:p>
         </p:txBody>
@@ -6301,112 +6349,14 @@
               </a:defRPr>
             </a:pPr>
             <a:r>
-              <a:t>Conclusion — Résultats Clés</a:t>
-            </a:r>
-          </a:p>
-        </p:txBody>
-      </p:sp>
-      <p:sp>
-        <p:nvSpPr>
-          <p:cNvPr id="3" name="TextBox 2"/>
-          <p:cNvSpPr txBox="1"/>
-          <p:nvPr/>
-        </p:nvSpPr>
-        <p:spPr>
-          <a:xfrm>
-            <a:off x="685800" y="1371600"/>
-            <a:ext cx="10789920" cy="4846320"/>
-          </a:xfrm>
-          <a:prstGeom prst="rect">
-            <a:avLst/>
-          </a:prstGeom>
-          <a:noFill/>
-        </p:spPr>
-        <p:txBody>
-          <a:bodyPr wrap="square">
-            <a:spAutoFit/>
-          </a:bodyPr>
-          <a:lstStyle/>
-          <a:p>
-            <a:pPr>
-              <a:spcAft>
-                <a:spcPts val="1400"/>
-              </a:spcAft>
-              <a:defRPr sz="1900">
-                <a:solidFill>
-                  <a:srgbClr val="1A1A1A"/>
-                </a:solidFill>
-              </a:defRPr>
-            </a:pPr>
-            <a:r>
-              <a:t>•  Aucune méthode de référence ne satisfait les trois critères EDI simultanément</a:t>
-            </a:r>
-          </a:p>
-          <a:p>
-            <a:pPr>
-              <a:spcAft>
-                <a:spcPts val="1400"/>
-              </a:spcAft>
-              <a:defRPr sz="1900">
-                <a:solidFill>
-                  <a:srgbClr val="1A1A1A"/>
-                </a:solidFill>
-              </a:defRPr>
-            </a:pPr>
-            <a:r>
-              <a:t>•  Sur MovieLens 100k (k=20), AURORA bat Borda et Condorcet sur ΔE, ILD et inclusion à la fois</a:t>
-            </a:r>
-          </a:p>
-          <a:p>
-            <a:pPr>
-              <a:spcAft>
-                <a:spcPts val="1400"/>
-              </a:spcAft>
-              <a:defRPr sz="1900">
-                <a:solidFill>
-                  <a:srgbClr val="1A1A1A"/>
-                </a:solidFill>
-              </a:defRPr>
-            </a:pPr>
-            <a:r>
-              <a:t>•  2ᵉ meilleure diversité (hors Average Score, dégénérée) et meilleure représentation sur Rate My Professors ; meilleur ΔE sur OpenAlex</a:t>
-            </a:r>
-          </a:p>
-          <a:p>
-            <a:pPr>
-              <a:spcAft>
-                <a:spcPts val="800"/>
-              </a:spcAft>
-              <a:defRPr sz="1600">
-                <a:solidFill>
-                  <a:srgbClr val="555555"/>
-                </a:solidFill>
-              </a:defRPr>
-            </a:pPr>
-            <a:r>
-              <a:t>      ‒  Sur libimseti.cz : AURORA ne réduit pas ΔE, comme les méthodes de vote — Average Score et Fair Re-rank y parviennent ; limite structurelle du domaine (genre des deux côtés du graphe), pas un défaut de réglage</a:t>
-            </a:r>
-          </a:p>
-          <a:p>
-            <a:pPr>
-              <a:spcAft>
-                <a:spcPts val="1400"/>
-              </a:spcAft>
-              <a:defRPr sz="1900">
-                <a:solidFill>
-                  <a:srgbClr val="1A1A1A"/>
-                </a:solidFill>
-              </a:defRPr>
-            </a:pPr>
-            <a:r>
-              <a:t>•  Sur MovieLens 1M (plus grand), Fair Re-rank domine sur les deux axes — le re-classement a posteriori dispose de plus de marge de manœuvre</a:t>
-            </a:r>
-          </a:p>
-        </p:txBody>
-      </p:sp>
-      <p:sp>
-        <p:nvSpPr>
-          <p:cNvPr id="4" name="Rectangle 3"/>
+              <a:t>Validation — Démonstration en Direct</a:t>
+            </a:r>
+          </a:p>
+        </p:txBody>
+      </p:sp>
+      <p:sp>
+        <p:nvSpPr>
+          <p:cNvPr id="5" name="Rectangle 4"/>
           <p:cNvSpPr/>
           <p:nvPr/>
         </p:nvSpPr>
@@ -6450,7 +6400,7 @@
       </p:sp>
       <p:sp>
         <p:nvSpPr>
-          <p:cNvPr id="5" name="TextBox 4"/>
+          <p:cNvPr id="6" name="TextBox 5"/>
           <p:cNvSpPr txBox="1"/>
           <p:nvPr/>
         </p:nvSpPr>
@@ -6478,7 +6428,94 @@
               </a:defRPr>
             </a:pPr>
             <a:r>
-              <a:t>10</a:t>
+              <a:t>9</a:t>
+            </a:r>
+          </a:p>
+        </p:txBody>
+      </p:sp>
+      <p:sp>
+        <p:nvSpPr>
+          <p:cNvPr id="7" name="TextBox 6"/>
+          <p:cNvSpPr txBox="1"/>
+          <p:nvPr/>
+        </p:nvSpPr>
+        <p:spPr>
+          <a:xfrm>
+            <a:off x="685800" y="1463040"/>
+            <a:ext cx="10789920" cy="1400000"/>
+          </a:xfrm>
+          <a:prstGeom prst="rect">
+            <a:avLst/>
+          </a:prstGeom>
+          <a:noFill/>
+        </p:spPr>
+        <p:txBody>
+          <a:bodyPr wrap="square">
+            <a:spAutoFit/>
+          </a:bodyPr>
+          <a:lstStyle/>
+          <a:p>
+            <a:pPr>
+              <a:spcAft>
+                <a:spcPts val="1400"/>
+              </a:spcAft>
+            </a:pPr>
+            <a:r>
+              <a:rPr sz="2200">
+                <a:solidFill>
+                  <a:srgbClr val="1A1A1A"/>
+                </a:solidFill>
+              </a:rPr>
+              <a:t>•  5 jeux de données, 4 domaines : MovieLens 100k et 1M, libimseti.cz, Rate My Professors, OpenAlex</a:t>
+            </a:r>
+          </a:p>
+          <a:p>
+            <a:pPr>
+              <a:spcAft>
+                <a:spcPts val="1400"/>
+              </a:spcAft>
+            </a:pPr>
+            <a:r>
+              <a:rPr sz="2200">
+                <a:solidFill>
+                  <a:srgbClr val="1A1A1A"/>
+                </a:solidFill>
+              </a:rPr>
+              <a:t>•  Bascule vers le tableau de bord interactif :</a:t>
+            </a:r>
+          </a:p>
+        </p:txBody>
+      </p:sp>
+      <p:sp>
+        <p:nvSpPr>
+          <p:cNvPr id="8" name="TextBox 7"/>
+          <p:cNvSpPr txBox="1"/>
+          <p:nvPr/>
+        </p:nvSpPr>
+        <p:spPr>
+          <a:xfrm>
+            <a:off x="1188720" y="3291840"/>
+            <a:ext cx="9784080" cy="914400"/>
+          </a:xfrm>
+          <a:prstGeom prst="rect">
+            <a:avLst/>
+          </a:prstGeom>
+          <a:noFill/>
+        </p:spPr>
+        <p:txBody>
+          <a:bodyPr wrap="none">
+            <a:spAutoFit/>
+          </a:bodyPr>
+          <a:lstStyle/>
+          <a:p>
+            <a:pPr algn="ctr"/>
+            <a:r>
+              <a:rPr sz="3000" b="1">
+                <a:solidFill>
+                  <a:srgbClr val="63003C"/>
+                </a:solidFill>
+              </a:rPr>
+              <a:t>sitaacisse-boop.github.io/EDI</a:t>
             </a:r>
           </a:p>
         </p:txBody>

</xml_diff>

<commit_message>
Applique les corrections de Malek sur le PowerPoint
- Slide 1 : "Prof. Zoubida Kedad" (cohérent avec "Prof. Malek Mouhoub")
- Slide 2 (Plan) : puces numérotées 1-5, comme demandé
- Slide 3 : précise "(Saskatchewan, Canada)"
- Slide 4 : "jamais la préservation de l'équité" -> "...de l'EDI"
- Slide 10 : éclate la puce dense (RMP+OpenAlex+libimseti sur 2 lignes)
  en une puce par jeu de données, plus lisible à l'oral
</commit_message>
<xml_diff>
--- a/presentation/AURORA_Soutenance_FR.pptx
+++ b/presentation/AURORA_Soutenance_FR.pptx
@@ -3378,7 +3378,7 @@
               </a:defRPr>
             </a:pPr>
             <a:r>
-              <a:t>Zoubida Kedad</a:t>
+              <a:t>Prof. Zoubida Kedad</a:t>
             </a:r>
           </a:p>
         </p:txBody>
@@ -3512,6 +3512,11 @@
               </a:defRPr>
             </a:pPr>
             <a:r>
+              <a:rPr sz="1900">
+                <a:solidFill>
+                  <a:srgbClr val="1A1A1A"/>
+                </a:solidFill>
+              </a:rPr>
               <a:t>•  Aucune méthode de référence ne satisfait les trois critères EDI simultanément</a:t>
             </a:r>
           </a:p>
@@ -3520,14 +3525,14 @@
               <a:spcAft>
                 <a:spcPts val="1400"/>
               </a:spcAft>
-              <a:defRPr sz="1900">
+            </a:pPr>
+            <a:r>
+              <a:rPr sz="1900">
                 <a:solidFill>
                   <a:srgbClr val="1A1A1A"/>
                 </a:solidFill>
-              </a:defRPr>
-            </a:pPr>
-            <a:r>
-              <a:t>•  Sur MovieLens 100k (k=20), AURORA bat Borda et Condorcet sur ΔE, ILD et inclusion à la fois</a:t>
+              </a:rPr>
+              <a:t>•  MovieLens 100k (k=20) : AURORA bat Borda et Condorcet sur ΔE, ILD et inclusion à la fois</a:t>
             </a:r>
           </a:p>
           <a:p>
@@ -3535,14 +3540,29 @@
               <a:spcAft>
                 <a:spcPts val="1400"/>
               </a:spcAft>
-              <a:defRPr sz="1900">
+            </a:pPr>
+            <a:r>
+              <a:rPr sz="1900">
                 <a:solidFill>
                   <a:srgbClr val="1A1A1A"/>
                 </a:solidFill>
-              </a:defRPr>
-            </a:pPr>
-            <a:r>
-              <a:t>•  2ᵉ meilleure diversité (hors Average Score, dégénérée) et meilleure représentation sur Rate My Professors ; meilleur ΔE sur OpenAlex</a:t>
+              </a:rPr>
+              <a:t>•  Rate My Professors : 2ᵉ meilleure diversité (hors Average Score, dégénérée) et meilleure représentation</a:t>
+            </a:r>
+          </a:p>
+          <a:p>
+            <a:pPr>
+              <a:spcAft>
+                <a:spcPts val="1400"/>
+              </a:spcAft>
+            </a:pPr>
+            <a:r>
+              <a:rPr sz="1900">
+                <a:solidFill>
+                  <a:srgbClr val="1A1A1A"/>
+                </a:solidFill>
+              </a:rPr>
+              <a:t>•  OpenAlex : meilleur ΔE de toutes les méthodes</a:t>
             </a:r>
           </a:p>
           <a:p>
@@ -3550,14 +3570,14 @@
               <a:spcAft>
                 <a:spcPts val="800"/>
               </a:spcAft>
-              <a:defRPr sz="1600">
+            </a:pPr>
+            <a:r>
+              <a:rPr sz="1600">
                 <a:solidFill>
                   <a:srgbClr val="555555"/>
                 </a:solidFill>
-              </a:defRPr>
-            </a:pPr>
-            <a:r>
-              <a:t>      ‒  Sur libimseti.cz : AURORA ne réduit pas ΔE, comme les méthodes de vote — Average Score et Fair Re-rank y parviennent ; limite structurelle du domaine (genre des deux côtés du graphe), pas un défaut de réglage</a:t>
+              </a:rPr>
+              <a:t>      ‒  libimseti.cz : AURORA ne réduit pas ΔE, comme les méthodes de vote (seules Average Score et Fair Re-rank y parviennent) — limite structurelle du domaine (genre des deux côtés du graphe), pas un défaut de réglage</a:t>
             </a:r>
           </a:p>
           <a:p>
@@ -3565,14 +3585,14 @@
               <a:spcAft>
                 <a:spcPts val="1400"/>
               </a:spcAft>
-              <a:defRPr sz="1900">
+            </a:pPr>
+            <a:r>
+              <a:rPr sz="1900">
                 <a:solidFill>
                   <a:srgbClr val="1A1A1A"/>
                 </a:solidFill>
-              </a:defRPr>
-            </a:pPr>
-            <a:r>
-              <a:t>•  Sur MovieLens 1M (plus grand), Fair Re-rank domine sur les deux axes — le re-classement a posteriori dispose de plus de marge de manœuvre</a:t>
+              </a:rPr>
+              <a:t>•  MovieLens 1M (plus grand) : Fair Re-rank domine sur les deux axes — le re-classement a posteriori dispose de plus de marge de manœuvre</a:t>
             </a:r>
           </a:p>
         </p:txBody>
@@ -4698,7 +4718,7 @@
               </a:defRPr>
             </a:pPr>
             <a:r>
-              <a:t>•  Contexte et objectif du stage</a:t>
+              <a:t>1.  Contexte et objectif du stage</a:t>
             </a:r>
           </a:p>
           <a:p>
@@ -4713,7 +4733,7 @@
               </a:defRPr>
             </a:pPr>
             <a:r>
-              <a:t>•  État de l'art — la lacune de recherche</a:t>
+              <a:t>2.  État de l'art — la lacune de recherche</a:t>
             </a:r>
           </a:p>
           <a:p>
@@ -4728,7 +4748,7 @@
               </a:defRPr>
             </a:pPr>
             <a:r>
-              <a:t>•  Approche proposée — AURORA</a:t>
+              <a:t>3.  Approche proposée — AURORA</a:t>
             </a:r>
           </a:p>
           <a:p>
@@ -4743,7 +4763,7 @@
               </a:defRPr>
             </a:pPr>
             <a:r>
-              <a:t>•  Validation — démonstration en direct</a:t>
+              <a:t>4.  Validation — démonstration en direct</a:t>
             </a:r>
           </a:p>
           <a:p>
@@ -4758,7 +4778,7 @@
               </a:defRPr>
             </a:pPr>
             <a:r>
-              <a:t>•  Conclusion et perspectives</a:t>
+              <a:t>5.  Conclusion et perspectives</a:t>
             </a:r>
           </a:p>
         </p:txBody>
@@ -4936,7 +4956,7 @@
               </a:defRPr>
             </a:pPr>
             <a:r>
-              <a:t>•  Stage de recherche au Department of Computer Science, University of Regina (Saskatchewan)</a:t>
+              <a:t>•  Stage de recherche au Department of Computer Science, University of Regina (Saskatchewan, Canada)</a:t>
             </a:r>
           </a:p>
           <a:p>
@@ -5219,7 +5239,7 @@
               </a:defRPr>
             </a:pPr>
             <a:r>
-              <a:t>•  Le résumé de graphe a toujours optimisé la fidélité structurelle — jamais la préservation de l'équité</a:t>
+              <a:t>•  Le résumé de graphe a toujours optimisé la fidélité structurelle — jamais la préservation de l'EDI</a:t>
             </a:r>
           </a:p>
           <a:p>
@@ -6494,8 +6514,8 @@
         </p:nvSpPr>
         <p:spPr>
           <a:xfrm>
-            <a:off x="1188720" y="3291840"/>
-            <a:ext cx="9784080" cy="914400"/>
+            <a:off x="3640380" y="3291840"/>
+            <a:ext cx="4880760" cy="553998"/>
           </a:xfrm>
           <a:prstGeom prst="rect">
             <a:avLst/>
@@ -6510,7 +6530,7 @@
           <a:p>
             <a:pPr algn="ctr"/>
             <a:r>
-              <a:rPr sz="3000" b="1">
+              <a:rPr sz="3000" b="1" dirty="0">
                 <a:solidFill>
                   <a:srgbClr val="63003C"/>
                 </a:solidFill>
@@ -6518,6 +6538,12 @@
               </a:rPr>
               <a:t>sitaacisse-boop.github.io/EDI</a:t>
             </a:r>
+            <a:endParaRPr sz="3000" b="1" dirty="0">
+              <a:solidFill>
+                <a:srgbClr val="63003C"/>
+              </a:solidFill>
+              <a:hlinkClick r:id="rId2"/>
+            </a:endParaRPr>
           </a:p>
         </p:txBody>
       </p:sp>

</xml_diff>

<commit_message>
Numérote les titres de slides pour qu'ils correspondent au Plan
Chaque titre de section porte maintenant le numéro du point du Plan
correspondant (1. Contexte..., 2. Problématique, 3. Approche (x2),
4. Jeux de données / Graphe / Validation (x3), 5. Conclusion (x2)) —
répond aussi à l'annotation de Malek sur la slide 3 suggérant cet écho.
</commit_message>
<xml_diff>
--- a/presentation/AURORA_Soutenance_FR.pptx
+++ b/presentation/AURORA_Soutenance_FR.pptx
@@ -3474,7 +3474,7 @@
               </a:defRPr>
             </a:pPr>
             <a:r>
-              <a:t>Conclusion — Résultats Clés</a:t>
+              <a:t>5. Conclusion — Résultats Clés</a:t>
             </a:r>
           </a:p>
         </p:txBody>
@@ -3732,7 +3732,7 @@
               </a:defRPr>
             </a:pPr>
             <a:r>
-              <a:t>Conclusion — Contribution et Perspectives</a:t>
+              <a:t>5. Conclusion — Contribution et Perspectives</a:t>
             </a:r>
           </a:p>
         </p:txBody>
@@ -4918,7 +4918,7 @@
               </a:defRPr>
             </a:pPr>
             <a:r>
-              <a:t>Contexte et Objectif du Stage</a:t>
+              <a:t>1. Contexte et Objectif du Stage</a:t>
             </a:r>
           </a:p>
         </p:txBody>
@@ -5156,7 +5156,7 @@
               </a:defRPr>
             </a:pPr>
             <a:r>
-              <a:t>Problématique</a:t>
+              <a:t>2. Problématique</a:t>
             </a:r>
           </a:p>
         </p:txBody>
@@ -5394,7 +5394,7 @@
               </a:defRPr>
             </a:pPr>
             <a:r>
-              <a:t>Approche — Graphe et Métriques EDI</a:t>
+              <a:t>3. Approche — Graphe et Métriques EDI</a:t>
             </a:r>
           </a:p>
         </p:txBody>
@@ -5632,7 +5632,7 @@
               </a:defRPr>
             </a:pPr>
             <a:r>
-              <a:t>Approche — AURORA : Coarsening sous Contraintes EDI</a:t>
+              <a:t>3. Approche — AURORA : Coarsening sous Contraintes EDI</a:t>
             </a:r>
           </a:p>
         </p:txBody>
@@ -5883,7 +5883,7 @@
                 </a:solidFill>
                 <a:latin typeface="Georgia"/>
               </a:rPr>
-              <a:t>Jeux de données</a:t>
+              <a:t>4. Jeux de données</a:t>
             </a:r>
           </a:p>
         </p:txBody>
@@ -6079,7 +6079,7 @@
                 </a:solidFill>
                 <a:latin typeface="Georgia"/>
               </a:rPr>
-              <a:t>Le graphe biparti G et son résumé G′</a:t>
+              <a:t>4. Le graphe biparti G et son résumé G′</a:t>
             </a:r>
           </a:p>
         </p:txBody>
@@ -6369,7 +6369,7 @@
               </a:defRPr>
             </a:pPr>
             <a:r>
-              <a:t>Validation — Démonstration en Direct</a:t>
+              <a:t>4. Validation — Démonstration en Direct</a:t>
             </a:r>
           </a:p>
         </p:txBody>

</xml_diff>

<commit_message>
Ajoute le tableau de synthèse à la slide Conclusion — Résultats Clés
Remplace les 5 puces détaillées (redondantes avec le tableau) par 1 seule
puce d'ouverture + la capture fraîche du tableau "En un coup d'œil — qui
gagne quoi par corpus" du site — plus rapide à lire pour le jury qu'une
liste de puces, et pas montré ailleurs pendant la démo live.
</commit_message>
<xml_diff>
--- a/presentation/AURORA_Soutenance_FR.pptx
+++ b/presentation/AURORA_Soutenance_FR.pptx
@@ -3520,81 +3520,6 @@
               <a:t>•  Aucune méthode de référence ne satisfait les trois critères EDI simultanément</a:t>
             </a:r>
           </a:p>
-          <a:p>
-            <a:pPr>
-              <a:spcAft>
-                <a:spcPts val="1400"/>
-              </a:spcAft>
-            </a:pPr>
-            <a:r>
-              <a:rPr sz="1900">
-                <a:solidFill>
-                  <a:srgbClr val="1A1A1A"/>
-                </a:solidFill>
-              </a:rPr>
-              <a:t>•  MovieLens 100k (k=20) : AURORA bat Borda et Condorcet sur ΔE, ILD et inclusion à la fois</a:t>
-            </a:r>
-          </a:p>
-          <a:p>
-            <a:pPr>
-              <a:spcAft>
-                <a:spcPts val="1400"/>
-              </a:spcAft>
-            </a:pPr>
-            <a:r>
-              <a:rPr sz="1900">
-                <a:solidFill>
-                  <a:srgbClr val="1A1A1A"/>
-                </a:solidFill>
-              </a:rPr>
-              <a:t>•  Rate My Professors : 2ᵉ meilleure diversité (hors Average Score, dégénérée) et meilleure représentation</a:t>
-            </a:r>
-          </a:p>
-          <a:p>
-            <a:pPr>
-              <a:spcAft>
-                <a:spcPts val="1400"/>
-              </a:spcAft>
-            </a:pPr>
-            <a:r>
-              <a:rPr sz="1900">
-                <a:solidFill>
-                  <a:srgbClr val="1A1A1A"/>
-                </a:solidFill>
-              </a:rPr>
-              <a:t>•  OpenAlex : meilleur ΔE de toutes les méthodes</a:t>
-            </a:r>
-          </a:p>
-          <a:p>
-            <a:pPr>
-              <a:spcAft>
-                <a:spcPts val="800"/>
-              </a:spcAft>
-            </a:pPr>
-            <a:r>
-              <a:rPr sz="1600">
-                <a:solidFill>
-                  <a:srgbClr val="555555"/>
-                </a:solidFill>
-              </a:rPr>
-              <a:t>      ‒  libimseti.cz : AURORA ne réduit pas ΔE, comme les méthodes de vote (seules Average Score et Fair Re-rank y parviennent) — limite structurelle du domaine (genre des deux côtés du graphe), pas un défaut de réglage</a:t>
-            </a:r>
-          </a:p>
-          <a:p>
-            <a:pPr>
-              <a:spcAft>
-                <a:spcPts val="1400"/>
-              </a:spcAft>
-            </a:pPr>
-            <a:r>
-              <a:rPr sz="1900">
-                <a:solidFill>
-                  <a:srgbClr val="1A1A1A"/>
-                </a:solidFill>
-              </a:rPr>
-              <a:t>•  MovieLens 1M (plus grand) : Fair Re-rank domine sur les deux axes — le re-classement a posteriori dispose de plus de marge de manœuvre</a:t>
-            </a:r>
-          </a:p>
         </p:txBody>
       </p:sp>
       <p:sp>
@@ -3676,6 +3601,30 @@
           </a:p>
         </p:txBody>
       </p:sp>
+      <p:pic>
+        <p:nvPicPr>
+          <p:cNvPr id="6" name="Picture 5" descr="shot_conclusion_table_fresh.png"/>
+          <p:cNvPicPr>
+            <a:picLocks noChangeAspect="1"/>
+          </p:cNvPicPr>
+          <p:nvPr/>
+        </p:nvPicPr>
+        <p:blipFill>
+          <a:blip r:embed="rId2"/>
+          <a:stretch>
+            <a:fillRect/>
+          </a:stretch>
+        </p:blipFill>
+        <p:spPr>
+          <a:xfrm>
+            <a:off x="685800" y="2000000"/>
+            <a:ext cx="10789920" cy="4016771"/>
+          </a:xfrm>
+          <a:prstGeom prst="rect">
+            <a:avLst/>
+          </a:prstGeom>
+        </p:spPr>
+      </p:pic>
     </p:spTree>
   </p:cSld>
   <p:clrMapOvr>

</xml_diff>

<commit_message>
Ajoute des notes de présentateur sur SCRUF-D et la significativité statistique
Notes invisibles pour le jury (mode présentateur uniquement), prêtes en cas
de question — pas d'impact sur le contenu visible ni le temps de présentation.
</commit_message>
<xml_diff>
--- a/presentation/AURORA_Soutenance_FR.pptx
+++ b/presentation/AURORA_Soutenance_FR.pptx
@@ -4,6 +4,9 @@
   <p:sldMasterIdLst>
     <p:sldMasterId id="2147483648" r:id="rId1"/>
   </p:sldMasterIdLst>
+  <p:notesMasterIdLst>
+    <p:notesMasterId r:id="rId16"/>
+  </p:notesMasterIdLst>
   <p:sldIdLst>
     <p:sldId id="256" r:id="rId2"/>
     <p:sldId id="257" r:id="rId3"/>
@@ -136,6 +139,1245 @@
 </p:presentation>
 </file>
 
+<file path=ppt/notesMasters/notesMaster1.xml><?xml version="1.0" encoding="utf-8"?>
+<p:notesMaster xmlns:a="http://schemas.openxmlformats.org/drawingml/2006/main" xmlns:r="http://schemas.openxmlformats.org/officeDocument/2006/relationships" xmlns:p="http://schemas.openxmlformats.org/presentationml/2006/main">
+  <p:cSld>
+    <p:bg>
+      <p:bgRef idx="1001">
+        <a:schemeClr val="bg1"/>
+      </p:bgRef>
+    </p:bg>
+    <p:spTree>
+      <p:nvGrpSpPr>
+        <p:cNvPr id="1" name=""/>
+        <p:cNvGrpSpPr/>
+        <p:nvPr/>
+      </p:nvGrpSpPr>
+      <p:grpSpPr>
+        <a:xfrm>
+          <a:off x="0" y="0"/>
+          <a:ext cx="0" cy="0"/>
+          <a:chOff x="0" y="0"/>
+          <a:chExt cx="0" cy="0"/>
+        </a:xfrm>
+      </p:grpSpPr>
+      <p:sp>
+        <p:nvSpPr>
+          <p:cNvPr id="2" name="Espace réservé de l'en-tête 1"/>
+          <p:cNvSpPr>
+            <a:spLocks noGrp="1"/>
+          </p:cNvSpPr>
+          <p:nvPr>
+            <p:ph type="hdr" sz="quarter"/>
+          </p:nvPr>
+        </p:nvSpPr>
+        <p:spPr>
+          <a:xfrm>
+            <a:off x="0" y="0"/>
+            <a:ext cx="2971800" cy="458788"/>
+          </a:xfrm>
+          <a:prstGeom prst="rect">
+            <a:avLst/>
+          </a:prstGeom>
+        </p:spPr>
+        <p:txBody>
+          <a:bodyPr vert="horz" lIns="91440" tIns="45720" rIns="91440" bIns="45720" rtlCol="0"/>
+          <a:lstStyle>
+            <a:lvl1pPr algn="l">
+              <a:defRPr sz="1200"/>
+            </a:lvl1pPr>
+          </a:lstStyle>
+          <a:p>
+            <a:endParaRPr lang="fr-FR"/>
+          </a:p>
+        </p:txBody>
+      </p:sp>
+      <p:sp>
+        <p:nvSpPr>
+          <p:cNvPr id="3" name="Espace réservé de la date 2"/>
+          <p:cNvSpPr>
+            <a:spLocks noGrp="1"/>
+          </p:cNvSpPr>
+          <p:nvPr>
+            <p:ph type="dt" idx="1"/>
+          </p:nvPr>
+        </p:nvSpPr>
+        <p:spPr>
+          <a:xfrm>
+            <a:off x="3884613" y="0"/>
+            <a:ext cx="2971800" cy="458788"/>
+          </a:xfrm>
+          <a:prstGeom prst="rect">
+            <a:avLst/>
+          </a:prstGeom>
+        </p:spPr>
+        <p:txBody>
+          <a:bodyPr vert="horz" lIns="91440" tIns="45720" rIns="91440" bIns="45720" rtlCol="0"/>
+          <a:lstStyle>
+            <a:lvl1pPr algn="r">
+              <a:defRPr sz="1200"/>
+            </a:lvl1pPr>
+          </a:lstStyle>
+          <a:p>
+            <a:fld id="{BB4E32DD-2BBF-E54C-AA90-1FF8494E5F3B}" type="datetimeFigureOut">
+              <a:rPr lang="fr-FR" smtClean="0"/>
+              <a:t>27/08/2026</a:t>
+            </a:fld>
+            <a:endParaRPr lang="fr-FR"/>
+          </a:p>
+        </p:txBody>
+      </p:sp>
+      <p:sp>
+        <p:nvSpPr>
+          <p:cNvPr id="4" name="Espace réservé de l'image des diapositives 3"/>
+          <p:cNvSpPr>
+            <a:spLocks noGrp="1" noRot="1" noChangeAspect="1"/>
+          </p:cNvSpPr>
+          <p:nvPr>
+            <p:ph type="sldImg" idx="2"/>
+          </p:nvPr>
+        </p:nvSpPr>
+        <p:spPr>
+          <a:xfrm>
+            <a:off x="685800" y="1143000"/>
+            <a:ext cx="5486400" cy="3086100"/>
+          </a:xfrm>
+          <a:prstGeom prst="rect">
+            <a:avLst/>
+          </a:prstGeom>
+          <a:noFill/>
+          <a:ln w="12700">
+            <a:solidFill>
+              <a:prstClr val="black"/>
+            </a:solidFill>
+          </a:ln>
+        </p:spPr>
+        <p:txBody>
+          <a:bodyPr vert="horz" lIns="91440" tIns="45720" rIns="91440" bIns="45720" rtlCol="0" anchor="ctr"/>
+          <a:lstStyle/>
+          <a:p>
+            <a:endParaRPr lang="fr-FR"/>
+          </a:p>
+        </p:txBody>
+      </p:sp>
+      <p:sp>
+        <p:nvSpPr>
+          <p:cNvPr id="5" name="Espace réservé des notes 4"/>
+          <p:cNvSpPr>
+            <a:spLocks noGrp="1"/>
+          </p:cNvSpPr>
+          <p:nvPr>
+            <p:ph type="body" sz="quarter" idx="3"/>
+          </p:nvPr>
+        </p:nvSpPr>
+        <p:spPr>
+          <a:xfrm>
+            <a:off x="685800" y="4400550"/>
+            <a:ext cx="5486400" cy="3600450"/>
+          </a:xfrm>
+          <a:prstGeom prst="rect">
+            <a:avLst/>
+          </a:prstGeom>
+        </p:spPr>
+        <p:txBody>
+          <a:bodyPr vert="horz" lIns="91440" tIns="45720" rIns="91440" bIns="45720" rtlCol="0"/>
+          <a:lstStyle/>
+          <a:p>
+            <a:pPr lvl="0"/>
+            <a:r>
+              <a:rPr lang="fr-FR"/>
+              <a:t>Cliquez pour modifier les styles du texte du masque</a:t>
+            </a:r>
+          </a:p>
+          <a:p>
+            <a:pPr lvl="1"/>
+            <a:r>
+              <a:rPr lang="fr-FR"/>
+              <a:t>Deuxième niveau</a:t>
+            </a:r>
+          </a:p>
+          <a:p>
+            <a:pPr lvl="2"/>
+            <a:r>
+              <a:rPr lang="fr-FR"/>
+              <a:t>Troisième niveau</a:t>
+            </a:r>
+          </a:p>
+          <a:p>
+            <a:pPr lvl="3"/>
+            <a:r>
+              <a:rPr lang="fr-FR"/>
+              <a:t>Quatrième niveau</a:t>
+            </a:r>
+          </a:p>
+          <a:p>
+            <a:pPr lvl="4"/>
+            <a:r>
+              <a:rPr lang="fr-FR"/>
+              <a:t>Cinquième niveau</a:t>
+            </a:r>
+          </a:p>
+        </p:txBody>
+      </p:sp>
+      <p:sp>
+        <p:nvSpPr>
+          <p:cNvPr id="6" name="Espace réservé du pied de page 5"/>
+          <p:cNvSpPr>
+            <a:spLocks noGrp="1"/>
+          </p:cNvSpPr>
+          <p:nvPr>
+            <p:ph type="ftr" sz="quarter" idx="4"/>
+          </p:nvPr>
+        </p:nvSpPr>
+        <p:spPr>
+          <a:xfrm>
+            <a:off x="0" y="8685213"/>
+            <a:ext cx="2971800" cy="458787"/>
+          </a:xfrm>
+          <a:prstGeom prst="rect">
+            <a:avLst/>
+          </a:prstGeom>
+        </p:spPr>
+        <p:txBody>
+          <a:bodyPr vert="horz" lIns="91440" tIns="45720" rIns="91440" bIns="45720" rtlCol="0" anchor="b"/>
+          <a:lstStyle>
+            <a:lvl1pPr algn="l">
+              <a:defRPr sz="1200"/>
+            </a:lvl1pPr>
+          </a:lstStyle>
+          <a:p>
+            <a:endParaRPr lang="fr-FR"/>
+          </a:p>
+        </p:txBody>
+      </p:sp>
+      <p:sp>
+        <p:nvSpPr>
+          <p:cNvPr id="7" name="Espace réservé du numéro de diapositive 6"/>
+          <p:cNvSpPr>
+            <a:spLocks noGrp="1"/>
+          </p:cNvSpPr>
+          <p:nvPr>
+            <p:ph type="sldNum" sz="quarter" idx="5"/>
+          </p:nvPr>
+        </p:nvSpPr>
+        <p:spPr>
+          <a:xfrm>
+            <a:off x="3884613" y="8685213"/>
+            <a:ext cx="2971800" cy="458787"/>
+          </a:xfrm>
+          <a:prstGeom prst="rect">
+            <a:avLst/>
+          </a:prstGeom>
+        </p:spPr>
+        <p:txBody>
+          <a:bodyPr vert="horz" lIns="91440" tIns="45720" rIns="91440" bIns="45720" rtlCol="0" anchor="b"/>
+          <a:lstStyle>
+            <a:lvl1pPr algn="r">
+              <a:defRPr sz="1200"/>
+            </a:lvl1pPr>
+          </a:lstStyle>
+          <a:p>
+            <a:fld id="{EC9DD9CB-6CB9-4048-8E70-4A785DF481B5}" type="slidenum">
+              <a:rPr lang="fr-FR" smtClean="0"/>
+              <a:t>‹N°›</a:t>
+            </a:fld>
+            <a:endParaRPr lang="fr-FR"/>
+          </a:p>
+        </p:txBody>
+      </p:sp>
+    </p:spTree>
+    <p:extLst>
+      <p:ext uri="{BB962C8B-B14F-4D97-AF65-F5344CB8AC3E}">
+        <p14:creationId xmlns:p14="http://schemas.microsoft.com/office/powerpoint/2010/main" val="3780932642"/>
+      </p:ext>
+    </p:extLst>
+  </p:cSld>
+  <p:clrMap bg1="lt1" tx1="dk1" bg2="lt2" tx2="dk2" accent1="accent1" accent2="accent2" accent3="accent3" accent4="accent4" accent5="accent5" accent6="accent6" hlink="hlink" folHlink="folHlink"/>
+  <p:notesStyle>
+    <a:lvl1pPr marL="0" algn="l" defTabSz="914400" rtl="0" eaLnBrk="1" latinLnBrk="0" hangingPunct="1">
+      <a:defRPr sz="1200" kern="1200">
+        <a:solidFill>
+          <a:schemeClr val="tx1"/>
+        </a:solidFill>
+        <a:latin typeface="+mn-lt"/>
+        <a:ea typeface="+mn-ea"/>
+        <a:cs typeface="+mn-cs"/>
+      </a:defRPr>
+    </a:lvl1pPr>
+    <a:lvl2pPr marL="457200" algn="l" defTabSz="914400" rtl="0" eaLnBrk="1" latinLnBrk="0" hangingPunct="1">
+      <a:defRPr sz="1200" kern="1200">
+        <a:solidFill>
+          <a:schemeClr val="tx1"/>
+        </a:solidFill>
+        <a:latin typeface="+mn-lt"/>
+        <a:ea typeface="+mn-ea"/>
+        <a:cs typeface="+mn-cs"/>
+      </a:defRPr>
+    </a:lvl2pPr>
+    <a:lvl3pPr marL="914400" algn="l" defTabSz="914400" rtl="0" eaLnBrk="1" latinLnBrk="0" hangingPunct="1">
+      <a:defRPr sz="1200" kern="1200">
+        <a:solidFill>
+          <a:schemeClr val="tx1"/>
+        </a:solidFill>
+        <a:latin typeface="+mn-lt"/>
+        <a:ea typeface="+mn-ea"/>
+        <a:cs typeface="+mn-cs"/>
+      </a:defRPr>
+    </a:lvl3pPr>
+    <a:lvl4pPr marL="1371600" algn="l" defTabSz="914400" rtl="0" eaLnBrk="1" latinLnBrk="0" hangingPunct="1">
+      <a:defRPr sz="1200" kern="1200">
+        <a:solidFill>
+          <a:schemeClr val="tx1"/>
+        </a:solidFill>
+        <a:latin typeface="+mn-lt"/>
+        <a:ea typeface="+mn-ea"/>
+        <a:cs typeface="+mn-cs"/>
+      </a:defRPr>
+    </a:lvl4pPr>
+    <a:lvl5pPr marL="1828800" algn="l" defTabSz="914400" rtl="0" eaLnBrk="1" latinLnBrk="0" hangingPunct="1">
+      <a:defRPr sz="1200" kern="1200">
+        <a:solidFill>
+          <a:schemeClr val="tx1"/>
+        </a:solidFill>
+        <a:latin typeface="+mn-lt"/>
+        <a:ea typeface="+mn-ea"/>
+        <a:cs typeface="+mn-cs"/>
+      </a:defRPr>
+    </a:lvl5pPr>
+    <a:lvl6pPr marL="2286000" algn="l" defTabSz="914400" rtl="0" eaLnBrk="1" latinLnBrk="0" hangingPunct="1">
+      <a:defRPr sz="1200" kern="1200">
+        <a:solidFill>
+          <a:schemeClr val="tx1"/>
+        </a:solidFill>
+        <a:latin typeface="+mn-lt"/>
+        <a:ea typeface="+mn-ea"/>
+        <a:cs typeface="+mn-cs"/>
+      </a:defRPr>
+    </a:lvl6pPr>
+    <a:lvl7pPr marL="2743200" algn="l" defTabSz="914400" rtl="0" eaLnBrk="1" latinLnBrk="0" hangingPunct="1">
+      <a:defRPr sz="1200" kern="1200">
+        <a:solidFill>
+          <a:schemeClr val="tx1"/>
+        </a:solidFill>
+        <a:latin typeface="+mn-lt"/>
+        <a:ea typeface="+mn-ea"/>
+        <a:cs typeface="+mn-cs"/>
+      </a:defRPr>
+    </a:lvl7pPr>
+    <a:lvl8pPr marL="3200400" algn="l" defTabSz="914400" rtl="0" eaLnBrk="1" latinLnBrk="0" hangingPunct="1">
+      <a:defRPr sz="1200" kern="1200">
+        <a:solidFill>
+          <a:schemeClr val="tx1"/>
+        </a:solidFill>
+        <a:latin typeface="+mn-lt"/>
+        <a:ea typeface="+mn-ea"/>
+        <a:cs typeface="+mn-cs"/>
+      </a:defRPr>
+    </a:lvl8pPr>
+    <a:lvl9pPr marL="3657600" algn="l" defTabSz="914400" rtl="0" eaLnBrk="1" latinLnBrk="0" hangingPunct="1">
+      <a:defRPr sz="1200" kern="1200">
+        <a:solidFill>
+          <a:schemeClr val="tx1"/>
+        </a:solidFill>
+        <a:latin typeface="+mn-lt"/>
+        <a:ea typeface="+mn-ea"/>
+        <a:cs typeface="+mn-cs"/>
+      </a:defRPr>
+    </a:lvl9pPr>
+  </p:notesStyle>
+</p:notesMaster>
+</file>
+
+<file path=ppt/notesSlides/notesSlide1.xml><?xml version="1.0" encoding="utf-8"?>
+<p:notes xmlns:a="http://schemas.openxmlformats.org/drawingml/2006/main" xmlns:r="http://schemas.openxmlformats.org/officeDocument/2006/relationships" xmlns:p="http://schemas.openxmlformats.org/presentationml/2006/main">
+  <p:cSld>
+    <p:spTree>
+      <p:nvGrpSpPr>
+        <p:cNvPr id="1" name=""/>
+        <p:cNvGrpSpPr/>
+        <p:nvPr/>
+      </p:nvGrpSpPr>
+      <p:grpSpPr>
+        <a:xfrm>
+          <a:off x="0" y="0"/>
+          <a:ext cx="0" cy="0"/>
+          <a:chOff x="0" y="0"/>
+          <a:chExt cx="0" cy="0"/>
+        </a:xfrm>
+      </p:grpSpPr>
+      <p:sp>
+        <p:nvSpPr>
+          <p:cNvPr id="2" name="Slide Image Placeholder 1"/>
+          <p:cNvSpPr>
+            <a:spLocks noGrp="1" noRot="1" noChangeAspect="1"/>
+          </p:cNvSpPr>
+          <p:nvPr>
+            <p:ph type="sldImg" idx="2"/>
+          </p:nvPr>
+        </p:nvSpPr>
+        <p:spPr/>
+      </p:sp>
+      <p:sp>
+        <p:nvSpPr>
+          <p:cNvPr id="3" name="Notes Placeholder 2"/>
+          <p:cNvSpPr>
+            <a:spLocks noGrp="1"/>
+          </p:cNvSpPr>
+          <p:nvPr>
+            <p:ph type="body" sz="quarter" idx="3"/>
+          </p:nvPr>
+        </p:nvSpPr>
+        <p:spPr/>
+        <p:txBody>
+          <a:bodyPr/>
+          <a:lstStyle/>
+          <a:p>
+            <a:r>
+              <a:rPr dirty="0"/>
+              <a:t>SCRUF-D (Aird et al. 2023/2024) est le travail </a:t>
+            </a:r>
+            <a:r>
+              <a:rPr dirty="0" err="1"/>
+              <a:t>conceptuellement</a:t>
+            </a:r>
+            <a:r>
+              <a:rPr dirty="0"/>
+              <a:t> le plus </a:t>
+            </a:r>
+            <a:r>
+              <a:rPr dirty="0" err="1"/>
+              <a:t>proche</a:t>
+            </a:r>
+            <a:r>
+              <a:rPr dirty="0"/>
+              <a:t> : </a:t>
+            </a:r>
+            <a:r>
+              <a:rPr dirty="0" err="1"/>
+              <a:t>chaque</a:t>
+            </a:r>
+            <a:r>
+              <a:rPr dirty="0"/>
+              <a:t> preoccupation </a:t>
+            </a:r>
+            <a:r>
+              <a:rPr dirty="0" err="1"/>
+              <a:t>d'equite</a:t>
+            </a:r>
+            <a:r>
+              <a:rPr dirty="0"/>
+              <a:t> y est un agent qui vote (Borda/Copeland/Ranked Pairs) aux cotes du </a:t>
+            </a:r>
+            <a:r>
+              <a:rPr dirty="0" err="1"/>
+              <a:t>recommandeur</a:t>
+            </a:r>
+            <a:r>
+              <a:rPr dirty="0"/>
+              <a:t>, au moment de </a:t>
+            </a:r>
+            <a:r>
+              <a:rPr dirty="0" err="1"/>
+              <a:t>produire</a:t>
+            </a:r>
+            <a:r>
+              <a:rPr dirty="0"/>
+              <a:t> le </a:t>
+            </a:r>
+            <a:r>
+              <a:rPr dirty="0" err="1"/>
+              <a:t>classement</a:t>
+            </a:r>
+            <a:r>
+              <a:rPr dirty="0"/>
+              <a:t> final -- un post-</a:t>
+            </a:r>
+            <a:r>
+              <a:rPr dirty="0" err="1"/>
+              <a:t>traitement</a:t>
+            </a:r>
+            <a:r>
+              <a:rPr dirty="0"/>
+              <a:t>, </a:t>
+            </a:r>
+            <a:r>
+              <a:rPr dirty="0" err="1"/>
+              <a:t>alors</a:t>
+            </a:r>
+            <a:r>
+              <a:rPr dirty="0"/>
+              <a:t> </a:t>
+            </a:r>
+            <a:r>
+              <a:rPr dirty="0" err="1"/>
+              <a:t>qu'AURORA</a:t>
+            </a:r>
+            <a:r>
+              <a:rPr dirty="0"/>
+              <a:t> agit </a:t>
+            </a:r>
+            <a:r>
+              <a:rPr dirty="0" err="1"/>
+              <a:t>en</a:t>
+            </a:r>
+            <a:r>
+              <a:rPr dirty="0"/>
+              <a:t> </a:t>
+            </a:r>
+            <a:r>
+              <a:rPr dirty="0" err="1"/>
+              <a:t>amont</a:t>
+            </a:r>
+            <a:r>
+              <a:rPr dirty="0"/>
+              <a:t> sur la structure du </a:t>
+            </a:r>
+            <a:r>
+              <a:rPr dirty="0" err="1"/>
+              <a:t>graphe</a:t>
+            </a:r>
+            <a:r>
+              <a:rPr dirty="0"/>
+              <a:t> resume. Non </a:t>
+            </a:r>
+            <a:r>
+              <a:rPr dirty="0" err="1"/>
+              <a:t>implemente</a:t>
+            </a:r>
+            <a:r>
+              <a:rPr dirty="0"/>
+              <a:t> </a:t>
+            </a:r>
+            <a:r>
+              <a:rPr dirty="0" err="1"/>
+              <a:t>comme</a:t>
+            </a:r>
+            <a:r>
+              <a:rPr dirty="0"/>
+              <a:t> </a:t>
+            </a:r>
+            <a:r>
+              <a:rPr dirty="0" err="1"/>
+              <a:t>referentiel</a:t>
+            </a:r>
+            <a:r>
+              <a:rPr dirty="0"/>
+              <a:t> experimental car il </a:t>
+            </a:r>
+            <a:r>
+              <a:rPr dirty="0" err="1"/>
+              <a:t>exige</a:t>
+            </a:r>
+            <a:r>
+              <a:rPr dirty="0"/>
+              <a:t> </a:t>
+            </a:r>
+            <a:r>
+              <a:rPr dirty="0" err="1"/>
+              <a:t>une</a:t>
+            </a:r>
+            <a:r>
+              <a:rPr dirty="0"/>
+              <a:t> </a:t>
+            </a:r>
+            <a:r>
+              <a:rPr dirty="0" err="1"/>
+              <a:t>fonction</a:t>
+            </a:r>
+            <a:r>
+              <a:rPr dirty="0"/>
+              <a:t> </a:t>
+            </a:r>
+            <a:r>
+              <a:rPr dirty="0" err="1"/>
+              <a:t>d'utilite</a:t>
+            </a:r>
+            <a:r>
+              <a:rPr dirty="0"/>
+              <a:t> par preoccupation </a:t>
+            </a:r>
+            <a:r>
+              <a:rPr dirty="0" err="1"/>
+              <a:t>d'equite</a:t>
+            </a:r>
+            <a:r>
+              <a:rPr dirty="0"/>
+              <a:t> et un </a:t>
+            </a:r>
+            <a:r>
+              <a:rPr dirty="0" err="1"/>
+              <a:t>mecanisme</a:t>
+            </a:r>
+            <a:r>
+              <a:rPr dirty="0"/>
+              <a:t> de </a:t>
+            </a:r>
+            <a:r>
+              <a:rPr dirty="0" err="1"/>
+              <a:t>negociation</a:t>
+            </a:r>
+            <a:r>
+              <a:rPr dirty="0"/>
+              <a:t> inter-agents a </a:t>
+            </a:r>
+            <a:r>
+              <a:rPr dirty="0" err="1"/>
+              <a:t>concevoir</a:t>
+            </a:r>
+            <a:r>
+              <a:rPr dirty="0"/>
+              <a:t> et </a:t>
+            </a:r>
+            <a:r>
+              <a:rPr dirty="0" err="1"/>
+              <a:t>calibrer</a:t>
+            </a:r>
+            <a:r>
+              <a:rPr dirty="0"/>
+              <a:t> </a:t>
+            </a:r>
+            <a:r>
+              <a:rPr dirty="0" err="1"/>
+              <a:t>separement</a:t>
+            </a:r>
+            <a:r>
+              <a:rPr dirty="0"/>
+              <a:t> pour chacun des 4 corpus -- </a:t>
+            </a:r>
+            <a:r>
+              <a:rPr dirty="0" err="1"/>
+              <a:t>une</a:t>
+            </a:r>
+            <a:r>
+              <a:rPr dirty="0"/>
+              <a:t> contribution </a:t>
+            </a:r>
+            <a:r>
+              <a:rPr dirty="0" err="1"/>
+              <a:t>methodologique</a:t>
+            </a:r>
+            <a:r>
+              <a:rPr dirty="0"/>
+              <a:t> a part </a:t>
+            </a:r>
+            <a:r>
+              <a:rPr dirty="0" err="1"/>
+              <a:t>entiere</a:t>
+            </a:r>
+            <a:r>
+              <a:rPr dirty="0"/>
+              <a:t>, </a:t>
+            </a:r>
+            <a:r>
+              <a:rPr dirty="0" err="1"/>
+              <a:t>distincte</a:t>
+            </a:r>
+            <a:r>
+              <a:rPr dirty="0"/>
+              <a:t> du </a:t>
+            </a:r>
+            <a:r>
+              <a:rPr dirty="0" err="1"/>
+              <a:t>protocole</a:t>
+            </a:r>
+            <a:r>
+              <a:rPr dirty="0"/>
+              <a:t> a </a:t>
+            </a:r>
+            <a:r>
+              <a:rPr dirty="0" err="1"/>
+              <a:t>metriques</a:t>
+            </a:r>
+            <a:r>
+              <a:rPr dirty="0"/>
+              <a:t> EDI fixes </a:t>
+            </a:r>
+            <a:r>
+              <a:rPr dirty="0" err="1"/>
+              <a:t>utilise</a:t>
+            </a:r>
+            <a:r>
+              <a:rPr dirty="0"/>
+              <a:t> </a:t>
+            </a:r>
+            <a:r>
+              <a:rPr dirty="0" err="1"/>
+              <a:t>ici</a:t>
+            </a:r>
+            <a:r>
+              <a:rPr dirty="0"/>
+              <a:t>. Fair Re-rank (</a:t>
+            </a:r>
+            <a:r>
+              <a:rPr dirty="0" err="1"/>
+              <a:t>notre</a:t>
+            </a:r>
+            <a:r>
+              <a:rPr dirty="0"/>
+              <a:t> </a:t>
+            </a:r>
+            <a:r>
+              <a:rPr dirty="0" err="1"/>
+              <a:t>referentiel</a:t>
+            </a:r>
+            <a:r>
+              <a:rPr dirty="0"/>
+              <a:t> de post-</a:t>
+            </a:r>
+            <a:r>
+              <a:rPr dirty="0" err="1"/>
+              <a:t>traitement</a:t>
+            </a:r>
+            <a:r>
+              <a:rPr dirty="0"/>
+              <a:t>) </a:t>
+            </a:r>
+            <a:r>
+              <a:rPr dirty="0" err="1"/>
+              <a:t>reste</a:t>
+            </a:r>
+            <a:r>
+              <a:rPr dirty="0"/>
+              <a:t> comparable dans </a:t>
+            </a:r>
+            <a:r>
+              <a:rPr dirty="0" err="1"/>
+              <a:t>l'esprit</a:t>
+            </a:r>
+            <a:r>
+              <a:rPr dirty="0"/>
+              <a:t> sans </a:t>
+            </a:r>
+            <a:r>
+              <a:rPr dirty="0" err="1"/>
+              <a:t>requerir</a:t>
+            </a:r>
+            <a:r>
+              <a:rPr dirty="0"/>
+              <a:t> </a:t>
+            </a:r>
+            <a:r>
+              <a:rPr dirty="0" err="1"/>
+              <a:t>cette</a:t>
+            </a:r>
+            <a:r>
+              <a:rPr dirty="0"/>
+              <a:t> architecture multi-agents. Une implementation </a:t>
+            </a:r>
+            <a:r>
+              <a:rPr dirty="0" err="1"/>
+              <a:t>fidele</a:t>
+            </a:r>
+            <a:r>
+              <a:rPr dirty="0"/>
+              <a:t> de SCRUF-D est </a:t>
+            </a:r>
+            <a:r>
+              <a:rPr dirty="0" err="1"/>
+              <a:t>laissee</a:t>
+            </a:r>
+            <a:r>
+              <a:rPr dirty="0"/>
+              <a:t> </a:t>
+            </a:r>
+            <a:r>
+              <a:rPr dirty="0" err="1"/>
+              <a:t>comme</a:t>
+            </a:r>
+            <a:r>
+              <a:rPr dirty="0"/>
+              <a:t> </a:t>
+            </a:r>
+            <a:r>
+              <a:rPr dirty="0" err="1"/>
+              <a:t>referentiel</a:t>
+            </a:r>
+            <a:r>
+              <a:rPr dirty="0"/>
+              <a:t> </a:t>
+            </a:r>
+            <a:r>
+              <a:rPr dirty="0" err="1"/>
+              <a:t>prioritaire</a:t>
+            </a:r>
+            <a:r>
+              <a:rPr dirty="0"/>
+              <a:t> pour un travail </a:t>
+            </a:r>
+            <a:r>
+              <a:rPr dirty="0" err="1"/>
+              <a:t>futur</a:t>
+            </a:r>
+            <a:r>
+              <a:rPr dirty="0"/>
+              <a:t>.</a:t>
+            </a:r>
+          </a:p>
+        </p:txBody>
+      </p:sp>
+      <p:sp>
+        <p:nvSpPr>
+          <p:cNvPr id="4" name="Slide Number Placeholder 3"/>
+          <p:cNvSpPr>
+            <a:spLocks noGrp="1"/>
+          </p:cNvSpPr>
+          <p:nvPr>
+            <p:ph type="sldNum" sz="quarter" idx="5"/>
+          </p:nvPr>
+        </p:nvSpPr>
+        <p:spPr/>
+      </p:sp>
+    </p:spTree>
+  </p:cSld>
+  <p:clrMapOvr>
+    <a:masterClrMapping/>
+  </p:clrMapOvr>
+</p:notes>
+</file>
+
+<file path=ppt/notesSlides/notesSlide2.xml><?xml version="1.0" encoding="utf-8"?>
+<p:notes xmlns:a="http://schemas.openxmlformats.org/drawingml/2006/main" xmlns:r="http://schemas.openxmlformats.org/officeDocument/2006/relationships" xmlns:p="http://schemas.openxmlformats.org/presentationml/2006/main">
+  <p:cSld>
+    <p:spTree>
+      <p:nvGrpSpPr>
+        <p:cNvPr id="1" name=""/>
+        <p:cNvGrpSpPr/>
+        <p:nvPr/>
+      </p:nvGrpSpPr>
+      <p:grpSpPr>
+        <a:xfrm>
+          <a:off x="0" y="0"/>
+          <a:ext cx="0" cy="0"/>
+          <a:chOff x="0" y="0"/>
+          <a:chExt cx="0" cy="0"/>
+        </a:xfrm>
+      </p:grpSpPr>
+      <p:sp>
+        <p:nvSpPr>
+          <p:cNvPr id="2" name="Espace réservé de l'image des diapositives 1"/>
+          <p:cNvSpPr>
+            <a:spLocks noGrp="1" noRot="1" noChangeAspect="1"/>
+          </p:cNvSpPr>
+          <p:nvPr>
+            <p:ph type="sldImg"/>
+          </p:nvPr>
+        </p:nvSpPr>
+        <p:spPr/>
+      </p:sp>
+      <p:sp>
+        <p:nvSpPr>
+          <p:cNvPr id="3" name="Espace réservé des notes 2"/>
+          <p:cNvSpPr>
+            <a:spLocks noGrp="1"/>
+          </p:cNvSpPr>
+          <p:nvPr>
+            <p:ph type="body" idx="1"/>
+          </p:nvPr>
+        </p:nvSpPr>
+        <p:spPr/>
+        <p:txBody>
+          <a:bodyPr/>
+          <a:lstStyle/>
+          <a:p>
+            <a:endParaRPr lang="fr-FR" dirty="0"/>
+          </a:p>
+        </p:txBody>
+      </p:sp>
+      <p:sp>
+        <p:nvSpPr>
+          <p:cNvPr id="4" name="Espace réservé du numéro de diapositive 3"/>
+          <p:cNvSpPr>
+            <a:spLocks noGrp="1"/>
+          </p:cNvSpPr>
+          <p:nvPr>
+            <p:ph type="sldNum" sz="quarter" idx="5"/>
+          </p:nvPr>
+        </p:nvSpPr>
+        <p:spPr/>
+        <p:txBody>
+          <a:bodyPr/>
+          <a:lstStyle/>
+          <a:p>
+            <a:fld id="{EC9DD9CB-6CB9-4048-8E70-4A785DF481B5}" type="slidenum">
+              <a:rPr lang="fr-FR" smtClean="0"/>
+              <a:t>5</a:t>
+            </a:fld>
+            <a:endParaRPr lang="fr-FR"/>
+          </a:p>
+        </p:txBody>
+      </p:sp>
+    </p:spTree>
+    <p:extLst>
+      <p:ext uri="{BB962C8B-B14F-4D97-AF65-F5344CB8AC3E}">
+        <p14:creationId xmlns:p14="http://schemas.microsoft.com/office/powerpoint/2010/main" val="3965112032"/>
+      </p:ext>
+    </p:extLst>
+  </p:cSld>
+  <p:clrMapOvr>
+    <a:masterClrMapping/>
+  </p:clrMapOvr>
+</p:notes>
+</file>
+
+<file path=ppt/notesSlides/notesSlide3.xml><?xml version="1.0" encoding="utf-8"?>
+<p:notes xmlns:a="http://schemas.openxmlformats.org/drawingml/2006/main" xmlns:r="http://schemas.openxmlformats.org/officeDocument/2006/relationships" xmlns:p="http://schemas.openxmlformats.org/presentationml/2006/main">
+  <p:cSld>
+    <p:spTree>
+      <p:nvGrpSpPr>
+        <p:cNvPr id="1" name=""/>
+        <p:cNvGrpSpPr/>
+        <p:nvPr/>
+      </p:nvGrpSpPr>
+      <p:grpSpPr>
+        <a:xfrm>
+          <a:off x="0" y="0"/>
+          <a:ext cx="0" cy="0"/>
+          <a:chOff x="0" y="0"/>
+          <a:chExt cx="0" cy="0"/>
+        </a:xfrm>
+      </p:grpSpPr>
+      <p:sp>
+        <p:nvSpPr>
+          <p:cNvPr id="2" name="Slide Image Placeholder 1"/>
+          <p:cNvSpPr>
+            <a:spLocks noGrp="1" noRot="1" noChangeAspect="1"/>
+          </p:cNvSpPr>
+          <p:nvPr>
+            <p:ph type="sldImg" idx="2"/>
+          </p:nvPr>
+        </p:nvSpPr>
+        <p:spPr/>
+      </p:sp>
+      <p:sp>
+        <p:nvSpPr>
+          <p:cNvPr id="3" name="Notes Placeholder 2"/>
+          <p:cNvSpPr>
+            <a:spLocks noGrp="1"/>
+          </p:cNvSpPr>
+          <p:nvPr>
+            <p:ph type="body" sz="quarter" idx="3"/>
+          </p:nvPr>
+        </p:nvSpPr>
+        <p:spPr/>
+        <p:txBody>
+          <a:bodyPr/>
+          <a:lstStyle/>
+          <a:p>
+            <a:r>
+              <a:rPr dirty="0"/>
+              <a:t>Les </a:t>
+            </a:r>
+            <a:r>
+              <a:rPr dirty="0" err="1"/>
+              <a:t>resultats</a:t>
+            </a:r>
+            <a:r>
+              <a:rPr dirty="0"/>
+              <a:t> </a:t>
+            </a:r>
+            <a:r>
+              <a:rPr dirty="0" err="1"/>
+              <a:t>MovieLens</a:t>
+            </a:r>
+            <a:r>
+              <a:rPr dirty="0"/>
+              <a:t> 100k a k=10 </a:t>
+            </a:r>
+            <a:r>
+              <a:rPr dirty="0" err="1"/>
+              <a:t>reposent</a:t>
+            </a:r>
+            <a:r>
+              <a:rPr dirty="0"/>
+              <a:t> sur un unique passage </a:t>
+            </a:r>
+            <a:r>
+              <a:rPr dirty="0" err="1"/>
+              <a:t>deterministe</a:t>
+            </a:r>
+            <a:r>
+              <a:rPr dirty="0"/>
+              <a:t> sur </a:t>
+            </a:r>
+            <a:r>
+              <a:rPr dirty="0" err="1"/>
+              <a:t>l'integralite</a:t>
+            </a:r>
+            <a:r>
+              <a:rPr dirty="0"/>
+              <a:t> du jeu de </a:t>
+            </a:r>
+            <a:r>
+              <a:rPr dirty="0" err="1"/>
+              <a:t>donnees</a:t>
+            </a:r>
+            <a:r>
+              <a:rPr dirty="0"/>
+              <a:t>. </a:t>
+            </a:r>
+            <a:r>
+              <a:rPr dirty="0" err="1"/>
+              <a:t>Verifie</a:t>
+            </a:r>
+            <a:r>
+              <a:rPr dirty="0"/>
+              <a:t> par sous-</a:t>
+            </a:r>
+            <a:r>
+              <a:rPr dirty="0" err="1"/>
+              <a:t>echantillonnage</a:t>
+            </a:r>
+            <a:r>
+              <a:rPr dirty="0"/>
+              <a:t> SANS remise (90% de |U|, 30 repetitions) : AURORA bat Borda et Condorcet sur delta-E dans 28/30 tirages et sur </a:t>
+            </a:r>
+            <a:r>
+              <a:rPr dirty="0" err="1"/>
+              <a:t>l'ILD</a:t>
+            </a:r>
+            <a:r>
+              <a:rPr dirty="0"/>
+              <a:t> dans 30/30 (Weighted Borda : 24/30 et 30/30) -- </a:t>
+            </a:r>
+            <a:r>
+              <a:rPr dirty="0" err="1"/>
+              <a:t>l'avantage</a:t>
+            </a:r>
+            <a:r>
+              <a:rPr dirty="0"/>
+              <a:t> sur les </a:t>
+            </a:r>
+            <a:r>
+              <a:rPr dirty="0" err="1"/>
+              <a:t>regles</a:t>
+            </a:r>
+            <a:r>
+              <a:rPr dirty="0"/>
+              <a:t> de vote </a:t>
+            </a:r>
+            <a:r>
+              <a:rPr dirty="0" err="1"/>
+              <a:t>classiques</a:t>
+            </a:r>
+            <a:r>
+              <a:rPr dirty="0"/>
+              <a:t> </a:t>
+            </a:r>
+            <a:r>
+              <a:rPr dirty="0" err="1"/>
+              <a:t>n'est</a:t>
+            </a:r>
+            <a:r>
+              <a:rPr dirty="0"/>
+              <a:t> pas un artefact du tirage unique </a:t>
+            </a:r>
+            <a:r>
+              <a:rPr dirty="0" err="1"/>
+              <a:t>rapporte</a:t>
+            </a:r>
+            <a:r>
+              <a:rPr dirty="0"/>
+              <a:t>. Fair Re-rank </a:t>
+            </a:r>
+            <a:r>
+              <a:rPr dirty="0" err="1"/>
+              <a:t>reste</a:t>
+            </a:r>
+            <a:r>
+              <a:rPr dirty="0"/>
+              <a:t> </a:t>
+            </a:r>
+            <a:r>
+              <a:rPr dirty="0" err="1"/>
+              <a:t>devant</a:t>
+            </a:r>
+            <a:r>
+              <a:rPr dirty="0"/>
+              <a:t> AURORA sur les deux </a:t>
+            </a:r>
+            <a:r>
+              <a:rPr dirty="0" err="1"/>
+              <a:t>metriques</a:t>
+            </a:r>
+            <a:r>
+              <a:rPr dirty="0"/>
+              <a:t> dans les 30/30 tirages -- </a:t>
+            </a:r>
+            <a:r>
+              <a:rPr dirty="0" err="1"/>
+              <a:t>confirme</a:t>
+            </a:r>
+            <a:r>
+              <a:rPr dirty="0"/>
+              <a:t> </a:t>
+            </a:r>
+            <a:r>
+              <a:rPr dirty="0" err="1"/>
+              <a:t>robuste</a:t>
+            </a:r>
+            <a:r>
+              <a:rPr dirty="0"/>
+              <a:t> </a:t>
+            </a:r>
+            <a:r>
+              <a:rPr dirty="0" err="1"/>
+              <a:t>aussi</a:t>
+            </a:r>
+            <a:r>
+              <a:rPr dirty="0"/>
+              <a:t>, dans les deux </a:t>
+            </a:r>
+            <a:r>
+              <a:rPr dirty="0" err="1"/>
+              <a:t>sens.</a:t>
+            </a:r>
+            <a:r>
+              <a:rPr dirty="0"/>
+              <a:t> (Un premier </a:t>
+            </a:r>
+            <a:r>
+              <a:rPr dirty="0" err="1"/>
+              <a:t>essai</a:t>
+            </a:r>
+            <a:r>
+              <a:rPr dirty="0"/>
+              <a:t> avec un bootstrap </a:t>
+            </a:r>
+            <a:r>
+              <a:rPr dirty="0" err="1"/>
+              <a:t>classique</a:t>
+            </a:r>
+            <a:r>
+              <a:rPr dirty="0"/>
+              <a:t> -- tirage AVEC remise -- </a:t>
+            </a:r>
+            <a:r>
+              <a:rPr dirty="0" err="1"/>
+              <a:t>donnait</a:t>
+            </a:r>
+            <a:r>
+              <a:rPr dirty="0"/>
+              <a:t> des </a:t>
+            </a:r>
+            <a:r>
+              <a:rPr dirty="0" err="1"/>
+              <a:t>resultats</a:t>
+            </a:r>
+            <a:r>
+              <a:rPr dirty="0"/>
+              <a:t> </a:t>
+            </a:r>
+            <a:r>
+              <a:rPr dirty="0" err="1"/>
+              <a:t>trompeurs</a:t>
+            </a:r>
+            <a:r>
+              <a:rPr dirty="0"/>
+              <a:t> : environ 63% des </a:t>
+            </a:r>
+            <a:r>
+              <a:rPr dirty="0" err="1"/>
+              <a:t>utilisateurs</a:t>
+            </a:r>
+            <a:r>
+              <a:rPr dirty="0"/>
+              <a:t> tires </a:t>
+            </a:r>
+            <a:r>
+              <a:rPr dirty="0" err="1"/>
+              <a:t>sont</a:t>
+            </a:r>
+            <a:r>
+              <a:rPr dirty="0"/>
+              <a:t> </a:t>
+            </a:r>
+            <a:r>
+              <a:rPr dirty="0" err="1"/>
+              <a:t>alors</a:t>
+            </a:r>
+            <a:r>
+              <a:rPr dirty="0"/>
+              <a:t> des </a:t>
+            </a:r>
+            <a:r>
+              <a:rPr dirty="0" err="1"/>
+              <a:t>doublons</a:t>
+            </a:r>
+            <a:r>
+              <a:rPr dirty="0"/>
+              <a:t> exacts, </a:t>
+            </a:r>
+            <a:r>
+              <a:rPr dirty="0" err="1"/>
+              <a:t>ce</a:t>
+            </a:r>
+            <a:r>
+              <a:rPr dirty="0"/>
+              <a:t> qui </a:t>
+            </a:r>
+            <a:r>
+              <a:rPr dirty="0" err="1"/>
+              <a:t>avantage</a:t>
+            </a:r>
+            <a:r>
+              <a:rPr dirty="0"/>
+              <a:t> </a:t>
+            </a:r>
+            <a:r>
+              <a:rPr dirty="0" err="1"/>
+              <a:t>artificiellement</a:t>
+            </a:r>
+            <a:r>
+              <a:rPr dirty="0"/>
+              <a:t> les fusions de quasi-</a:t>
+            </a:r>
+            <a:r>
+              <a:rPr dirty="0" err="1"/>
+              <a:t>identiques</a:t>
+            </a:r>
+            <a:r>
+              <a:rPr dirty="0"/>
+              <a:t> dans le coarsening. </a:t>
+            </a:r>
+            <a:r>
+              <a:rPr dirty="0" err="1"/>
+              <a:t>D'ou</a:t>
+            </a:r>
+            <a:r>
+              <a:rPr dirty="0"/>
+              <a:t> le choix du sans-remise pour un test </a:t>
+            </a:r>
+            <a:r>
+              <a:rPr dirty="0" err="1"/>
+              <a:t>methodologiquement</a:t>
+            </a:r>
+            <a:r>
+              <a:rPr dirty="0"/>
+              <a:t> correct.)</a:t>
+            </a:r>
+          </a:p>
+        </p:txBody>
+      </p:sp>
+      <p:sp>
+        <p:nvSpPr>
+          <p:cNvPr id="4" name="Slide Number Placeholder 3"/>
+          <p:cNvSpPr>
+            <a:spLocks noGrp="1"/>
+          </p:cNvSpPr>
+          <p:nvPr>
+            <p:ph type="sldNum" sz="quarter" idx="5"/>
+          </p:nvPr>
+        </p:nvSpPr>
+        <p:spPr/>
+      </p:sp>
+    </p:spTree>
+  </p:cSld>
+  <p:clrMapOvr>
+    <a:masterClrMapping/>
+  </p:clrMapOvr>
+</p:notes>
+</file>
+
 <file path=ppt/slideLayouts/slideLayout1.xml><?xml version="1.0" encoding="utf-8"?>
 <p:sldLayout xmlns:a="http://schemas.openxmlformats.org/drawingml/2006/main" xmlns:r="http://schemas.openxmlformats.org/officeDocument/2006/relationships" xmlns:p="http://schemas.openxmlformats.org/presentationml/2006/main" type="title" preserve="1">
   <p:cSld name="Title Slide">
@@ -315,7 +1557,7 @@
           <a:p>
             <a:fld id="{5BCAD085-E8A6-8845-BD4E-CB4CCA059FC4}" type="datetimeFigureOut">
               <a:rPr lang="en-US" smtClean="0"/>
-              <a:t>8/26/26</a:t>
+              <a:t>8/27/26</a:t>
             </a:fld>
             <a:endParaRPr lang="en-US"/>
           </a:p>
@@ -483,7 +1725,7 @@
           <a:p>
             <a:fld id="{5BCAD085-E8A6-8845-BD4E-CB4CCA059FC4}" type="datetimeFigureOut">
               <a:rPr lang="en-US" smtClean="0"/>
-              <a:t>8/26/26</a:t>
+              <a:t>8/27/26</a:t>
             </a:fld>
             <a:endParaRPr lang="en-US"/>
           </a:p>
@@ -661,7 +1903,7 @@
           <a:p>
             <a:fld id="{5BCAD085-E8A6-8845-BD4E-CB4CCA059FC4}" type="datetimeFigureOut">
               <a:rPr lang="en-US" smtClean="0"/>
-              <a:t>8/26/26</a:t>
+              <a:t>8/27/26</a:t>
             </a:fld>
             <a:endParaRPr lang="en-US"/>
           </a:p>
@@ -829,7 +2071,7 @@
           <a:p>
             <a:fld id="{5BCAD085-E8A6-8845-BD4E-CB4CCA059FC4}" type="datetimeFigureOut">
               <a:rPr lang="en-US" smtClean="0"/>
-              <a:t>8/26/26</a:t>
+              <a:t>8/27/26</a:t>
             </a:fld>
             <a:endParaRPr lang="en-US"/>
           </a:p>
@@ -1074,7 +2316,7 @@
           <a:p>
             <a:fld id="{5BCAD085-E8A6-8845-BD4E-CB4CCA059FC4}" type="datetimeFigureOut">
               <a:rPr lang="en-US" smtClean="0"/>
-              <a:t>8/26/26</a:t>
+              <a:t>8/27/26</a:t>
             </a:fld>
             <a:endParaRPr lang="en-US"/>
           </a:p>
@@ -1359,7 +2601,7 @@
           <a:p>
             <a:fld id="{5BCAD085-E8A6-8845-BD4E-CB4CCA059FC4}" type="datetimeFigureOut">
               <a:rPr lang="en-US" smtClean="0"/>
-              <a:t>8/26/26</a:t>
+              <a:t>8/27/26</a:t>
             </a:fld>
             <a:endParaRPr lang="en-US"/>
           </a:p>
@@ -1778,7 +3020,7 @@
           <a:p>
             <a:fld id="{5BCAD085-E8A6-8845-BD4E-CB4CCA059FC4}" type="datetimeFigureOut">
               <a:rPr lang="en-US" smtClean="0"/>
-              <a:t>8/26/26</a:t>
+              <a:t>8/27/26</a:t>
             </a:fld>
             <a:endParaRPr lang="en-US"/>
           </a:p>
@@ -1895,7 +3137,7 @@
           <a:p>
             <a:fld id="{5BCAD085-E8A6-8845-BD4E-CB4CCA059FC4}" type="datetimeFigureOut">
               <a:rPr lang="en-US" smtClean="0"/>
-              <a:t>8/26/26</a:t>
+              <a:t>8/27/26</a:t>
             </a:fld>
             <a:endParaRPr lang="en-US"/>
           </a:p>
@@ -1990,7 +3232,7 @@
           <a:p>
             <a:fld id="{5BCAD085-E8A6-8845-BD4E-CB4CCA059FC4}" type="datetimeFigureOut">
               <a:rPr lang="en-US" smtClean="0"/>
-              <a:t>8/26/26</a:t>
+              <a:t>8/27/26</a:t>
             </a:fld>
             <a:endParaRPr lang="en-US"/>
           </a:p>
@@ -2265,7 +3507,7 @@
           <a:p>
             <a:fld id="{5BCAD085-E8A6-8845-BD4E-CB4CCA059FC4}" type="datetimeFigureOut">
               <a:rPr lang="en-US" smtClean="0"/>
-              <a:t>8/26/26</a:t>
+              <a:t>8/27/26</a:t>
             </a:fld>
             <a:endParaRPr lang="en-US"/>
           </a:p>
@@ -2517,7 +3759,7 @@
           <a:p>
             <a:fld id="{5BCAD085-E8A6-8845-BD4E-CB4CCA059FC4}" type="datetimeFigureOut">
               <a:rPr lang="en-US" smtClean="0"/>
-              <a:t>8/26/26</a:t>
+              <a:t>8/27/26</a:t>
             </a:fld>
             <a:endParaRPr lang="en-US"/>
           </a:p>
@@ -2728,7 +3970,7 @@
           <a:p>
             <a:fld id="{5BCAD085-E8A6-8845-BD4E-CB4CCA059FC4}" type="datetimeFigureOut">
               <a:rPr lang="en-US" smtClean="0"/>
-              <a:t>8/26/26</a:t>
+              <a:t>8/27/26</a:t>
             </a:fld>
             <a:endParaRPr lang="en-US"/>
           </a:p>
@@ -3610,7 +4852,7 @@
           <p:nvPr/>
         </p:nvPicPr>
         <p:blipFill>
-          <a:blip r:embed="rId2"/>
+          <a:blip r:embed="rId3"/>
           <a:stretch>
             <a:fillRect/>
           </a:stretch>
@@ -6487,12 +7729,6 @@
               </a:rPr>
               <a:t>sitaacisse-boop.github.io/EDI</a:t>
             </a:r>
-            <a:endParaRPr sz="3000" b="1" dirty="0">
-              <a:solidFill>
-                <a:srgbClr val="63003C"/>
-              </a:solidFill>
-              <a:hlinkClick r:id="rId2"/>
-            </a:endParaRPr>
           </a:p>
         </p:txBody>
       </p:sp>
@@ -6822,4 +8058,319 @@
   </a:objectDefaults>
   <a:extraClrSchemeLst/>
 </a:theme>
+</file>
+
+<file path=ppt/theme/theme2.xml><?xml version="1.0" encoding="utf-8"?>
+<a:theme xmlns:a="http://schemas.openxmlformats.org/drawingml/2006/main" name="Thème Office">
+  <a:themeElements>
+    <a:clrScheme name="Office">
+      <a:dk1>
+        <a:sysClr val="windowText" lastClr="000000"/>
+      </a:dk1>
+      <a:lt1>
+        <a:sysClr val="window" lastClr="FFFFFF"/>
+      </a:lt1>
+      <a:dk2>
+        <a:srgbClr val="0E2841"/>
+      </a:dk2>
+      <a:lt2>
+        <a:srgbClr val="E8E8E8"/>
+      </a:lt2>
+      <a:accent1>
+        <a:srgbClr val="156082"/>
+      </a:accent1>
+      <a:accent2>
+        <a:srgbClr val="E97132"/>
+      </a:accent2>
+      <a:accent3>
+        <a:srgbClr val="196B24"/>
+      </a:accent3>
+      <a:accent4>
+        <a:srgbClr val="0F9ED5"/>
+      </a:accent4>
+      <a:accent5>
+        <a:srgbClr val="A02B93"/>
+      </a:accent5>
+      <a:accent6>
+        <a:srgbClr val="4EA72E"/>
+      </a:accent6>
+      <a:hlink>
+        <a:srgbClr val="467886"/>
+      </a:hlink>
+      <a:folHlink>
+        <a:srgbClr val="96607D"/>
+      </a:folHlink>
+    </a:clrScheme>
+    <a:fontScheme name="Office">
+      <a:majorFont>
+        <a:latin typeface="Aptos Display" panose="02110004020202020204"/>
+        <a:ea typeface=""/>
+        <a:cs typeface=""/>
+        <a:font script="Jpan" typeface="游ゴシック Light"/>
+        <a:font script="Hang" typeface="맑은 고딕"/>
+        <a:font script="Hans" typeface="等线 Light"/>
+        <a:font script="Hant" typeface="新細明體"/>
+        <a:font script="Arab" typeface="Times New Roman"/>
+        <a:font script="Hebr" typeface="Times New Roman"/>
+        <a:font script="Thai" typeface="Angsana New"/>
+        <a:font script="Ethi" typeface="Nyala"/>
+        <a:font script="Beng" typeface="Vrinda"/>
+        <a:font script="Gujr" typeface="Shruti"/>
+        <a:font script="Khmr" typeface="MoolBoran"/>
+        <a:font script="Knda" typeface="Tunga"/>
+        <a:font script="Guru" typeface="Raavi"/>
+        <a:font script="Cans" typeface="Euphemia"/>
+        <a:font script="Cher" typeface="Plantagenet Cherokee"/>
+        <a:font script="Yiii" typeface="Microsoft Yi Baiti"/>
+        <a:font script="Tibt" typeface="Microsoft Himalaya"/>
+        <a:font script="Thaa" typeface="MV Boli"/>
+        <a:font script="Deva" typeface="Mangal"/>
+        <a:font script="Telu" typeface="Gautami"/>
+        <a:font script="Taml" typeface="Latha"/>
+        <a:font script="Syrc" typeface="Estrangelo Edessa"/>
+        <a:font script="Orya" typeface="Kalinga"/>
+        <a:font script="Mlym" typeface="Kartika"/>
+        <a:font script="Laoo" typeface="DokChampa"/>
+        <a:font script="Sinh" typeface="Iskoola Pota"/>
+        <a:font script="Mong" typeface="Mongolian Baiti"/>
+        <a:font script="Viet" typeface="Times New Roman"/>
+        <a:font script="Uigh" typeface="Microsoft Uighur"/>
+        <a:font script="Geor" typeface="Sylfaen"/>
+        <a:font script="Armn" typeface="Arial"/>
+        <a:font script="Bugi" typeface="Leelawadee UI"/>
+        <a:font script="Bopo" typeface="Microsoft JhengHei"/>
+        <a:font script="Java" typeface="Javanese Text"/>
+        <a:font script="Lisu" typeface="Segoe UI"/>
+        <a:font script="Mymr" typeface="Myanmar Text"/>
+        <a:font script="Nkoo" typeface="Ebrima"/>
+        <a:font script="Olck" typeface="Nirmala UI"/>
+        <a:font script="Osma" typeface="Ebrima"/>
+        <a:font script="Phag" typeface="Phagspa"/>
+        <a:font script="Syrn" typeface="Estrangelo Edessa"/>
+        <a:font script="Syrj" typeface="Estrangelo Edessa"/>
+        <a:font script="Syre" typeface="Estrangelo Edessa"/>
+        <a:font script="Sora" typeface="Nirmala UI"/>
+        <a:font script="Tale" typeface="Microsoft Tai Le"/>
+        <a:font script="Talu" typeface="Microsoft New Tai Lue"/>
+        <a:font script="Tfng" typeface="Ebrima"/>
+      </a:majorFont>
+      <a:minorFont>
+        <a:latin typeface="Aptos" panose="02110004020202020204"/>
+        <a:ea typeface=""/>
+        <a:cs typeface=""/>
+        <a:font script="Jpan" typeface="游ゴシック"/>
+        <a:font script="Hang" typeface="맑은 고딕"/>
+        <a:font script="Hans" typeface="等线"/>
+        <a:font script="Hant" typeface="新細明體"/>
+        <a:font script="Arab" typeface="Arial"/>
+        <a:font script="Hebr" typeface="Arial"/>
+        <a:font script="Thai" typeface="Cordia New"/>
+        <a:font script="Ethi" typeface="Nyala"/>
+        <a:font script="Beng" typeface="Vrinda"/>
+        <a:font script="Gujr" typeface="Shruti"/>
+        <a:font script="Khmr" typeface="DaunPenh"/>
+        <a:font script="Knda" typeface="Tunga"/>
+        <a:font script="Guru" typeface="Raavi"/>
+        <a:font script="Cans" typeface="Euphemia"/>
+        <a:font script="Cher" typeface="Plantagenet Cherokee"/>
+        <a:font script="Yiii" typeface="Microsoft Yi Baiti"/>
+        <a:font script="Tibt" typeface="Microsoft Himalaya"/>
+        <a:font script="Thaa" typeface="MV Boli"/>
+        <a:font script="Deva" typeface="Mangal"/>
+        <a:font script="Telu" typeface="Gautami"/>
+        <a:font script="Taml" typeface="Latha"/>
+        <a:font script="Syrc" typeface="Estrangelo Edessa"/>
+        <a:font script="Orya" typeface="Kalinga"/>
+        <a:font script="Mlym" typeface="Kartika"/>
+        <a:font script="Laoo" typeface="DokChampa"/>
+        <a:font script="Sinh" typeface="Iskoola Pota"/>
+        <a:font script="Mong" typeface="Mongolian Baiti"/>
+        <a:font script="Viet" typeface="Arial"/>
+        <a:font script="Uigh" typeface="Microsoft Uighur"/>
+        <a:font script="Geor" typeface="Sylfaen"/>
+        <a:font script="Armn" typeface="Arial"/>
+        <a:font script="Bugi" typeface="Leelawadee UI"/>
+        <a:font script="Bopo" typeface="Microsoft JhengHei"/>
+        <a:font script="Java" typeface="Javanese Text"/>
+        <a:font script="Lisu" typeface="Segoe UI"/>
+        <a:font script="Mymr" typeface="Myanmar Text"/>
+        <a:font script="Nkoo" typeface="Ebrima"/>
+        <a:font script="Olck" typeface="Nirmala UI"/>
+        <a:font script="Osma" typeface="Ebrima"/>
+        <a:font script="Phag" typeface="Phagspa"/>
+        <a:font script="Syrn" typeface="Estrangelo Edessa"/>
+        <a:font script="Syrj" typeface="Estrangelo Edessa"/>
+        <a:font script="Syre" typeface="Estrangelo Edessa"/>
+        <a:font script="Sora" typeface="Nirmala UI"/>
+        <a:font script="Tale" typeface="Microsoft Tai Le"/>
+        <a:font script="Talu" typeface="Microsoft New Tai Lue"/>
+        <a:font script="Tfng" typeface="Ebrima"/>
+      </a:minorFont>
+    </a:fontScheme>
+    <a:fmtScheme name="Office">
+      <a:fillStyleLst>
+        <a:solidFill>
+          <a:schemeClr val="phClr"/>
+        </a:solidFill>
+        <a:gradFill rotWithShape="1">
+          <a:gsLst>
+            <a:gs pos="0">
+              <a:schemeClr val="phClr">
+                <a:lumMod val="110000"/>
+                <a:satMod val="105000"/>
+                <a:tint val="67000"/>
+              </a:schemeClr>
+            </a:gs>
+            <a:gs pos="50000">
+              <a:schemeClr val="phClr">
+                <a:lumMod val="105000"/>
+                <a:satMod val="103000"/>
+                <a:tint val="73000"/>
+              </a:schemeClr>
+            </a:gs>
+            <a:gs pos="100000">
+              <a:schemeClr val="phClr">
+                <a:lumMod val="105000"/>
+                <a:satMod val="109000"/>
+                <a:tint val="81000"/>
+              </a:schemeClr>
+            </a:gs>
+          </a:gsLst>
+          <a:lin ang="5400000" scaled="0"/>
+        </a:gradFill>
+        <a:gradFill rotWithShape="1">
+          <a:gsLst>
+            <a:gs pos="0">
+              <a:schemeClr val="phClr">
+                <a:satMod val="103000"/>
+                <a:lumMod val="102000"/>
+                <a:tint val="94000"/>
+              </a:schemeClr>
+            </a:gs>
+            <a:gs pos="50000">
+              <a:schemeClr val="phClr">
+                <a:satMod val="110000"/>
+                <a:lumMod val="100000"/>
+                <a:shade val="100000"/>
+              </a:schemeClr>
+            </a:gs>
+            <a:gs pos="100000">
+              <a:schemeClr val="phClr">
+                <a:lumMod val="99000"/>
+                <a:satMod val="120000"/>
+                <a:shade val="78000"/>
+              </a:schemeClr>
+            </a:gs>
+          </a:gsLst>
+          <a:lin ang="5400000" scaled="0"/>
+        </a:gradFill>
+      </a:fillStyleLst>
+      <a:lnStyleLst>
+        <a:ln w="12700" cap="flat" cmpd="sng" algn="ctr">
+          <a:solidFill>
+            <a:schemeClr val="phClr"/>
+          </a:solidFill>
+          <a:prstDash val="solid"/>
+          <a:miter lim="800000"/>
+        </a:ln>
+        <a:ln w="19050" cap="flat" cmpd="sng" algn="ctr">
+          <a:solidFill>
+            <a:schemeClr val="phClr"/>
+          </a:solidFill>
+          <a:prstDash val="solid"/>
+          <a:miter lim="800000"/>
+        </a:ln>
+        <a:ln w="25400" cap="flat" cmpd="sng" algn="ctr">
+          <a:solidFill>
+            <a:schemeClr val="phClr"/>
+          </a:solidFill>
+          <a:prstDash val="solid"/>
+          <a:miter lim="800000"/>
+        </a:ln>
+      </a:lnStyleLst>
+      <a:effectStyleLst>
+        <a:effectStyle>
+          <a:effectLst/>
+        </a:effectStyle>
+        <a:effectStyle>
+          <a:effectLst/>
+        </a:effectStyle>
+        <a:effectStyle>
+          <a:effectLst>
+            <a:outerShdw blurRad="57150" dist="19050" dir="5400000" algn="ctr" rotWithShape="0">
+              <a:srgbClr val="000000">
+                <a:alpha val="63000"/>
+              </a:srgbClr>
+            </a:outerShdw>
+          </a:effectLst>
+        </a:effectStyle>
+      </a:effectStyleLst>
+      <a:bgFillStyleLst>
+        <a:solidFill>
+          <a:schemeClr val="phClr"/>
+        </a:solidFill>
+        <a:solidFill>
+          <a:schemeClr val="phClr">
+            <a:tint val="95000"/>
+            <a:satMod val="170000"/>
+          </a:schemeClr>
+        </a:solidFill>
+        <a:gradFill rotWithShape="1">
+          <a:gsLst>
+            <a:gs pos="0">
+              <a:schemeClr val="phClr">
+                <a:tint val="93000"/>
+                <a:satMod val="150000"/>
+                <a:shade val="98000"/>
+                <a:lumMod val="102000"/>
+              </a:schemeClr>
+            </a:gs>
+            <a:gs pos="50000">
+              <a:schemeClr val="phClr">
+                <a:tint val="98000"/>
+                <a:satMod val="130000"/>
+                <a:shade val="90000"/>
+                <a:lumMod val="103000"/>
+              </a:schemeClr>
+            </a:gs>
+            <a:gs pos="100000">
+              <a:schemeClr val="phClr">
+                <a:shade val="63000"/>
+                <a:satMod val="120000"/>
+              </a:schemeClr>
+            </a:gs>
+          </a:gsLst>
+          <a:lin ang="5400000" scaled="0"/>
+        </a:gradFill>
+      </a:bgFillStyleLst>
+    </a:fmtScheme>
+  </a:themeElements>
+  <a:objectDefaults>
+    <a:lnDef>
+      <a:spPr/>
+      <a:bodyPr/>
+      <a:lstStyle/>
+      <a:style>
+        <a:lnRef idx="2">
+          <a:schemeClr val="accent1"/>
+        </a:lnRef>
+        <a:fillRef idx="0">
+          <a:schemeClr val="accent1"/>
+        </a:fillRef>
+        <a:effectRef idx="1">
+          <a:schemeClr val="accent1"/>
+        </a:effectRef>
+        <a:fontRef idx="minor">
+          <a:schemeClr val="tx1"/>
+        </a:fontRef>
+      </a:style>
+    </a:lnDef>
+  </a:objectDefaults>
+  <a:extraClrSchemeLst/>
+  <a:extLst>
+    <a:ext uri="{05A4C25C-085E-4340-85A3-A5531E510DB2}">
+      <thm15:themeFamily xmlns:thm15="http://schemas.microsoft.com/office/thememl/2012/main" name="Office Theme" id="{2E142A2C-CD16-42D6-873A-C26D2A0506FA}" vid="{1BDDFF52-6CD6-40A5-AB3C-68EB2F1E4D0A}"/>
+    </a:ext>
+  </a:extLst>
+</a:theme>
 </file>
</xml_diff>

<commit_message>
Définit brièvement Équité, Diversité, Inclusion dans l'onglet Calcul EDI et la diapo 3
Site : ajoute une carte de définitions courtes des trois notions EDI en
tête de l'onglet Calcul EDI, avant les métriques formelles. Diapo :
complète la puce Objectif de la diapositive 3 avec une définition
parenthétique de chaque terme.
</commit_message>
<xml_diff>
--- a/presentation/AURORA_Soutenance_FR.pptx
+++ b/presentation/AURORA_Soutenance_FR.pptx
@@ -221,7 +221,7 @@
           <a:p>
             <a:fld id="{BB4E32DD-2BBF-E54C-AA90-1FF8494E5F3B}" type="datetimeFigureOut">
               <a:rPr lang="fr-FR" smtClean="0"/>
-              <a:t>27/08/2026</a:t>
+              <a:t>31/08/2026</a:t>
             </a:fld>
             <a:endParaRPr lang="fr-FR"/>
           </a:p>
@@ -1557,7 +1557,7 @@
           <a:p>
             <a:fld id="{5BCAD085-E8A6-8845-BD4E-CB4CCA059FC4}" type="datetimeFigureOut">
               <a:rPr lang="en-US" smtClean="0"/>
-              <a:t>8/27/26</a:t>
+              <a:t>8/31/26</a:t>
             </a:fld>
             <a:endParaRPr lang="en-US"/>
           </a:p>
@@ -1725,7 +1725,7 @@
           <a:p>
             <a:fld id="{5BCAD085-E8A6-8845-BD4E-CB4CCA059FC4}" type="datetimeFigureOut">
               <a:rPr lang="en-US" smtClean="0"/>
-              <a:t>8/27/26</a:t>
+              <a:t>8/31/26</a:t>
             </a:fld>
             <a:endParaRPr lang="en-US"/>
           </a:p>
@@ -1903,7 +1903,7 @@
           <a:p>
             <a:fld id="{5BCAD085-E8A6-8845-BD4E-CB4CCA059FC4}" type="datetimeFigureOut">
               <a:rPr lang="en-US" smtClean="0"/>
-              <a:t>8/27/26</a:t>
+              <a:t>8/31/26</a:t>
             </a:fld>
             <a:endParaRPr lang="en-US"/>
           </a:p>
@@ -2071,7 +2071,7 @@
           <a:p>
             <a:fld id="{5BCAD085-E8A6-8845-BD4E-CB4CCA059FC4}" type="datetimeFigureOut">
               <a:rPr lang="en-US" smtClean="0"/>
-              <a:t>8/27/26</a:t>
+              <a:t>8/31/26</a:t>
             </a:fld>
             <a:endParaRPr lang="en-US"/>
           </a:p>
@@ -2316,7 +2316,7 @@
           <a:p>
             <a:fld id="{5BCAD085-E8A6-8845-BD4E-CB4CCA059FC4}" type="datetimeFigureOut">
               <a:rPr lang="en-US" smtClean="0"/>
-              <a:t>8/27/26</a:t>
+              <a:t>8/31/26</a:t>
             </a:fld>
             <a:endParaRPr lang="en-US"/>
           </a:p>
@@ -2601,7 +2601,7 @@
           <a:p>
             <a:fld id="{5BCAD085-E8A6-8845-BD4E-CB4CCA059FC4}" type="datetimeFigureOut">
               <a:rPr lang="en-US" smtClean="0"/>
-              <a:t>8/27/26</a:t>
+              <a:t>8/31/26</a:t>
             </a:fld>
             <a:endParaRPr lang="en-US"/>
           </a:p>
@@ -3020,7 +3020,7 @@
           <a:p>
             <a:fld id="{5BCAD085-E8A6-8845-BD4E-CB4CCA059FC4}" type="datetimeFigureOut">
               <a:rPr lang="en-US" smtClean="0"/>
-              <a:t>8/27/26</a:t>
+              <a:t>8/31/26</a:t>
             </a:fld>
             <a:endParaRPr lang="en-US"/>
           </a:p>
@@ -3137,7 +3137,7 @@
           <a:p>
             <a:fld id="{5BCAD085-E8A6-8845-BD4E-CB4CCA059FC4}" type="datetimeFigureOut">
               <a:rPr lang="en-US" smtClean="0"/>
-              <a:t>8/27/26</a:t>
+              <a:t>8/31/26</a:t>
             </a:fld>
             <a:endParaRPr lang="en-US"/>
           </a:p>
@@ -3232,7 +3232,7 @@
           <a:p>
             <a:fld id="{5BCAD085-E8A6-8845-BD4E-CB4CCA059FC4}" type="datetimeFigureOut">
               <a:rPr lang="en-US" smtClean="0"/>
-              <a:t>8/27/26</a:t>
+              <a:t>8/31/26</a:t>
             </a:fld>
             <a:endParaRPr lang="en-US"/>
           </a:p>
@@ -3507,7 +3507,7 @@
           <a:p>
             <a:fld id="{5BCAD085-E8A6-8845-BD4E-CB4CCA059FC4}" type="datetimeFigureOut">
               <a:rPr lang="en-US" smtClean="0"/>
-              <a:t>8/27/26</a:t>
+              <a:t>8/31/26</a:t>
             </a:fld>
             <a:endParaRPr lang="en-US"/>
           </a:p>
@@ -3759,7 +3759,7 @@
           <a:p>
             <a:fld id="{5BCAD085-E8A6-8845-BD4E-CB4CCA059FC4}" type="datetimeFigureOut">
               <a:rPr lang="en-US" smtClean="0"/>
-              <a:t>8/27/26</a:t>
+              <a:t>8/31/26</a:t>
             </a:fld>
             <a:endParaRPr lang="en-US"/>
           </a:p>
@@ -3970,7 +3970,7 @@
           <a:p>
             <a:fld id="{5BCAD085-E8A6-8845-BD4E-CB4CCA059FC4}" type="datetimeFigureOut">
               <a:rPr lang="en-US" smtClean="0"/>
-              <a:t>8/27/26</a:t>
+              <a:t>8/31/26</a:t>
             </a:fld>
             <a:endParaRPr lang="en-US"/>
           </a:p>
@@ -6192,7 +6192,7 @@
               </a:defRPr>
             </a:pPr>
             <a:r>
-              <a:t>•  Objectif : représenter les préférences comme un graphe biparti attribué, et concevoir une méthode de résumé de graphe qui préserve explicitement l'équité, la diversité et l'inclusion (EDI)</a:t>
+              <a:t>•  Objectif : représenter les préférences comme un graphe biparti attribué, et concevoir une méthode de résumé de graphe qui préserve explicitement l'équité (traitement juste des groupes), la diversité (variété des recommandations) et l'inclusion (représentation proportionnelle des minorités) — ensemble, l'EDI</a:t>
             </a:r>
           </a:p>
           <a:p>
@@ -7020,6 +7020,36 @@
           </a:p>
         </p:txBody>
       </p:sp>
+      <p:pic>
+        <p:nvPicPr>
+          <p:cNvPr id="6" name="Image 5">
+            <a:extLst>
+              <a:ext uri="{FF2B5EF4-FFF2-40B4-BE49-F238E27FC236}">
+                <a16:creationId xmlns:a16="http://schemas.microsoft.com/office/drawing/2014/main" id="{DBB68A0D-A701-D00E-842C-777FCC5079D7}"/>
+              </a:ext>
+            </a:extLst>
+          </p:cNvPr>
+          <p:cNvPicPr>
+            <a:picLocks noChangeAspect="1"/>
+          </p:cNvPicPr>
+          <p:nvPr/>
+        </p:nvPicPr>
+        <p:blipFill>
+          <a:blip r:embed="rId2"/>
+          <a:stretch>
+            <a:fillRect/>
+          </a:stretch>
+        </p:blipFill>
+        <p:spPr>
+          <a:xfrm>
+            <a:off x="2762250" y="3919220"/>
+            <a:ext cx="5753100" cy="2298700"/>
+          </a:xfrm>
+          <a:prstGeom prst="rect">
+            <a:avLst/>
+          </a:prstGeom>
+        </p:spPr>
+      </p:pic>
     </p:spTree>
   </p:cSld>
   <p:clrMapOvr>

</xml_diff>

<commit_message>
Explique le déséquilibre de genre dans la diapo Jeux de données
Rétrécit la figure du mémoire pour faire de la place à une explication
du pourquoi de ce déséquilibre, avec des statistiques sur les femmes en
sciences/tech au Sénégal, au Canada et en France — pour montrer qu'il
s'agit d'un phénomène structurel mondial, pas un artefact des jeux de
données.
</commit_message>
<xml_diff>
--- a/presentation/AURORA_Soutenance_FR.pptx
+++ b/presentation/AURORA_Soutenance_FR.pptx
@@ -7204,8 +7204,8 @@
         </p:blipFill>
         <p:spPr>
           <a:xfrm>
-            <a:off x="2576741" y="1330000"/>
-            <a:ext cx="7008038" cy="4650000"/>
+            <a:off x="685800" y="1500000"/>
+            <a:ext cx="6200000" cy="4113847"/>
           </a:xfrm>
           <a:prstGeom prst="rect">
             <a:avLst/>
@@ -7220,8 +7220,8 @@
         </p:nvSpPr>
         <p:spPr>
           <a:xfrm>
-            <a:off x="685800" y="6020000"/>
-            <a:ext cx="10789920" cy="240000"/>
+            <a:off x="685800" y="5673847"/>
+            <a:ext cx="6200000" cy="240000"/>
           </a:xfrm>
           <a:prstGeom prst="rect">
             <a:avLst/>
@@ -7242,6 +7242,105 @@
                 </a:solidFill>
               </a:rPr>
               <a:t>Figure extraite du mémoire — taille des corpus, déséquilibre de genre, répartition des notes</a:t>
+            </a:r>
+          </a:p>
+        </p:txBody>
+      </p:sp>
+      <p:sp>
+        <p:nvSpPr>
+          <p:cNvPr id="12" name="TextBox 11"/>
+          <p:cNvSpPr txBox="1"/>
+          <p:nvPr/>
+        </p:nvSpPr>
+        <p:spPr>
+          <a:xfrm>
+            <a:off x="7135800" y="1500000"/>
+            <a:ext cx="4339920" cy="4413847"/>
+          </a:xfrm>
+          <a:prstGeom prst="rect">
+            <a:avLst/>
+          </a:prstGeom>
+          <a:noFill/>
+        </p:spPr>
+        <p:txBody>
+          <a:bodyPr wrap="square">
+            <a:spAutoFit/>
+          </a:bodyPr>
+          <a:lstStyle/>
+          <a:p>
+            <a:pPr>
+              <a:spcAft>
+                <a:spcPts val="1259"/>
+              </a:spcAft>
+            </a:pPr>
+            <a:r>
+              <a:rPr sz="1700" b="1" i="0">
+                <a:solidFill>
+                  <a:srgbClr val="63003C"/>
+                </a:solidFill>
+                <a:latin typeface="Georgia"/>
+              </a:rPr>
+              <a:t>Pourquoi ce déséquilibre ?</a:t>
+            </a:r>
+          </a:p>
+          <a:p>
+            <a:pPr>
+              <a:spcAft>
+                <a:spcPts val="866"/>
+              </a:spcAft>
+            </a:pPr>
+            <a:r>
+              <a:rPr sz="1300" b="0" i="0">
+                <a:solidFill>
+                  <a:srgbClr val="1A1A1A"/>
+                </a:solidFill>
+              </a:rPr>
+              <a:t>Sénégal — femmes chercheuses : 10 % (2006) → 29 % (2015)</a:t>
+            </a:r>
+          </a:p>
+          <a:p>
+            <a:pPr>
+              <a:spcAft>
+                <a:spcPts val="866"/>
+              </a:spcAft>
+            </a:pPr>
+            <a:r>
+              <a:rPr sz="1300" b="0" i="0">
+                <a:solidFill>
+                  <a:srgbClr val="1A1A1A"/>
+                </a:solidFill>
+              </a:rPr>
+              <a:t>Canada — femmes en génie informatique/logiciel : ~10–14 %</a:t>
+            </a:r>
+          </a:p>
+          <a:p>
+            <a:pPr>
+              <a:spcAft>
+                <a:spcPts val="1259"/>
+              </a:spcAft>
+            </a:pPr>
+            <a:r>
+              <a:rPr sz="1300" b="0" i="0">
+                <a:solidFill>
+                  <a:srgbClr val="1A1A1A"/>
+                </a:solidFill>
+              </a:rPr>
+              <a:t>France — femmes dans les métiers techniques du numérique : 17 % (2024)</a:t>
+            </a:r>
+          </a:p>
+          <a:p>
+            <a:pPr>
+              <a:spcAft>
+                <a:spcPts val="1102"/>
+              </a:spcAft>
+            </a:pPr>
+            <a:r>
+              <a:rPr sz="1200" b="0" i="1">
+                <a:solidFill>
+                  <a:srgbClr val="555555"/>
+                </a:solidFill>
+              </a:rPr>
+              <a:t>Un phénomène structurel mondial — pas un artefact des données.</a:t>
             </a:r>
           </a:p>
         </p:txBody>

</xml_diff>

<commit_message>
Renomme le bloc pays en "Exemple des pays où j'ai vécu" et ajoute une transition
"Pourquoi ce déséquilibre ?" surclaimait une explication causale ; le
nouveau titre présente honnêtement ces trois pays comme des exemples
vécus. Ajoute une phrase de transition reliant les chiffres de la
figure (29% F, 19% d'autrices) à ces exemples personnels.
</commit_message>
<xml_diff>
--- a/presentation/AURORA_Soutenance_FR.pptx
+++ b/presentation/AURORA_Soutenance_FR.pptx
@@ -7270,7 +7270,7 @@
           <a:p>
             <a:pPr>
               <a:spcAft>
-                <a:spcPts val="1259"/>
+                <a:spcPts val="1102"/>
               </a:spcAft>
             </a:pPr>
             <a:r>
@@ -7280,7 +7280,22 @@
                 </a:solidFill>
                 <a:latin typeface="Georgia"/>
               </a:rPr>
-              <a:t>Pourquoi ce déséquilibre ?</a:t>
+              <a:t>Exemple des pays où j'ai vécu</a:t>
+            </a:r>
+          </a:p>
+          <a:p>
+            <a:pPr>
+              <a:spcAft>
+                <a:spcPts val="1417"/>
+              </a:spcAft>
+            </a:pPr>
+            <a:r>
+              <a:rPr sz="1200" b="0" i="1">
+                <a:solidFill>
+                  <a:srgbClr val="555555"/>
+                </a:solidFill>
+              </a:rPr>
+              <a:t>Le déséquilibre de genre visible dans nos données (29 % F sur MovieLens, 19 % d'autrices sur OpenAlex) fait écho à une réalité que j'ai observée dans mon propre parcours :</a:t>
             </a:r>
           </a:p>
           <a:p>
@@ -7316,7 +7331,7 @@
           <a:p>
             <a:pPr>
               <a:spcAft>
-                <a:spcPts val="1259"/>
+                <a:spcPts val="0"/>
               </a:spcAft>
             </a:pPr>
             <a:r>
@@ -7326,21 +7341,6 @@
                 </a:solidFill>
               </a:rPr>
               <a:t>France — femmes dans les métiers techniques du numérique : 17 % (2024)</a:t>
-            </a:r>
-          </a:p>
-          <a:p>
-            <a:pPr>
-              <a:spcAft>
-                <a:spcPts val="1102"/>
-              </a:spcAft>
-            </a:pPr>
-            <a:r>
-              <a:rPr sz="1200" b="0" i="1">
-                <a:solidFill>
-                  <a:srgbClr val="555555"/>
-                </a:solidFill>
-              </a:rPr>
-              <a:t>Un phénomène structurel mondial — pas un artefact des données.</a:t>
             </a:r>
           </a:p>
         </p:txBody>

</xml_diff>

<commit_message>
Ajoute des images aux diapos Approche (graphe biparti + coarsening G→G')
Diapo 5 (Graphe et Métriques EDI) : ajoute le graphe biparti jouet
annoté (u,i, arête, poids, attribut sensible) qui n'avait aucun support
visuel jusqu'ici.

Diapo 6 (AURORA) : remplace ce même graphe par un nouveau schéma
avant/après illustrant le coarsening lui-même — G original (4
utilisateurs) vs G' résumé (2 super-nœuds, poids recalculés par
moyenne) — plus cohérent avec le contenu de cette diapo (fusion,
contraintes EDI, budget de fusion).
</commit_message>
<xml_diff>
--- a/presentation/AURORA_Soutenance_FR.pptx
+++ b/presentation/AURORA_Soutenance_FR.pptx
@@ -6767,6 +6767,30 @@
           </a:p>
         </p:txBody>
       </p:sp>
+      <p:pic>
+        <p:nvPicPr>
+          <p:cNvPr id="6" name="Picture 5" descr="image.png"/>
+          <p:cNvPicPr>
+            <a:picLocks noChangeAspect="1"/>
+          </p:cNvPicPr>
+          <p:nvPr/>
+        </p:nvPicPr>
+        <p:blipFill>
+          <a:blip r:embed="rId3"/>
+          <a:stretch>
+            <a:fillRect/>
+          </a:stretch>
+        </p:blipFill>
+        <p:spPr>
+          <a:xfrm>
+            <a:off x="3219450" y="3919220"/>
+            <a:ext cx="5753100" cy="2298700"/>
+          </a:xfrm>
+          <a:prstGeom prst="rect">
+            <a:avLst/>
+          </a:prstGeom>
+        </p:spPr>
+      </p:pic>
     </p:spTree>
   </p:cSld>
   <p:clrMapOvr>
@@ -7022,28 +7046,22 @@
       </p:sp>
       <p:pic>
         <p:nvPicPr>
-          <p:cNvPr id="6" name="Image 5">
-            <a:extLst>
-              <a:ext uri="{FF2B5EF4-FFF2-40B4-BE49-F238E27FC236}">
-                <a16:creationId xmlns:a16="http://schemas.microsoft.com/office/drawing/2014/main" id="{DBB68A0D-A701-D00E-842C-777FCC5079D7}"/>
-              </a:ext>
-            </a:extLst>
-          </p:cNvPr>
+          <p:cNvPr id="6" name="Picture 5" descr="g_gprime.png"/>
           <p:cNvPicPr>
             <a:picLocks noChangeAspect="1"/>
           </p:cNvPicPr>
           <p:nvPr/>
         </p:nvPicPr>
         <p:blipFill>
-          <a:blip r:embed="rId2"/>
+          <a:blip r:embed="rId3"/>
           <a:stretch>
             <a:fillRect/>
           </a:stretch>
         </p:blipFill>
         <p:spPr>
           <a:xfrm>
-            <a:off x="2762250" y="3919220"/>
-            <a:ext cx="5753100" cy="2298700"/>
+            <a:off x="2446000" y="3919220"/>
+            <a:ext cx="7300000" cy="2358415"/>
           </a:xfrm>
           <a:prstGeom prst="rect">
             <a:avLst/>

</xml_diff>

<commit_message>
Aligne la stat Sénégal sur le domaine tech et précise l'objectif d'AURORA
Diapo 7 : remplace "femmes chercheuses" (tous domaines, 10%->29%) par
"entreprises numériques dirigées par des femmes" (15%, 2019, Ministère
de l'Économie numérique du Sénégal) — pour rester dans le même domaine
tech/numérique que les stats Canada (génie informatique) et France
(métiers techniques du numérique).

Diapo 6 : ajoute une puce "Objectif" avant le budget de fusion,
précisant que parmi les fusions respectant les contraintes EDI, celle
retenue minimise la perte structurelle L(G,G') — cohérent avec la
distinction contrainte/objectif validée par Malek.
</commit_message>
<xml_diff>
--- a/presentation/AURORA_Soutenance_FR.pptx
+++ b/presentation/AURORA_Soutenance_FR.pptx
@@ -6945,6 +6945,21 @@
               </a:defRPr>
             </a:pPr>
             <a:r>
+              <a:t>•  Objectif : parmi les fusions respectant ces contraintes, celle retenue minimise la perte structurelle L(G,G') (écart entre poids d'arêtes originaux et reconstruits)</a:t>
+            </a:r>
+          </a:p>
+          <a:p>
+            <a:pPr>
+              <a:spcAft>
+                <a:spcPts val="1400"/>
+              </a:spcAft>
+              <a:defRPr sz="1900">
+                <a:solidFill>
+                  <a:srgbClr val="1A1A1A"/>
+                </a:solidFill>
+              </a:defRPr>
+            </a:pPr>
+            <a:r>
               <a:t>•  Budget de fusion = fraction fixe de |U| → même taux de compression quelle que soit l'échelle</a:t>
             </a:r>
           </a:p>
@@ -7328,7 +7343,7 @@
                   <a:srgbClr val="1A1A1A"/>
                 </a:solidFill>
               </a:rPr>
-              <a:t>Sénégal — femmes chercheuses : 10 % (2006) → 29 % (2015)</a:t>
+              <a:t>Sénégal — entreprises numériques dirigées par des femmes : 15 % (2019)</a:t>
             </a:r>
           </a:p>
           <a:p>

</xml_diff>

<commit_message>
Retire la vidéo intégrée de la diapo 12 et la bande de texte associée
La vidéo intégrée directement dans la diapositive faisait grimper le
fichier à 59 Mo ; retirée (le lien vers le site remplace déjà cette
fonction ailleurs). Le bandeau "vidéo hors ligne, voir en ligne" ajouté
temporairement est aussi retiré à la demande de l'utilisatrice.
</commit_message>
<xml_diff>
--- a/presentation/AURORA_Soutenance_FR.pptx
+++ b/presentation/AURORA_Soutenance_FR.pptx
@@ -5,7 +5,7 @@
     <p:sldMasterId id="2147483648" r:id="rId1"/>
   </p:sldMasterIdLst>
   <p:notesMasterIdLst>
-    <p:notesMasterId r:id="rId16"/>
+    <p:notesMasterId r:id="rId17"/>
   </p:notesMasterIdLst>
   <p:sldIdLst>
     <p:sldId id="256" r:id="rId2"/>
@@ -19,9 +19,10 @@
     <p:sldId id="262" r:id="rId10"/>
     <p:sldId id="263" r:id="rId11"/>
     <p:sldId id="264" r:id="rId12"/>
-    <p:sldId id="265" r:id="rId13"/>
-    <p:sldId id="266" r:id="rId14"/>
-    <p:sldId id="267" r:id="rId15"/>
+    <p:sldId id="270" r:id="rId13"/>
+    <p:sldId id="265" r:id="rId14"/>
+    <p:sldId id="266" r:id="rId15"/>
+    <p:sldId id="267" r:id="rId16"/>
   </p:sldIdLst>
   <p:sldSz cx="12192000" cy="6858000"/>
   <p:notesSz cx="6858000" cy="9144000"/>
@@ -221,7 +222,7 @@
           <a:p>
             <a:fld id="{BB4E32DD-2BBF-E54C-AA90-1FF8494E5F3B}" type="datetimeFigureOut">
               <a:rPr lang="fr-FR" smtClean="0"/>
-              <a:t>31/08/2026</a:t>
+              <a:t>03/09/2026</a:t>
             </a:fld>
             <a:endParaRPr lang="fr-FR"/>
           </a:p>
@@ -507,24 +508,24 @@
       </p:grpSpPr>
       <p:sp>
         <p:nvSpPr>
-          <p:cNvPr id="2" name="Slide Image Placeholder 1"/>
+          <p:cNvPr id="2" name="Espace réservé de l'image des diapositives 1"/>
           <p:cNvSpPr>
             <a:spLocks noGrp="1" noRot="1" noChangeAspect="1"/>
           </p:cNvSpPr>
           <p:nvPr>
-            <p:ph type="sldImg" idx="2"/>
+            <p:ph type="sldImg"/>
           </p:nvPr>
         </p:nvSpPr>
         <p:spPr/>
       </p:sp>
       <p:sp>
         <p:nvSpPr>
-          <p:cNvPr id="3" name="Notes Placeholder 2"/>
+          <p:cNvPr id="3" name="Espace réservé des notes 2"/>
           <p:cNvSpPr>
             <a:spLocks noGrp="1"/>
           </p:cNvSpPr>
           <p:nvPr>
-            <p:ph type="body" sz="quarter" idx="3"/>
+            <p:ph type="body" idx="1"/>
           </p:nvPr>
         </p:nvSpPr>
         <p:spPr/>
@@ -532,392 +533,13 @@
           <a:bodyPr/>
           <a:lstStyle/>
           <a:p>
-            <a:r>
-              <a:rPr dirty="0"/>
-              <a:t>SCRUF-D (Aird et al. 2023/2024) est le travail </a:t>
-            </a:r>
-            <a:r>
-              <a:rPr dirty="0" err="1"/>
-              <a:t>conceptuellement</a:t>
-            </a:r>
-            <a:r>
-              <a:rPr dirty="0"/>
-              <a:t> le plus </a:t>
-            </a:r>
-            <a:r>
-              <a:rPr dirty="0" err="1"/>
-              <a:t>proche</a:t>
-            </a:r>
-            <a:r>
-              <a:rPr dirty="0"/>
-              <a:t> : </a:t>
-            </a:r>
-            <a:r>
-              <a:rPr dirty="0" err="1"/>
-              <a:t>chaque</a:t>
-            </a:r>
-            <a:r>
-              <a:rPr dirty="0"/>
-              <a:t> preoccupation </a:t>
-            </a:r>
-            <a:r>
-              <a:rPr dirty="0" err="1"/>
-              <a:t>d'equite</a:t>
-            </a:r>
-            <a:r>
-              <a:rPr dirty="0"/>
-              <a:t> y est un agent qui vote (Borda/Copeland/Ranked Pairs) aux cotes du </a:t>
-            </a:r>
-            <a:r>
-              <a:rPr dirty="0" err="1"/>
-              <a:t>recommandeur</a:t>
-            </a:r>
-            <a:r>
-              <a:rPr dirty="0"/>
-              <a:t>, au moment de </a:t>
-            </a:r>
-            <a:r>
-              <a:rPr dirty="0" err="1"/>
-              <a:t>produire</a:t>
-            </a:r>
-            <a:r>
-              <a:rPr dirty="0"/>
-              <a:t> le </a:t>
-            </a:r>
-            <a:r>
-              <a:rPr dirty="0" err="1"/>
-              <a:t>classement</a:t>
-            </a:r>
-            <a:r>
-              <a:rPr dirty="0"/>
-              <a:t> final -- un post-</a:t>
-            </a:r>
-            <a:r>
-              <a:rPr dirty="0" err="1"/>
-              <a:t>traitement</a:t>
-            </a:r>
-            <a:r>
-              <a:rPr dirty="0"/>
-              <a:t>, </a:t>
-            </a:r>
-            <a:r>
-              <a:rPr dirty="0" err="1"/>
-              <a:t>alors</a:t>
-            </a:r>
-            <a:r>
-              <a:rPr dirty="0"/>
-              <a:t> </a:t>
-            </a:r>
-            <a:r>
-              <a:rPr dirty="0" err="1"/>
-              <a:t>qu'AURORA</a:t>
-            </a:r>
-            <a:r>
-              <a:rPr dirty="0"/>
-              <a:t> agit </a:t>
-            </a:r>
-            <a:r>
-              <a:rPr dirty="0" err="1"/>
-              <a:t>en</a:t>
-            </a:r>
-            <a:r>
-              <a:rPr dirty="0"/>
-              <a:t> </a:t>
-            </a:r>
-            <a:r>
-              <a:rPr dirty="0" err="1"/>
-              <a:t>amont</a:t>
-            </a:r>
-            <a:r>
-              <a:rPr dirty="0"/>
-              <a:t> sur la structure du </a:t>
-            </a:r>
-            <a:r>
-              <a:rPr dirty="0" err="1"/>
-              <a:t>graphe</a:t>
-            </a:r>
-            <a:r>
-              <a:rPr dirty="0"/>
-              <a:t> resume. Non </a:t>
-            </a:r>
-            <a:r>
-              <a:rPr dirty="0" err="1"/>
-              <a:t>implemente</a:t>
-            </a:r>
-            <a:r>
-              <a:rPr dirty="0"/>
-              <a:t> </a:t>
-            </a:r>
-            <a:r>
-              <a:rPr dirty="0" err="1"/>
-              <a:t>comme</a:t>
-            </a:r>
-            <a:r>
-              <a:rPr dirty="0"/>
-              <a:t> </a:t>
-            </a:r>
-            <a:r>
-              <a:rPr dirty="0" err="1"/>
-              <a:t>referentiel</a:t>
-            </a:r>
-            <a:r>
-              <a:rPr dirty="0"/>
-              <a:t> experimental car il </a:t>
-            </a:r>
-            <a:r>
-              <a:rPr dirty="0" err="1"/>
-              <a:t>exige</a:t>
-            </a:r>
-            <a:r>
-              <a:rPr dirty="0"/>
-              <a:t> </a:t>
-            </a:r>
-            <a:r>
-              <a:rPr dirty="0" err="1"/>
-              <a:t>une</a:t>
-            </a:r>
-            <a:r>
-              <a:rPr dirty="0"/>
-              <a:t> </a:t>
-            </a:r>
-            <a:r>
-              <a:rPr dirty="0" err="1"/>
-              <a:t>fonction</a:t>
-            </a:r>
-            <a:r>
-              <a:rPr dirty="0"/>
-              <a:t> </a:t>
-            </a:r>
-            <a:r>
-              <a:rPr dirty="0" err="1"/>
-              <a:t>d'utilite</a:t>
-            </a:r>
-            <a:r>
-              <a:rPr dirty="0"/>
-              <a:t> par preoccupation </a:t>
-            </a:r>
-            <a:r>
-              <a:rPr dirty="0" err="1"/>
-              <a:t>d'equite</a:t>
-            </a:r>
-            <a:r>
-              <a:rPr dirty="0"/>
-              <a:t> et un </a:t>
-            </a:r>
-            <a:r>
-              <a:rPr dirty="0" err="1"/>
-              <a:t>mecanisme</a:t>
-            </a:r>
-            <a:r>
-              <a:rPr dirty="0"/>
-              <a:t> de </a:t>
-            </a:r>
-            <a:r>
-              <a:rPr dirty="0" err="1"/>
-              <a:t>negociation</a:t>
-            </a:r>
-            <a:r>
-              <a:rPr dirty="0"/>
-              <a:t> inter-agents a </a:t>
-            </a:r>
-            <a:r>
-              <a:rPr dirty="0" err="1"/>
-              <a:t>concevoir</a:t>
-            </a:r>
-            <a:r>
-              <a:rPr dirty="0"/>
-              <a:t> et </a:t>
-            </a:r>
-            <a:r>
-              <a:rPr dirty="0" err="1"/>
-              <a:t>calibrer</a:t>
-            </a:r>
-            <a:r>
-              <a:rPr dirty="0"/>
-              <a:t> </a:t>
-            </a:r>
-            <a:r>
-              <a:rPr dirty="0" err="1"/>
-              <a:t>separement</a:t>
-            </a:r>
-            <a:r>
-              <a:rPr dirty="0"/>
-              <a:t> pour chacun des 4 corpus -- </a:t>
-            </a:r>
-            <a:r>
-              <a:rPr dirty="0" err="1"/>
-              <a:t>une</a:t>
-            </a:r>
-            <a:r>
-              <a:rPr dirty="0"/>
-              <a:t> contribution </a:t>
-            </a:r>
-            <a:r>
-              <a:rPr dirty="0" err="1"/>
-              <a:t>methodologique</a:t>
-            </a:r>
-            <a:r>
-              <a:rPr dirty="0"/>
-              <a:t> a part </a:t>
-            </a:r>
-            <a:r>
-              <a:rPr dirty="0" err="1"/>
-              <a:t>entiere</a:t>
-            </a:r>
-            <a:r>
-              <a:rPr dirty="0"/>
-              <a:t>, </a:t>
-            </a:r>
-            <a:r>
-              <a:rPr dirty="0" err="1"/>
-              <a:t>distincte</a:t>
-            </a:r>
-            <a:r>
-              <a:rPr dirty="0"/>
-              <a:t> du </a:t>
-            </a:r>
-            <a:r>
-              <a:rPr dirty="0" err="1"/>
-              <a:t>protocole</a:t>
-            </a:r>
-            <a:r>
-              <a:rPr dirty="0"/>
-              <a:t> a </a:t>
-            </a:r>
-            <a:r>
-              <a:rPr dirty="0" err="1"/>
-              <a:t>metriques</a:t>
-            </a:r>
-            <a:r>
-              <a:rPr dirty="0"/>
-              <a:t> EDI fixes </a:t>
-            </a:r>
-            <a:r>
-              <a:rPr dirty="0" err="1"/>
-              <a:t>utilise</a:t>
-            </a:r>
-            <a:r>
-              <a:rPr dirty="0"/>
-              <a:t> </a:t>
-            </a:r>
-            <a:r>
-              <a:rPr dirty="0" err="1"/>
-              <a:t>ici</a:t>
-            </a:r>
-            <a:r>
-              <a:rPr dirty="0"/>
-              <a:t>. Fair Re-rank (</a:t>
-            </a:r>
-            <a:r>
-              <a:rPr dirty="0" err="1"/>
-              <a:t>notre</a:t>
-            </a:r>
-            <a:r>
-              <a:rPr dirty="0"/>
-              <a:t> </a:t>
-            </a:r>
-            <a:r>
-              <a:rPr dirty="0" err="1"/>
-              <a:t>referentiel</a:t>
-            </a:r>
-            <a:r>
-              <a:rPr dirty="0"/>
-              <a:t> de post-</a:t>
-            </a:r>
-            <a:r>
-              <a:rPr dirty="0" err="1"/>
-              <a:t>traitement</a:t>
-            </a:r>
-            <a:r>
-              <a:rPr dirty="0"/>
-              <a:t>) </a:t>
-            </a:r>
-            <a:r>
-              <a:rPr dirty="0" err="1"/>
-              <a:t>reste</a:t>
-            </a:r>
-            <a:r>
-              <a:rPr dirty="0"/>
-              <a:t> comparable dans </a:t>
-            </a:r>
-            <a:r>
-              <a:rPr dirty="0" err="1"/>
-              <a:t>l'esprit</a:t>
-            </a:r>
-            <a:r>
-              <a:rPr dirty="0"/>
-              <a:t> sans </a:t>
-            </a:r>
-            <a:r>
-              <a:rPr dirty="0" err="1"/>
-              <a:t>requerir</a:t>
-            </a:r>
-            <a:r>
-              <a:rPr dirty="0"/>
-              <a:t> </a:t>
-            </a:r>
-            <a:r>
-              <a:rPr dirty="0" err="1"/>
-              <a:t>cette</a:t>
-            </a:r>
-            <a:r>
-              <a:rPr dirty="0"/>
-              <a:t> architecture multi-agents. Une implementation </a:t>
-            </a:r>
-            <a:r>
-              <a:rPr dirty="0" err="1"/>
-              <a:t>fidele</a:t>
-            </a:r>
-            <a:r>
-              <a:rPr dirty="0"/>
-              <a:t> de SCRUF-D est </a:t>
-            </a:r>
-            <a:r>
-              <a:rPr dirty="0" err="1"/>
-              <a:t>laissee</a:t>
-            </a:r>
-            <a:r>
-              <a:rPr dirty="0"/>
-              <a:t> </a:t>
-            </a:r>
-            <a:r>
-              <a:rPr dirty="0" err="1"/>
-              <a:t>comme</a:t>
-            </a:r>
-            <a:r>
-              <a:rPr dirty="0"/>
-              <a:t> </a:t>
-            </a:r>
-            <a:r>
-              <a:rPr dirty="0" err="1"/>
-              <a:t>referentiel</a:t>
-            </a:r>
-            <a:r>
-              <a:rPr dirty="0"/>
-              <a:t> </a:t>
-            </a:r>
-            <a:r>
-              <a:rPr dirty="0" err="1"/>
-              <a:t>prioritaire</a:t>
-            </a:r>
-            <a:r>
-              <a:rPr dirty="0"/>
-              <a:t> pour un travail </a:t>
-            </a:r>
-            <a:r>
-              <a:rPr dirty="0" err="1"/>
-              <a:t>futur</a:t>
-            </a:r>
-            <a:r>
-              <a:rPr dirty="0"/>
-              <a:t>.</a:t>
-            </a:r>
-          </a:p>
-        </p:txBody>
-      </p:sp>
-      <p:sp>
-        <p:nvSpPr>
-          <p:cNvPr id="4" name="Slide Number Placeholder 3"/>
+            <a:endParaRPr lang="fr-FR" dirty="0"/>
+          </a:p>
+        </p:txBody>
+      </p:sp>
+      <p:sp>
+        <p:nvSpPr>
+          <p:cNvPr id="4" name="Espace réservé du numéro de diapositive 3"/>
           <p:cNvSpPr>
             <a:spLocks noGrp="1"/>
           </p:cNvSpPr>
@@ -926,8 +548,24 @@
           </p:nvPr>
         </p:nvSpPr>
         <p:spPr/>
+        <p:txBody>
+          <a:bodyPr/>
+          <a:lstStyle/>
+          <a:p>
+            <a:fld id="{EC9DD9CB-6CB9-4048-8E70-4A785DF481B5}" type="slidenum">
+              <a:rPr lang="fr-FR" smtClean="0"/>
+              <a:t>1</a:t>
+            </a:fld>
+            <a:endParaRPr lang="fr-FR"/>
+          </a:p>
+        </p:txBody>
       </p:sp>
     </p:spTree>
+    <p:extLst>
+      <p:ext uri="{BB962C8B-B14F-4D97-AF65-F5344CB8AC3E}">
+        <p14:creationId xmlns:p14="http://schemas.microsoft.com/office/powerpoint/2010/main" val="2781993123"/>
+      </p:ext>
+    </p:extLst>
   </p:cSld>
   <p:clrMapOvr>
     <a:masterClrMapping/>
@@ -954,6 +592,453 @@
       </p:grpSpPr>
       <p:sp>
         <p:nvSpPr>
+          <p:cNvPr id="2" name="Slide Image Placeholder 1"/>
+          <p:cNvSpPr>
+            <a:spLocks noGrp="1" noRot="1" noChangeAspect="1"/>
+          </p:cNvSpPr>
+          <p:nvPr>
+            <p:ph type="sldImg" idx="2"/>
+          </p:nvPr>
+        </p:nvSpPr>
+        <p:spPr/>
+      </p:sp>
+      <p:sp>
+        <p:nvSpPr>
+          <p:cNvPr id="3" name="Notes Placeholder 2"/>
+          <p:cNvSpPr>
+            <a:spLocks noGrp="1"/>
+          </p:cNvSpPr>
+          <p:nvPr>
+            <p:ph type="body" sz="quarter" idx="3"/>
+          </p:nvPr>
+        </p:nvSpPr>
+        <p:spPr/>
+        <p:txBody>
+          <a:bodyPr/>
+          <a:lstStyle/>
+          <a:p>
+            <a:r>
+              <a:rPr dirty="0"/>
+              <a:t>SCRUF-D (Aird et al. 2023/2024) est le travail </a:t>
+            </a:r>
+            <a:r>
+              <a:rPr dirty="0" err="1"/>
+              <a:t>conceptuellement</a:t>
+            </a:r>
+            <a:r>
+              <a:rPr dirty="0"/>
+              <a:t> le plus </a:t>
+            </a:r>
+            <a:r>
+              <a:rPr dirty="0" err="1"/>
+              <a:t>proche</a:t>
+            </a:r>
+            <a:r>
+              <a:rPr dirty="0"/>
+              <a:t> : </a:t>
+            </a:r>
+            <a:r>
+              <a:rPr dirty="0" err="1"/>
+              <a:t>chaque</a:t>
+            </a:r>
+            <a:r>
+              <a:rPr dirty="0"/>
+              <a:t> preoccupation </a:t>
+            </a:r>
+            <a:r>
+              <a:rPr dirty="0" err="1"/>
+              <a:t>d'equite</a:t>
+            </a:r>
+            <a:r>
+              <a:rPr dirty="0"/>
+              <a:t> y est un agent qui vote (Borda/Copeland/Ranked Pairs) aux cotes du </a:t>
+            </a:r>
+            <a:r>
+              <a:rPr dirty="0" err="1"/>
+              <a:t>recommandeur</a:t>
+            </a:r>
+            <a:r>
+              <a:rPr dirty="0"/>
+              <a:t>, au moment de </a:t>
+            </a:r>
+            <a:r>
+              <a:rPr dirty="0" err="1"/>
+              <a:t>produire</a:t>
+            </a:r>
+            <a:r>
+              <a:rPr dirty="0"/>
+              <a:t> le </a:t>
+            </a:r>
+            <a:r>
+              <a:rPr dirty="0" err="1"/>
+              <a:t>classement</a:t>
+            </a:r>
+            <a:r>
+              <a:rPr dirty="0"/>
+              <a:t> final -- un post-</a:t>
+            </a:r>
+            <a:r>
+              <a:rPr dirty="0" err="1"/>
+              <a:t>traitement</a:t>
+            </a:r>
+            <a:r>
+              <a:rPr dirty="0"/>
+              <a:t>, </a:t>
+            </a:r>
+            <a:r>
+              <a:rPr dirty="0" err="1"/>
+              <a:t>alors</a:t>
+            </a:r>
+            <a:r>
+              <a:rPr dirty="0"/>
+              <a:t> </a:t>
+            </a:r>
+            <a:r>
+              <a:rPr dirty="0" err="1"/>
+              <a:t>qu'AURORA</a:t>
+            </a:r>
+            <a:r>
+              <a:rPr dirty="0"/>
+              <a:t> agit </a:t>
+            </a:r>
+            <a:r>
+              <a:rPr dirty="0" err="1"/>
+              <a:t>en</a:t>
+            </a:r>
+            <a:r>
+              <a:rPr dirty="0"/>
+              <a:t> </a:t>
+            </a:r>
+            <a:r>
+              <a:rPr dirty="0" err="1"/>
+              <a:t>amont</a:t>
+            </a:r>
+            <a:r>
+              <a:rPr dirty="0"/>
+              <a:t> sur la structure du </a:t>
+            </a:r>
+            <a:r>
+              <a:rPr dirty="0" err="1"/>
+              <a:t>graphe</a:t>
+            </a:r>
+            <a:r>
+              <a:rPr dirty="0"/>
+              <a:t> resume. Non </a:t>
+            </a:r>
+            <a:r>
+              <a:rPr dirty="0" err="1"/>
+              <a:t>implemente</a:t>
+            </a:r>
+            <a:r>
+              <a:rPr dirty="0"/>
+              <a:t> </a:t>
+            </a:r>
+            <a:r>
+              <a:rPr dirty="0" err="1"/>
+              <a:t>comme</a:t>
+            </a:r>
+            <a:r>
+              <a:rPr dirty="0"/>
+              <a:t> </a:t>
+            </a:r>
+            <a:r>
+              <a:rPr dirty="0" err="1"/>
+              <a:t>referentiel</a:t>
+            </a:r>
+            <a:r>
+              <a:rPr dirty="0"/>
+              <a:t> experimental car il </a:t>
+            </a:r>
+            <a:r>
+              <a:rPr dirty="0" err="1"/>
+              <a:t>exige</a:t>
+            </a:r>
+            <a:r>
+              <a:rPr dirty="0"/>
+              <a:t> </a:t>
+            </a:r>
+            <a:r>
+              <a:rPr dirty="0" err="1"/>
+              <a:t>une</a:t>
+            </a:r>
+            <a:r>
+              <a:rPr dirty="0"/>
+              <a:t> </a:t>
+            </a:r>
+            <a:r>
+              <a:rPr dirty="0" err="1"/>
+              <a:t>fonction</a:t>
+            </a:r>
+            <a:r>
+              <a:rPr dirty="0"/>
+              <a:t> </a:t>
+            </a:r>
+            <a:r>
+              <a:rPr dirty="0" err="1"/>
+              <a:t>d'utilite</a:t>
+            </a:r>
+            <a:r>
+              <a:rPr dirty="0"/>
+              <a:t> par preoccupation </a:t>
+            </a:r>
+            <a:r>
+              <a:rPr dirty="0" err="1"/>
+              <a:t>d'equite</a:t>
+            </a:r>
+            <a:r>
+              <a:rPr dirty="0"/>
+              <a:t> et un </a:t>
+            </a:r>
+            <a:r>
+              <a:rPr dirty="0" err="1"/>
+              <a:t>mecanisme</a:t>
+            </a:r>
+            <a:r>
+              <a:rPr dirty="0"/>
+              <a:t> de </a:t>
+            </a:r>
+            <a:r>
+              <a:rPr dirty="0" err="1"/>
+              <a:t>negociation</a:t>
+            </a:r>
+            <a:r>
+              <a:rPr dirty="0"/>
+              <a:t> inter-agents a </a:t>
+            </a:r>
+            <a:r>
+              <a:rPr dirty="0" err="1"/>
+              <a:t>concevoir</a:t>
+            </a:r>
+            <a:r>
+              <a:rPr dirty="0"/>
+              <a:t> et </a:t>
+            </a:r>
+            <a:r>
+              <a:rPr dirty="0" err="1"/>
+              <a:t>calibrer</a:t>
+            </a:r>
+            <a:r>
+              <a:rPr dirty="0"/>
+              <a:t> </a:t>
+            </a:r>
+            <a:r>
+              <a:rPr dirty="0" err="1"/>
+              <a:t>separement</a:t>
+            </a:r>
+            <a:r>
+              <a:rPr dirty="0"/>
+              <a:t> pour chacun des 4 corpus -- </a:t>
+            </a:r>
+            <a:r>
+              <a:rPr dirty="0" err="1"/>
+              <a:t>une</a:t>
+            </a:r>
+            <a:r>
+              <a:rPr dirty="0"/>
+              <a:t> contribution </a:t>
+            </a:r>
+            <a:r>
+              <a:rPr dirty="0" err="1"/>
+              <a:t>methodologique</a:t>
+            </a:r>
+            <a:r>
+              <a:rPr dirty="0"/>
+              <a:t> a part </a:t>
+            </a:r>
+            <a:r>
+              <a:rPr dirty="0" err="1"/>
+              <a:t>entiere</a:t>
+            </a:r>
+            <a:r>
+              <a:rPr dirty="0"/>
+              <a:t>, </a:t>
+            </a:r>
+            <a:r>
+              <a:rPr dirty="0" err="1"/>
+              <a:t>distincte</a:t>
+            </a:r>
+            <a:r>
+              <a:rPr dirty="0"/>
+              <a:t> du </a:t>
+            </a:r>
+            <a:r>
+              <a:rPr dirty="0" err="1"/>
+              <a:t>protocole</a:t>
+            </a:r>
+            <a:r>
+              <a:rPr dirty="0"/>
+              <a:t> a </a:t>
+            </a:r>
+            <a:r>
+              <a:rPr dirty="0" err="1"/>
+              <a:t>metriques</a:t>
+            </a:r>
+            <a:r>
+              <a:rPr dirty="0"/>
+              <a:t> EDI fixes </a:t>
+            </a:r>
+            <a:r>
+              <a:rPr dirty="0" err="1"/>
+              <a:t>utilise</a:t>
+            </a:r>
+            <a:r>
+              <a:rPr dirty="0"/>
+              <a:t> </a:t>
+            </a:r>
+            <a:r>
+              <a:rPr dirty="0" err="1"/>
+              <a:t>ici</a:t>
+            </a:r>
+            <a:r>
+              <a:rPr dirty="0"/>
+              <a:t>. Fair Re-rank (</a:t>
+            </a:r>
+            <a:r>
+              <a:rPr dirty="0" err="1"/>
+              <a:t>notre</a:t>
+            </a:r>
+            <a:r>
+              <a:rPr dirty="0"/>
+              <a:t> </a:t>
+            </a:r>
+            <a:r>
+              <a:rPr dirty="0" err="1"/>
+              <a:t>referentiel</a:t>
+            </a:r>
+            <a:r>
+              <a:rPr dirty="0"/>
+              <a:t> de post-</a:t>
+            </a:r>
+            <a:r>
+              <a:rPr dirty="0" err="1"/>
+              <a:t>traitement</a:t>
+            </a:r>
+            <a:r>
+              <a:rPr dirty="0"/>
+              <a:t>) </a:t>
+            </a:r>
+            <a:r>
+              <a:rPr dirty="0" err="1"/>
+              <a:t>reste</a:t>
+            </a:r>
+            <a:r>
+              <a:rPr dirty="0"/>
+              <a:t> comparable dans </a:t>
+            </a:r>
+            <a:r>
+              <a:rPr dirty="0" err="1"/>
+              <a:t>l'esprit</a:t>
+            </a:r>
+            <a:r>
+              <a:rPr dirty="0"/>
+              <a:t> sans </a:t>
+            </a:r>
+            <a:r>
+              <a:rPr dirty="0" err="1"/>
+              <a:t>requerir</a:t>
+            </a:r>
+            <a:r>
+              <a:rPr dirty="0"/>
+              <a:t> </a:t>
+            </a:r>
+            <a:r>
+              <a:rPr dirty="0" err="1"/>
+              <a:t>cette</a:t>
+            </a:r>
+            <a:r>
+              <a:rPr dirty="0"/>
+              <a:t> architecture multi-agents. Une implementation </a:t>
+            </a:r>
+            <a:r>
+              <a:rPr dirty="0" err="1"/>
+              <a:t>fidele</a:t>
+            </a:r>
+            <a:r>
+              <a:rPr dirty="0"/>
+              <a:t> de SCRUF-D est </a:t>
+            </a:r>
+            <a:r>
+              <a:rPr dirty="0" err="1"/>
+              <a:t>laissee</a:t>
+            </a:r>
+            <a:r>
+              <a:rPr dirty="0"/>
+              <a:t> </a:t>
+            </a:r>
+            <a:r>
+              <a:rPr dirty="0" err="1"/>
+              <a:t>comme</a:t>
+            </a:r>
+            <a:r>
+              <a:rPr dirty="0"/>
+              <a:t> </a:t>
+            </a:r>
+            <a:r>
+              <a:rPr dirty="0" err="1"/>
+              <a:t>referentiel</a:t>
+            </a:r>
+            <a:r>
+              <a:rPr dirty="0"/>
+              <a:t> </a:t>
+            </a:r>
+            <a:r>
+              <a:rPr dirty="0" err="1"/>
+              <a:t>prioritaire</a:t>
+            </a:r>
+            <a:r>
+              <a:rPr dirty="0"/>
+              <a:t> pour un travail </a:t>
+            </a:r>
+            <a:r>
+              <a:rPr dirty="0" err="1"/>
+              <a:t>futur</a:t>
+            </a:r>
+            <a:r>
+              <a:rPr dirty="0"/>
+              <a:t>.</a:t>
+            </a:r>
+          </a:p>
+        </p:txBody>
+      </p:sp>
+      <p:sp>
+        <p:nvSpPr>
+          <p:cNvPr id="4" name="Slide Number Placeholder 3"/>
+          <p:cNvSpPr>
+            <a:spLocks noGrp="1"/>
+          </p:cNvSpPr>
+          <p:nvPr>
+            <p:ph type="sldNum" sz="quarter" idx="5"/>
+          </p:nvPr>
+        </p:nvSpPr>
+        <p:spPr/>
+      </p:sp>
+    </p:spTree>
+  </p:cSld>
+  <p:clrMapOvr>
+    <a:masterClrMapping/>
+  </p:clrMapOvr>
+</p:notes>
+</file>
+
+<file path=ppt/notesSlides/notesSlide3.xml><?xml version="1.0" encoding="utf-8"?>
+<p:notes xmlns:a="http://schemas.openxmlformats.org/drawingml/2006/main" xmlns:r="http://schemas.openxmlformats.org/officeDocument/2006/relationships" xmlns:p="http://schemas.openxmlformats.org/presentationml/2006/main">
+  <p:cSld>
+    <p:spTree>
+      <p:nvGrpSpPr>
+        <p:cNvPr id="1" name=""/>
+        <p:cNvGrpSpPr/>
+        <p:nvPr/>
+      </p:nvGrpSpPr>
+      <p:grpSpPr>
+        <a:xfrm>
+          <a:off x="0" y="0"/>
+          <a:ext cx="0" cy="0"/>
+          <a:chOff x="0" y="0"/>
+          <a:chExt cx="0" cy="0"/>
+        </a:xfrm>
+      </p:grpSpPr>
+      <p:sp>
+        <p:nvSpPr>
           <p:cNvPr id="2" name="Espace réservé de l'image des diapositives 1"/>
           <p:cNvSpPr>
             <a:spLocks noGrp="1" noRot="1" noChangeAspect="1"/>
@@ -1019,7 +1104,7 @@
 </p:notes>
 </file>
 
-<file path=ppt/notesSlides/notesSlide3.xml><?xml version="1.0" encoding="utf-8"?>
+<file path=ppt/notesSlides/notesSlide4.xml><?xml version="1.0" encoding="utf-8"?>
 <p:notes xmlns:a="http://schemas.openxmlformats.org/drawingml/2006/main" xmlns:r="http://schemas.openxmlformats.org/officeDocument/2006/relationships" xmlns:p="http://schemas.openxmlformats.org/presentationml/2006/main">
   <p:cSld>
     <p:spTree>
@@ -1557,7 +1642,7 @@
           <a:p>
             <a:fld id="{5BCAD085-E8A6-8845-BD4E-CB4CCA059FC4}" type="datetimeFigureOut">
               <a:rPr lang="en-US" smtClean="0"/>
-              <a:t>8/31/26</a:t>
+              <a:t>9/3/26</a:t>
             </a:fld>
             <a:endParaRPr lang="en-US"/>
           </a:p>
@@ -1725,7 +1810,7 @@
           <a:p>
             <a:fld id="{5BCAD085-E8A6-8845-BD4E-CB4CCA059FC4}" type="datetimeFigureOut">
               <a:rPr lang="en-US" smtClean="0"/>
-              <a:t>8/31/26</a:t>
+              <a:t>9/3/26</a:t>
             </a:fld>
             <a:endParaRPr lang="en-US"/>
           </a:p>
@@ -1903,7 +1988,7 @@
           <a:p>
             <a:fld id="{5BCAD085-E8A6-8845-BD4E-CB4CCA059FC4}" type="datetimeFigureOut">
               <a:rPr lang="en-US" smtClean="0"/>
-              <a:t>8/31/26</a:t>
+              <a:t>9/3/26</a:t>
             </a:fld>
             <a:endParaRPr lang="en-US"/>
           </a:p>
@@ -2071,7 +2156,7 @@
           <a:p>
             <a:fld id="{5BCAD085-E8A6-8845-BD4E-CB4CCA059FC4}" type="datetimeFigureOut">
               <a:rPr lang="en-US" smtClean="0"/>
-              <a:t>8/31/26</a:t>
+              <a:t>9/3/26</a:t>
             </a:fld>
             <a:endParaRPr lang="en-US"/>
           </a:p>
@@ -2316,7 +2401,7 @@
           <a:p>
             <a:fld id="{5BCAD085-E8A6-8845-BD4E-CB4CCA059FC4}" type="datetimeFigureOut">
               <a:rPr lang="en-US" smtClean="0"/>
-              <a:t>8/31/26</a:t>
+              <a:t>9/3/26</a:t>
             </a:fld>
             <a:endParaRPr lang="en-US"/>
           </a:p>
@@ -2601,7 +2686,7 @@
           <a:p>
             <a:fld id="{5BCAD085-E8A6-8845-BD4E-CB4CCA059FC4}" type="datetimeFigureOut">
               <a:rPr lang="en-US" smtClean="0"/>
-              <a:t>8/31/26</a:t>
+              <a:t>9/3/26</a:t>
             </a:fld>
             <a:endParaRPr lang="en-US"/>
           </a:p>
@@ -3020,7 +3105,7 @@
           <a:p>
             <a:fld id="{5BCAD085-E8A6-8845-BD4E-CB4CCA059FC4}" type="datetimeFigureOut">
               <a:rPr lang="en-US" smtClean="0"/>
-              <a:t>8/31/26</a:t>
+              <a:t>9/3/26</a:t>
             </a:fld>
             <a:endParaRPr lang="en-US"/>
           </a:p>
@@ -3137,7 +3222,7 @@
           <a:p>
             <a:fld id="{5BCAD085-E8A6-8845-BD4E-CB4CCA059FC4}" type="datetimeFigureOut">
               <a:rPr lang="en-US" smtClean="0"/>
-              <a:t>8/31/26</a:t>
+              <a:t>9/3/26</a:t>
             </a:fld>
             <a:endParaRPr lang="en-US"/>
           </a:p>
@@ -3232,7 +3317,7 @@
           <a:p>
             <a:fld id="{5BCAD085-E8A6-8845-BD4E-CB4CCA059FC4}" type="datetimeFigureOut">
               <a:rPr lang="en-US" smtClean="0"/>
-              <a:t>8/31/26</a:t>
+              <a:t>9/3/26</a:t>
             </a:fld>
             <a:endParaRPr lang="en-US"/>
           </a:p>
@@ -3507,7 +3592,7 @@
           <a:p>
             <a:fld id="{5BCAD085-E8A6-8845-BD4E-CB4CCA059FC4}" type="datetimeFigureOut">
               <a:rPr lang="en-US" smtClean="0"/>
-              <a:t>8/31/26</a:t>
+              <a:t>9/3/26</a:t>
             </a:fld>
             <a:endParaRPr lang="en-US"/>
           </a:p>
@@ -3759,7 +3844,7 @@
           <a:p>
             <a:fld id="{5BCAD085-E8A6-8845-BD4E-CB4CCA059FC4}" type="datetimeFigureOut">
               <a:rPr lang="en-US" smtClean="0"/>
-              <a:t>8/31/26</a:t>
+              <a:t>9/3/26</a:t>
             </a:fld>
             <a:endParaRPr lang="en-US"/>
           </a:p>
@@ -3970,7 +4055,7 @@
           <a:p>
             <a:fld id="{5BCAD085-E8A6-8845-BD4E-CB4CCA059FC4}" type="datetimeFigureOut">
               <a:rPr lang="en-US" smtClean="0"/>
-              <a:t>8/31/26</a:t>
+              <a:t>9/3/26</a:t>
             </a:fld>
             <a:endParaRPr lang="en-US"/>
           </a:p>
@@ -4398,7 +4483,7 @@
           <p:nvPr/>
         </p:nvPicPr>
         <p:blipFill>
-          <a:blip r:embed="rId2"/>
+          <a:blip r:embed="rId3"/>
           <a:stretch>
             <a:fillRect/>
           </a:stretch>
@@ -5162,14 +5247,20 @@
       </p:grpSpPr>
       <p:sp>
         <p:nvSpPr>
-          <p:cNvPr id="2" name="TextBox 1"/>
+          <p:cNvPr id="4" name="ZoneTexte 3">
+            <a:extLst>
+              <a:ext uri="{FF2B5EF4-FFF2-40B4-BE49-F238E27FC236}">
+                <a16:creationId xmlns:a16="http://schemas.microsoft.com/office/drawing/2014/main" id="{E66130A0-1149-3472-655C-80C3F885A861}"/>
+              </a:ext>
+            </a:extLst>
+          </p:cNvPr>
           <p:cNvSpPr txBox="1"/>
           <p:nvPr/>
         </p:nvSpPr>
         <p:spPr>
           <a:xfrm>
-            <a:off x="548640" y="320040"/>
-            <a:ext cx="11064240" cy="914400"/>
+            <a:off x="3048000" y="3152001"/>
+            <a:ext cx="6096000" cy="553998"/>
           </a:xfrm>
           <a:prstGeom prst="rect">
             <a:avLst/>
@@ -5182,213 +5273,25 @@
           </a:bodyPr>
           <a:lstStyle/>
           <a:p>
-            <a:pPr>
-              <a:defRPr sz="3000" b="1">
+            <a:pPr algn="ctr"/>
+            <a:r>
+              <a:rPr lang="fr-FR" sz="3000" b="1" dirty="0">
                 <a:solidFill>
                   <a:srgbClr val="63003C"/>
                 </a:solidFill>
-                <a:latin typeface="Georgia"/>
-              </a:defRPr>
-            </a:pPr>
-            <a:r>
-              <a:t>Références (1/2)</a:t>
-            </a:r>
-          </a:p>
-        </p:txBody>
-      </p:sp>
-      <p:sp>
-        <p:nvSpPr>
-          <p:cNvPr id="3" name="TextBox 2"/>
-          <p:cNvSpPr txBox="1"/>
-          <p:nvPr/>
-        </p:nvSpPr>
-        <p:spPr>
-          <a:xfrm>
-            <a:off x="685800" y="1371600"/>
-            <a:ext cx="10789920" cy="4846320"/>
-          </a:xfrm>
-          <a:prstGeom prst="rect">
-            <a:avLst/>
-          </a:prstGeom>
-          <a:noFill/>
-        </p:spPr>
-        <p:txBody>
-          <a:bodyPr wrap="square">
-            <a:spAutoFit/>
-          </a:bodyPr>
-          <a:lstStyle/>
-          <a:p>
-            <a:pPr>
-              <a:spcAft>
-                <a:spcPts val="1400"/>
-              </a:spcAft>
-              <a:defRPr sz="1600">
-                <a:solidFill>
-                  <a:srgbClr val="1A1A1A"/>
-                </a:solidFill>
-              </a:defRPr>
-            </a:pPr>
-            <a:r>
-              <a:t>•  Aird et al. — Exploring Social Choice Mechanisms for Recommendation Fairness in SCRUF (2023)</a:t>
-            </a:r>
-          </a:p>
-          <a:p>
-            <a:pPr>
-              <a:spcAft>
-                <a:spcPts val="1400"/>
-              </a:spcAft>
-              <a:defRPr sz="1600">
-                <a:solidFill>
-                  <a:srgbClr val="1A1A1A"/>
-                </a:solidFill>
-              </a:defRPr>
-            </a:pPr>
-            <a:r>
-              <a:t>•  Aird et al. — Social Choice for Heterogeneous Fairness in Recommendation, SCRUF-D (2024)</a:t>
-            </a:r>
-          </a:p>
-          <a:p>
-            <a:pPr>
-              <a:spcAft>
-                <a:spcPts val="1400"/>
-              </a:spcAft>
-              <a:defRPr sz="1600">
-                <a:solidFill>
-                  <a:srgbClr val="1A1A1A"/>
-                </a:solidFill>
-              </a:defRPr>
-            </a:pPr>
-            <a:r>
-              <a:t>•  Dong et al. — Fairness in Graph Mining: A Survey. IEEE TKDE (2023)</a:t>
-            </a:r>
-          </a:p>
-          <a:p>
-            <a:pPr>
-              <a:spcAft>
-                <a:spcPts val="1400"/>
-              </a:spcAft>
-              <a:defRPr sz="1600">
-                <a:solidFill>
-                  <a:srgbClr val="1A1A1A"/>
-                </a:solidFill>
-              </a:defRPr>
-            </a:pPr>
-            <a:r>
-              <a:t>•  Harper &amp; Konstan — The MovieLens Datasets: History and Context. ACM TiiS (2015)</a:t>
-            </a:r>
-          </a:p>
-          <a:p>
-            <a:pPr>
-              <a:spcAft>
-                <a:spcPts val="1400"/>
-              </a:spcAft>
-              <a:defRPr sz="1600">
-                <a:solidFill>
-                  <a:srgbClr val="1A1A1A"/>
-                </a:solidFill>
-              </a:defRPr>
-            </a:pPr>
-            <a:r>
-              <a:t>•  Kellerhals &amp; Peters — Proportional Fairness in Clustering (2024)</a:t>
-            </a:r>
-          </a:p>
-          <a:p>
-            <a:pPr>
-              <a:spcAft>
-                <a:spcPts val="1400"/>
-              </a:spcAft>
-              <a:defRPr sz="1600">
-                <a:solidFill>
-                  <a:srgbClr val="1A1A1A"/>
-                </a:solidFill>
-              </a:defRPr>
-            </a:pPr>
-            <a:r>
-              <a:t>•  Leonhardt et al. — User Fairness in Recommender Systems (2018)</a:t>
-            </a:r>
-          </a:p>
-        </p:txBody>
-      </p:sp>
-      <p:sp>
-        <p:nvSpPr>
-          <p:cNvPr id="4" name="Rectangle 3"/>
-          <p:cNvSpPr/>
-          <p:nvPr/>
-        </p:nvSpPr>
-        <p:spPr>
-          <a:xfrm>
-            <a:off x="548640" y="6446520"/>
-            <a:ext cx="11091672" cy="27940"/>
-          </a:xfrm>
-          <a:prstGeom prst="rect">
-            <a:avLst/>
-          </a:prstGeom>
-          <a:solidFill>
-            <a:srgbClr val="63003C"/>
-          </a:solidFill>
-          <a:ln>
-            <a:noFill/>
-          </a:ln>
-        </p:spPr>
-        <p:style>
-          <a:lnRef idx="1">
-            <a:schemeClr val="accent1"/>
-          </a:lnRef>
-          <a:fillRef idx="3">
-            <a:schemeClr val="accent1"/>
-          </a:fillRef>
-          <a:effectRef idx="2">
-            <a:schemeClr val="accent1"/>
-          </a:effectRef>
-          <a:fontRef idx="minor">
-            <a:schemeClr val="lt1"/>
-          </a:fontRef>
-        </p:style>
-        <p:txBody>
-          <a:bodyPr rtlCol="0" anchor="ctr"/>
-          <a:lstStyle/>
-          <a:p>
-            <a:pPr algn="ctr"/>
-            <a:endParaRPr/>
-          </a:p>
-        </p:txBody>
-      </p:sp>
-      <p:sp>
-        <p:nvSpPr>
-          <p:cNvPr id="5" name="TextBox 4"/>
-          <p:cNvSpPr txBox="1"/>
-          <p:nvPr/>
-        </p:nvSpPr>
-        <p:spPr>
-          <a:xfrm>
-            <a:off x="11521440" y="6492240"/>
-            <a:ext cx="548640" cy="320040"/>
-          </a:xfrm>
-          <a:prstGeom prst="rect">
-            <a:avLst/>
-          </a:prstGeom>
-          <a:noFill/>
-        </p:spPr>
-        <p:txBody>
-          <a:bodyPr wrap="none">
-            <a:spAutoFit/>
-          </a:bodyPr>
-          <a:lstStyle/>
-          <a:p>
-            <a:pPr algn="r">
-              <a:defRPr sz="1100">
-                <a:solidFill>
-                  <a:srgbClr val="555555"/>
-                </a:solidFill>
-              </a:defRPr>
-            </a:pPr>
-            <a:r>
-              <a:t>12</a:t>
+                <a:hlinkClick r:id="rId2"/>
+              </a:rPr>
+              <a:t>sitaacisse-boop.github.io/EDI</a:t>
             </a:r>
           </a:p>
         </p:txBody>
       </p:sp>
     </p:spTree>
+    <p:extLst>
+      <p:ext uri="{BB962C8B-B14F-4D97-AF65-F5344CB8AC3E}">
+        <p14:creationId xmlns:p14="http://schemas.microsoft.com/office/powerpoint/2010/main" val="1968070707"/>
+      </p:ext>
+    </p:extLst>
   </p:cSld>
   <p:clrMapOvr>
     <a:masterClrMapping/>
@@ -5444,7 +5347,7 @@
               </a:defRPr>
             </a:pPr>
             <a:r>
-              <a:t>Références (2/2)</a:t>
+              <a:t>Références (1/2)</a:t>
             </a:r>
           </a:p>
         </p:txBody>
@@ -5482,7 +5385,7 @@
               </a:defRPr>
             </a:pPr>
             <a:r>
-              <a:t>•  Liu et al. — Graph Summarization Methods and Applications: A Survey (2018)</a:t>
+              <a:t>•  Aird et al. — Exploring Social Choice Mechanisms for Recommendation Fairness in SCRUF (2023)</a:t>
             </a:r>
           </a:p>
           <a:p>
@@ -5497,7 +5400,7 @@
               </a:defRPr>
             </a:pPr>
             <a:r>
-              <a:t>•  Ricci, Rokach &amp; Shapira — Recommender Systems Handbook (2011)</a:t>
+              <a:t>•  Aird et al. — Social Choice for Heterogeneous Fairness in Recommendation, SCRUF-D (2024)</a:t>
             </a:r>
           </a:p>
           <a:p>
@@ -5512,7 +5415,7 @@
               </a:defRPr>
             </a:pPr>
             <a:r>
-              <a:t>•  Roy, Schieber &amp; Talmon — Fairness in Preference Queries. VLDB (2024)</a:t>
+              <a:t>•  Dong et al. — Fairness in Graph Mining: A Survey. IEEE TKDE (2023)</a:t>
             </a:r>
           </a:p>
           <a:p>
@@ -5527,7 +5430,7 @@
               </a:defRPr>
             </a:pPr>
             <a:r>
-              <a:t>•  Shabani et al. — Graph Summarization with GNNs: A Survey (2024)</a:t>
+              <a:t>•  Harper &amp; Konstan — The MovieLens Datasets: History and Context. ACM TiiS (2015)</a:t>
             </a:r>
           </a:p>
           <a:p>
@@ -5542,7 +5445,7 @@
               </a:defRPr>
             </a:pPr>
             <a:r>
-              <a:t>•  Yao &amp; Huang — New Fairness Metrics for Recommendation (2017)</a:t>
+              <a:t>•  Kellerhals &amp; Peters — Proportional Fairness in Clustering (2024)</a:t>
             </a:r>
           </a:p>
           <a:p>
@@ -5557,7 +5460,7 @@
               </a:defRPr>
             </a:pPr>
             <a:r>
-              <a:t>•  Zhao et al. — Fairness and Diversity in Recommender Systems: A Survey (2024)</a:t>
+              <a:t>•  Leonhardt et al. — User Fairness in Recommender Systems (2018)</a:t>
             </a:r>
           </a:p>
         </p:txBody>
@@ -5636,7 +5539,7 @@
               </a:defRPr>
             </a:pPr>
             <a:r>
-              <a:t>13</a:t>
+              <a:t>12</a:t>
             </a:r>
           </a:p>
         </p:txBody>
@@ -5650,6 +5553,259 @@
 </file>
 
 <file path=ppt/slides/slide14.xml><?xml version="1.0" encoding="utf-8"?>
+<p:sld xmlns:a="http://schemas.openxmlformats.org/drawingml/2006/main" xmlns:r="http://schemas.openxmlformats.org/officeDocument/2006/relationships" xmlns:p="http://schemas.openxmlformats.org/presentationml/2006/main">
+  <p:cSld>
+    <p:spTree>
+      <p:nvGrpSpPr>
+        <p:cNvPr id="1" name=""/>
+        <p:cNvGrpSpPr/>
+        <p:nvPr/>
+      </p:nvGrpSpPr>
+      <p:grpSpPr>
+        <a:xfrm>
+          <a:off x="0" y="0"/>
+          <a:ext cx="0" cy="0"/>
+          <a:chOff x="0" y="0"/>
+          <a:chExt cx="0" cy="0"/>
+        </a:xfrm>
+      </p:grpSpPr>
+      <p:sp>
+        <p:nvSpPr>
+          <p:cNvPr id="2" name="TextBox 1"/>
+          <p:cNvSpPr txBox="1"/>
+          <p:nvPr/>
+        </p:nvSpPr>
+        <p:spPr>
+          <a:xfrm>
+            <a:off x="548640" y="320040"/>
+            <a:ext cx="11064240" cy="914400"/>
+          </a:xfrm>
+          <a:prstGeom prst="rect">
+            <a:avLst/>
+          </a:prstGeom>
+          <a:noFill/>
+        </p:spPr>
+        <p:txBody>
+          <a:bodyPr wrap="square">
+            <a:spAutoFit/>
+          </a:bodyPr>
+          <a:lstStyle/>
+          <a:p>
+            <a:pPr>
+              <a:defRPr sz="3000" b="1">
+                <a:solidFill>
+                  <a:srgbClr val="63003C"/>
+                </a:solidFill>
+                <a:latin typeface="Georgia"/>
+              </a:defRPr>
+            </a:pPr>
+            <a:r>
+              <a:t>Références (2/2)</a:t>
+            </a:r>
+          </a:p>
+        </p:txBody>
+      </p:sp>
+      <p:sp>
+        <p:nvSpPr>
+          <p:cNvPr id="3" name="TextBox 2"/>
+          <p:cNvSpPr txBox="1"/>
+          <p:nvPr/>
+        </p:nvSpPr>
+        <p:spPr>
+          <a:xfrm>
+            <a:off x="685800" y="1371600"/>
+            <a:ext cx="10789920" cy="4846320"/>
+          </a:xfrm>
+          <a:prstGeom prst="rect">
+            <a:avLst/>
+          </a:prstGeom>
+          <a:noFill/>
+        </p:spPr>
+        <p:txBody>
+          <a:bodyPr wrap="square">
+            <a:spAutoFit/>
+          </a:bodyPr>
+          <a:lstStyle/>
+          <a:p>
+            <a:pPr>
+              <a:spcAft>
+                <a:spcPts val="1400"/>
+              </a:spcAft>
+              <a:defRPr sz="1600">
+                <a:solidFill>
+                  <a:srgbClr val="1A1A1A"/>
+                </a:solidFill>
+              </a:defRPr>
+            </a:pPr>
+            <a:r>
+              <a:t>•  Liu et al. — Graph Summarization Methods and Applications: A Survey (2018)</a:t>
+            </a:r>
+          </a:p>
+          <a:p>
+            <a:pPr>
+              <a:spcAft>
+                <a:spcPts val="1400"/>
+              </a:spcAft>
+              <a:defRPr sz="1600">
+                <a:solidFill>
+                  <a:srgbClr val="1A1A1A"/>
+                </a:solidFill>
+              </a:defRPr>
+            </a:pPr>
+            <a:r>
+              <a:t>•  Ricci, Rokach &amp; Shapira — Recommender Systems Handbook (2011)</a:t>
+            </a:r>
+          </a:p>
+          <a:p>
+            <a:pPr>
+              <a:spcAft>
+                <a:spcPts val="1400"/>
+              </a:spcAft>
+              <a:defRPr sz="1600">
+                <a:solidFill>
+                  <a:srgbClr val="1A1A1A"/>
+                </a:solidFill>
+              </a:defRPr>
+            </a:pPr>
+            <a:r>
+              <a:t>•  Roy, Schieber &amp; Talmon — Fairness in Preference Queries. VLDB (2024)</a:t>
+            </a:r>
+          </a:p>
+          <a:p>
+            <a:pPr>
+              <a:spcAft>
+                <a:spcPts val="1400"/>
+              </a:spcAft>
+              <a:defRPr sz="1600">
+                <a:solidFill>
+                  <a:srgbClr val="1A1A1A"/>
+                </a:solidFill>
+              </a:defRPr>
+            </a:pPr>
+            <a:r>
+              <a:t>•  Shabani et al. — Graph Summarization with GNNs: A Survey (2024)</a:t>
+            </a:r>
+          </a:p>
+          <a:p>
+            <a:pPr>
+              <a:spcAft>
+                <a:spcPts val="1400"/>
+              </a:spcAft>
+              <a:defRPr sz="1600">
+                <a:solidFill>
+                  <a:srgbClr val="1A1A1A"/>
+                </a:solidFill>
+              </a:defRPr>
+            </a:pPr>
+            <a:r>
+              <a:t>•  Yao &amp; Huang — New Fairness Metrics for Recommendation (2017)</a:t>
+            </a:r>
+          </a:p>
+          <a:p>
+            <a:pPr>
+              <a:spcAft>
+                <a:spcPts val="1400"/>
+              </a:spcAft>
+              <a:defRPr sz="1600">
+                <a:solidFill>
+                  <a:srgbClr val="1A1A1A"/>
+                </a:solidFill>
+              </a:defRPr>
+            </a:pPr>
+            <a:r>
+              <a:t>•  Zhao et al. — Fairness and Diversity in Recommender Systems: A Survey (2024)</a:t>
+            </a:r>
+          </a:p>
+        </p:txBody>
+      </p:sp>
+      <p:sp>
+        <p:nvSpPr>
+          <p:cNvPr id="4" name="Rectangle 3"/>
+          <p:cNvSpPr/>
+          <p:nvPr/>
+        </p:nvSpPr>
+        <p:spPr>
+          <a:xfrm>
+            <a:off x="548640" y="6446520"/>
+            <a:ext cx="11091672" cy="27940"/>
+          </a:xfrm>
+          <a:prstGeom prst="rect">
+            <a:avLst/>
+          </a:prstGeom>
+          <a:solidFill>
+            <a:srgbClr val="63003C"/>
+          </a:solidFill>
+          <a:ln>
+            <a:noFill/>
+          </a:ln>
+        </p:spPr>
+        <p:style>
+          <a:lnRef idx="1">
+            <a:schemeClr val="accent1"/>
+          </a:lnRef>
+          <a:fillRef idx="3">
+            <a:schemeClr val="accent1"/>
+          </a:fillRef>
+          <a:effectRef idx="2">
+            <a:schemeClr val="accent1"/>
+          </a:effectRef>
+          <a:fontRef idx="minor">
+            <a:schemeClr val="lt1"/>
+          </a:fontRef>
+        </p:style>
+        <p:txBody>
+          <a:bodyPr rtlCol="0" anchor="ctr"/>
+          <a:lstStyle/>
+          <a:p>
+            <a:pPr algn="ctr"/>
+            <a:endParaRPr/>
+          </a:p>
+        </p:txBody>
+      </p:sp>
+      <p:sp>
+        <p:nvSpPr>
+          <p:cNvPr id="5" name="TextBox 4"/>
+          <p:cNvSpPr txBox="1"/>
+          <p:nvPr/>
+        </p:nvSpPr>
+        <p:spPr>
+          <a:xfrm>
+            <a:off x="11521440" y="6492240"/>
+            <a:ext cx="548640" cy="320040"/>
+          </a:xfrm>
+          <a:prstGeom prst="rect">
+            <a:avLst/>
+          </a:prstGeom>
+          <a:noFill/>
+        </p:spPr>
+        <p:txBody>
+          <a:bodyPr wrap="none">
+            <a:spAutoFit/>
+          </a:bodyPr>
+          <a:lstStyle/>
+          <a:p>
+            <a:pPr algn="r">
+              <a:defRPr sz="1100">
+                <a:solidFill>
+                  <a:srgbClr val="555555"/>
+                </a:solidFill>
+              </a:defRPr>
+            </a:pPr>
+            <a:r>
+              <a:t>13</a:t>
+            </a:r>
+          </a:p>
+        </p:txBody>
+      </p:sp>
+    </p:spTree>
+  </p:cSld>
+  <p:clrMapOvr>
+    <a:masterClrMapping/>
+  </p:clrMapOvr>
+</p:sld>
+</file>
+
+<file path=ppt/slides/slide15.xml><?xml version="1.0" encoding="utf-8"?>
 <p:sld xmlns:a="http://schemas.openxmlformats.org/drawingml/2006/main" xmlns:r="http://schemas.openxmlformats.org/officeDocument/2006/relationships" xmlns:p="http://schemas.openxmlformats.org/presentationml/2006/main">
   <p:cSld>
     <p:spTree>
@@ -6847,7 +7003,24 @@
               </a:defRPr>
             </a:pPr>
             <a:r>
-              <a:t>3. Approche — AURORA : Coarsening sous Contraintes EDI</a:t>
+              <a:rPr dirty="0"/>
+              <a:t>3. </a:t>
+            </a:r>
+            <a:r>
+              <a:rPr dirty="0" err="1"/>
+              <a:t>Approche</a:t>
+            </a:r>
+            <a:r>
+              <a:rPr dirty="0"/>
+              <a:t> — AURORA : Coarsening sous </a:t>
+            </a:r>
+            <a:r>
+              <a:rPr dirty="0" err="1"/>
+              <a:t>Contraintes</a:t>
+            </a:r>
+            <a:r>
+              <a:rPr dirty="0"/>
+              <a:t> EDI</a:t>
             </a:r>
           </a:p>
         </p:txBody>
@@ -6860,8 +7033,8 @@
         </p:nvSpPr>
         <p:spPr>
           <a:xfrm>
-            <a:off x="685800" y="1371600"/>
-            <a:ext cx="10789920" cy="4846320"/>
+            <a:off x="548640" y="1371600"/>
+            <a:ext cx="11064240" cy="3000000"/>
           </a:xfrm>
           <a:prstGeom prst="rect">
             <a:avLst/>
@@ -6885,8 +7058,30 @@
               </a:defRPr>
             </a:pPr>
             <a:r>
-              <a:t>•  AURORA = Attributed Unified gRaph cOarsening for equitable RecommendAtion</a:t>
-            </a:r>
+              <a:rPr sz="1600" dirty="0"/>
+              <a:t>•  AURORA = Attributed Unified </a:t>
+            </a:r>
+            <a:r>
+              <a:rPr sz="1600" dirty="0" err="1"/>
+              <a:t>gRaph</a:t>
+            </a:r>
+            <a:r>
+              <a:rPr sz="1600" dirty="0"/>
+              <a:t> </a:t>
+            </a:r>
+            <a:r>
+              <a:rPr sz="1600" dirty="0" err="1"/>
+              <a:t>cOarsening</a:t>
+            </a:r>
+            <a:r>
+              <a:rPr sz="1600" dirty="0"/>
+              <a:t> for equitable </a:t>
+            </a:r>
+            <a:r>
+              <a:rPr sz="1600" dirty="0" err="1"/>
+              <a:t>RecommendAtion</a:t>
+            </a:r>
+            <a:endParaRPr sz="2000" dirty="0"/>
           </a:p>
           <a:p>
             <a:pPr>
@@ -6900,8 +7095,62 @@
               </a:defRPr>
             </a:pPr>
             <a:r>
-              <a:t>•  Fusion itérative et gloutonne de nœuds utilisateurs similaires en super-nœuds</a:t>
-            </a:r>
+              <a:rPr sz="1600" dirty="0"/>
+              <a:t>•  Fusion </a:t>
+            </a:r>
+            <a:r>
+              <a:rPr sz="1600" dirty="0" err="1"/>
+              <a:t>itérative</a:t>
+            </a:r>
+            <a:r>
+              <a:rPr sz="1600" dirty="0"/>
+              <a:t> et </a:t>
+            </a:r>
+            <a:r>
+              <a:rPr sz="1600" dirty="0" err="1"/>
+              <a:t>gloutonne</a:t>
+            </a:r>
+            <a:r>
+              <a:rPr sz="1600" dirty="0"/>
+              <a:t> de </a:t>
+            </a:r>
+            <a:r>
+              <a:rPr sz="1600" dirty="0" err="1"/>
+              <a:t>nœuds</a:t>
+            </a:r>
+            <a:r>
+              <a:rPr sz="1600" dirty="0"/>
+              <a:t> </a:t>
+            </a:r>
+            <a:r>
+              <a:rPr sz="1600" dirty="0" err="1"/>
+              <a:t>utilisateurs</a:t>
+            </a:r>
+            <a:r>
+              <a:rPr sz="1600" dirty="0"/>
+              <a:t> </a:t>
+            </a:r>
+            <a:r>
+              <a:rPr sz="1600" dirty="0" err="1"/>
+              <a:t>similaires</a:t>
+            </a:r>
+            <a:r>
+              <a:rPr sz="1600" dirty="0"/>
+              <a:t> </a:t>
+            </a:r>
+            <a:r>
+              <a:rPr sz="1600" dirty="0" err="1"/>
+              <a:t>en</a:t>
+            </a:r>
+            <a:r>
+              <a:rPr sz="1600" dirty="0"/>
+              <a:t> super-</a:t>
+            </a:r>
+            <a:r>
+              <a:rPr sz="1600" dirty="0" err="1"/>
+              <a:t>nœuds</a:t>
+            </a:r>
+            <a:endParaRPr sz="2000" dirty="0"/>
           </a:p>
           <a:p>
             <a:pPr>
@@ -6915,7 +7164,72 @@
               </a:defRPr>
             </a:pPr>
             <a:r>
-              <a:t>•  Une fusion n'est acceptée que si elle respecte les trois contraintes EDI simultanément :</a:t>
+              <a:rPr sz="1600" dirty="0"/>
+              <a:t>•  Une fusion </a:t>
+            </a:r>
+            <a:r>
+              <a:rPr sz="1600" dirty="0" err="1"/>
+              <a:t>n'est</a:t>
+            </a:r>
+            <a:r>
+              <a:rPr sz="1600" dirty="0"/>
+              <a:t> </a:t>
+            </a:r>
+            <a:r>
+              <a:rPr sz="1600" dirty="0" err="1"/>
+              <a:t>acceptée</a:t>
+            </a:r>
+            <a:r>
+              <a:rPr sz="1600" dirty="0"/>
+              <a:t> </a:t>
+            </a:r>
+            <a:r>
+              <a:rPr sz="1600" dirty="0" err="1"/>
+              <a:t>que</a:t>
+            </a:r>
+            <a:r>
+              <a:rPr sz="1600" dirty="0"/>
+              <a:t> </a:t>
+            </a:r>
+            <a:r>
+              <a:rPr sz="1600" dirty="0" err="1"/>
+              <a:t>si</a:t>
+            </a:r>
+            <a:r>
+              <a:rPr sz="1600" dirty="0"/>
+              <a:t> </a:t>
+            </a:r>
+            <a:r>
+              <a:rPr sz="1600" dirty="0" err="1"/>
+              <a:t>elle</a:t>
+            </a:r>
+            <a:r>
+              <a:rPr sz="1600" dirty="0"/>
+              <a:t> </a:t>
+            </a:r>
+            <a:r>
+              <a:rPr sz="1600" dirty="0" err="1"/>
+              <a:t>respecte</a:t>
+            </a:r>
+            <a:r>
+              <a:rPr sz="1600" dirty="0"/>
+              <a:t> les trois </a:t>
+            </a:r>
+            <a:r>
+              <a:rPr sz="1600" dirty="0" err="1"/>
+              <a:t>contraintes</a:t>
+            </a:r>
+            <a:r>
+              <a:rPr sz="1600" dirty="0"/>
+              <a:t> EDI </a:t>
+            </a:r>
+            <a:r>
+              <a:rPr sz="1600" dirty="0" err="1"/>
+              <a:t>simultanément</a:t>
+            </a:r>
+            <a:r>
+              <a:rPr sz="1600" dirty="0"/>
+              <a:t> :</a:t>
             </a:r>
           </a:p>
           <a:p>
@@ -6930,8 +7244,46 @@
               </a:defRPr>
             </a:pPr>
             <a:r>
-              <a:t>      ‒  ΔE(G′) ≤ ΔE(G) + εE     ILD(G′) ≥ ILD(G) − εD     inclusion_g(G′) ≥ inclusion_g(G) − εI</a:t>
-            </a:r>
+              <a:rPr sz="1400" dirty="0"/>
+              <a:t>      ‒  ΔE(G′) ≤ ΔE(G) + </a:t>
+            </a:r>
+            <a:r>
+              <a:rPr sz="1400" dirty="0" err="1"/>
+              <a:t>εE</a:t>
+            </a:r>
+            <a:r>
+              <a:rPr sz="1400" dirty="0"/>
+              <a:t>     ILD(G′) ≥ ILD(G) − </a:t>
+            </a:r>
+            <a:r>
+              <a:rPr sz="1400" dirty="0" err="1"/>
+              <a:t>εD</a:t>
+            </a:r>
+            <a:r>
+              <a:rPr sz="1400" dirty="0"/>
+              <a:t>     </a:t>
+            </a:r>
+            <a:r>
+              <a:rPr sz="1400" dirty="0" err="1"/>
+              <a:t>inclusion_g</a:t>
+            </a:r>
+            <a:r>
+              <a:rPr sz="1400" dirty="0"/>
+              <a:t>(G′) ≥ </a:t>
+            </a:r>
+            <a:r>
+              <a:rPr sz="1400" dirty="0" err="1"/>
+              <a:t>inclusion_g</a:t>
+            </a:r>
+            <a:r>
+              <a:rPr sz="1400" dirty="0"/>
+              <a:t>(G) − </a:t>
+            </a:r>
+            <a:r>
+              <a:rPr sz="1400" dirty="0" err="1"/>
+              <a:t>εI</a:t>
+            </a:r>
+            <a:endParaRPr sz="1600" dirty="0"/>
           </a:p>
           <a:p>
             <a:pPr>
@@ -6945,7 +7297,120 @@
               </a:defRPr>
             </a:pPr>
             <a:r>
-              <a:t>•  Objectif : parmi les fusions respectant ces contraintes, celle retenue minimise la perte structurelle L(G,G') (écart entre poids d'arêtes originaux et reconstruits)</a:t>
+              <a:rPr sz="1600" dirty="0"/>
+              <a:t>•  Objectif : </a:t>
+            </a:r>
+            <a:r>
+              <a:rPr sz="1600" dirty="0" err="1"/>
+              <a:t>parmi</a:t>
+            </a:r>
+            <a:r>
+              <a:rPr sz="1600" dirty="0"/>
+              <a:t> les fusions </a:t>
+            </a:r>
+            <a:r>
+              <a:rPr sz="1600" dirty="0" err="1"/>
+              <a:t>respectant</a:t>
+            </a:r>
+            <a:r>
+              <a:rPr sz="1600" dirty="0"/>
+              <a:t> </a:t>
+            </a:r>
+            <a:r>
+              <a:rPr sz="1600" dirty="0" err="1"/>
+              <a:t>ces</a:t>
+            </a:r>
+            <a:r>
+              <a:rPr sz="1600" dirty="0"/>
+              <a:t> </a:t>
+            </a:r>
+            <a:r>
+              <a:rPr sz="1600" dirty="0" err="1"/>
+              <a:t>contraintes</a:t>
+            </a:r>
+            <a:r>
+              <a:rPr sz="1600" dirty="0"/>
+              <a:t>, </a:t>
+            </a:r>
+            <a:r>
+              <a:rPr sz="1600" dirty="0" err="1"/>
+              <a:t>celle</a:t>
+            </a:r>
+            <a:r>
+              <a:rPr sz="1600" dirty="0"/>
+              <a:t> </a:t>
+            </a:r>
+            <a:r>
+              <a:rPr sz="1600" dirty="0" err="1"/>
+              <a:t>retenue</a:t>
+            </a:r>
+            <a:r>
+              <a:rPr sz="1600" dirty="0"/>
+              <a:t> </a:t>
+            </a:r>
+            <a:r>
+              <a:rPr sz="1600" dirty="0" err="1"/>
+              <a:t>minimise</a:t>
+            </a:r>
+            <a:r>
+              <a:rPr sz="1600" dirty="0"/>
+              <a:t> la </a:t>
+            </a:r>
+            <a:r>
+              <a:rPr sz="1600" dirty="0" err="1"/>
+              <a:t>perte</a:t>
+            </a:r>
+            <a:r>
+              <a:rPr sz="1600" dirty="0"/>
+              <a:t> </a:t>
+            </a:r>
+            <a:r>
+              <a:rPr sz="1600" dirty="0" err="1"/>
+              <a:t>structurelle</a:t>
+            </a:r>
+            <a:r>
+              <a:rPr sz="1600" dirty="0"/>
+              <a:t> L(G,G') (</a:t>
+            </a:r>
+            <a:r>
+              <a:rPr sz="1600" dirty="0" err="1"/>
+              <a:t>écart</a:t>
+            </a:r>
+            <a:r>
+              <a:rPr sz="1600" dirty="0"/>
+              <a:t> entre </a:t>
+            </a:r>
+            <a:r>
+              <a:rPr sz="1600" dirty="0" err="1"/>
+              <a:t>poids</a:t>
+            </a:r>
+            <a:r>
+              <a:rPr sz="1600" dirty="0"/>
+              <a:t> </a:t>
+            </a:r>
+            <a:r>
+              <a:rPr sz="1600" dirty="0" err="1"/>
+              <a:t>d'arêtes</a:t>
+            </a:r>
+            <a:r>
+              <a:rPr sz="1600" dirty="0"/>
+              <a:t> </a:t>
+            </a:r>
+            <a:r>
+              <a:rPr sz="1600" dirty="0" err="1"/>
+              <a:t>originaux</a:t>
+            </a:r>
+            <a:r>
+              <a:rPr sz="1600" dirty="0"/>
+              <a:t> et </a:t>
+            </a:r>
+            <a:r>
+              <a:rPr sz="1600" dirty="0" err="1"/>
+              <a:t>reconstruits</a:t>
+            </a:r>
+            <a:r>
+              <a:rPr sz="1600" dirty="0"/>
+              <a:t>)</a:t>
             </a:r>
           </a:p>
           <a:p>
@@ -6960,8 +7425,38 @@
               </a:defRPr>
             </a:pPr>
             <a:r>
-              <a:t>•  Budget de fusion = fraction fixe de |U| → même taux de compression quelle que soit l'échelle</a:t>
-            </a:r>
+              <a:rPr sz="1600" dirty="0"/>
+              <a:t>•  Budget de fusion = fraction fixe de |U| → </a:t>
+            </a:r>
+            <a:r>
+              <a:rPr sz="1600" dirty="0" err="1"/>
+              <a:t>même</a:t>
+            </a:r>
+            <a:r>
+              <a:rPr sz="1600" dirty="0"/>
+              <a:t> </a:t>
+            </a:r>
+            <a:r>
+              <a:rPr sz="1600" dirty="0" err="1"/>
+              <a:t>taux</a:t>
+            </a:r>
+            <a:r>
+              <a:rPr sz="1600" dirty="0"/>
+              <a:t> de compression quelle </a:t>
+            </a:r>
+            <a:r>
+              <a:rPr sz="1600" dirty="0" err="1"/>
+              <a:t>que</a:t>
+            </a:r>
+            <a:r>
+              <a:rPr sz="1600" dirty="0"/>
+              <a:t> soit </a:t>
+            </a:r>
+            <a:r>
+              <a:rPr sz="1600" dirty="0" err="1"/>
+              <a:t>l'échelle</a:t>
+            </a:r>
+            <a:endParaRPr sz="2000" dirty="0"/>
           </a:p>
           <a:p>
             <a:pPr>
@@ -6975,7 +7470,24 @@
               </a:defRPr>
             </a:pPr>
             <a:r>
-              <a:t>•  Comparé à : Average Score, Borda, Borda pondéré, Condorcet, Fair Re-rank</a:t>
+              <a:rPr sz="1600" dirty="0"/>
+              <a:t>•  </a:t>
+            </a:r>
+            <a:r>
+              <a:rPr sz="1600" dirty="0" err="1"/>
+              <a:t>Comparé</a:t>
+            </a:r>
+            <a:r>
+              <a:rPr sz="1600" dirty="0"/>
+              <a:t> à : Average Score, Borda, Borda </a:t>
+            </a:r>
+            <a:r>
+              <a:rPr sz="1600" dirty="0" err="1"/>
+              <a:t>pondéré</a:t>
+            </a:r>
+            <a:r>
+              <a:rPr sz="1600" dirty="0"/>
+              <a:t>, Condorcet, Fair Re-rank</a:t>
             </a:r>
           </a:p>
         </p:txBody>
@@ -6988,7 +7500,7 @@
         </p:nvSpPr>
         <p:spPr>
           <a:xfrm>
-            <a:off x="548640" y="6446520"/>
+            <a:off x="429768" y="6807200"/>
             <a:ext cx="11091672" cy="27940"/>
           </a:xfrm>
           <a:prstGeom prst="rect">
@@ -7068,15 +7580,15 @@
           <p:nvPr/>
         </p:nvPicPr>
         <p:blipFill>
-          <a:blip r:embed="rId3"/>
+          <a:blip r:embed="rId2"/>
           <a:stretch>
             <a:fillRect/>
           </a:stretch>
         </p:blipFill>
         <p:spPr>
           <a:xfrm>
-            <a:off x="2446000" y="3919220"/>
-            <a:ext cx="7300000" cy="2358415"/>
+            <a:off x="2989558" y="4700000"/>
+            <a:ext cx="6212883" cy="2007200"/>
           </a:xfrm>
           <a:prstGeom prst="rect">
             <a:avLst/>

</xml_diff>